<commit_message>
Update deck for durable servicing cases + Neo4j audit graph
- Slide 6: replace guardian-monitor with the durable saga + compensation +
  human-in-the-loop story (with a fail->rollback visual)
- Slide 9: add the durable-case path and the audit-graph path (Neo4j -> Cytoscape);
  refresh the stack line
- Regenerate .pptx + .pdf
</commit_message>
<xml_diff>
--- a/deck/CodeStreet2026_Servicing_Agent.pptx
+++ b/deck/CodeStreet2026_Servicing_Agent.pptx
@@ -8020,7 +8020,7 @@
             <a:r>
               <a:rPr sz="1300" b="1">
                 <a:solidFill>
-                  <a:srgbClr val="F26D6D"/>
+                  <a:srgbClr val="A68BF0"/>
                 </a:solidFill>
                 <a:latin typeface="Calibri"/>
               </a:rPr>
@@ -8066,7 +8066,7 @@
                 </a:solidFill>
                 <a:latin typeface="Calibri"/>
               </a:rPr>
-              <a:t>A guardian agent that acts while you sleep</a:t>
+              <a:t>Servicing cases that can’t be left half-done</a:t>
             </a:r>
           </a:p>
         </p:txBody>
@@ -8079,7 +8079,7 @@
         </p:nvSpPr>
         <p:spPr>
           <a:xfrm>
-            <a:off x="822960" y="2276856"/>
+            <a:off x="822960" y="2231136"/>
             <a:ext cx="109728" cy="109728"/>
           </a:xfrm>
           <a:prstGeom prst="roundRect">
@@ -8123,7 +8123,7 @@
         </p:nvSpPr>
         <p:spPr>
           <a:xfrm>
-            <a:off x="1115568" y="2194560"/>
+            <a:off x="1115568" y="2148840"/>
             <a:ext cx="6492240" cy="841248"/>
           </a:xfrm>
           <a:prstGeom prst="rect">
@@ -8152,7 +8152,7 @@
                 </a:solidFill>
                 <a:latin typeface="Calibri"/>
               </a:rPr>
-              <a:t>A durable Temporal workflow continuously watches for unusual activity</a:t>
+              <a:t>Every high-stakes request becomes a durable Temporal workflow</a:t>
             </a:r>
             <a:r>
               <a:rPr sz="1550" b="0">
@@ -8161,7 +8161,7 @@
                 </a:solidFill>
                 <a:latin typeface="Calibri"/>
               </a:rPr>
-              <a:t>  — the agent is idle until something happens.</a:t>
+              <a:t>  — it survives crashes and resumes exactly where it stopped.</a:t>
             </a:r>
           </a:p>
         </p:txBody>
@@ -8174,7 +8174,7 @@
         </p:nvSpPr>
         <p:spPr>
           <a:xfrm>
-            <a:off x="822960" y="3118103"/>
+            <a:off x="822960" y="3072384"/>
             <a:ext cx="109728" cy="109728"/>
           </a:xfrm>
           <a:prstGeom prst="roundRect">
@@ -8218,7 +8218,7 @@
         </p:nvSpPr>
         <p:spPr>
           <a:xfrm>
-            <a:off x="1115568" y="3035808"/>
+            <a:off x="1115568" y="2990088"/>
             <a:ext cx="6492240" cy="841248"/>
           </a:xfrm>
           <a:prstGeom prst="rect">
@@ -8247,7 +8247,7 @@
                 </a:solidFill>
                 <a:latin typeface="Calibri"/>
               </a:rPr>
-              <a:t>On an anomaly (e.g. high-value card-not-present charge) it acts autonomously</a:t>
+              <a:t>Saga with automatic compensation</a:t>
             </a:r>
             <a:r>
               <a:rPr sz="1550" b="0">
@@ -8256,7 +8256,7 @@
                 </a:solidFill>
                 <a:latin typeface="Calibri"/>
               </a:rPr>
-              <a:t>  — freezes the card, alerts the member, logs everything.</a:t>
+              <a:t>  — if a step fails, completed steps roll back in reverse. Never partial.</a:t>
             </a:r>
           </a:p>
         </p:txBody>
@@ -8269,7 +8269,7 @@
         </p:nvSpPr>
         <p:spPr>
           <a:xfrm>
-            <a:off x="822960" y="3959352"/>
+            <a:off x="822960" y="3913632"/>
             <a:ext cx="109728" cy="109728"/>
           </a:xfrm>
           <a:prstGeom prst="roundRect">
@@ -8313,7 +8313,7 @@
         </p:nvSpPr>
         <p:spPr>
           <a:xfrm>
-            <a:off x="1115568" y="3877056"/>
+            <a:off x="1115568" y="3831336"/>
             <a:ext cx="6492240" cy="841248"/>
           </a:xfrm>
           <a:prstGeom prst="rect">
@@ -8342,7 +8342,7 @@
                 </a:solidFill>
                 <a:latin typeface="Calibri"/>
               </a:rPr>
-              <a:t>Oversight at scale: humans handle exceptions, not every step</a:t>
+              <a:t>Durable human-in-the-loop approval</a:t>
             </a:r>
             <a:r>
               <a:rPr sz="1550" b="0">
@@ -8351,7 +8351,7 @@
                 </a:solidFill>
                 <a:latin typeface="Calibri"/>
               </a:rPr>
-              <a:t>  — the resolution to the bank’s autonomy dilemma.</a:t>
+              <a:t>  — over-policy cases wait on an underwriter for as long as it takes.</a:t>
             </a:r>
           </a:p>
         </p:txBody>
@@ -8364,7 +8364,7 @@
         </p:nvSpPr>
         <p:spPr>
           <a:xfrm>
-            <a:off x="822960" y="4800600"/>
+            <a:off x="822960" y="4754880"/>
             <a:ext cx="109728" cy="109728"/>
           </a:xfrm>
           <a:prstGeom prst="roundRect">
@@ -8408,7 +8408,7 @@
         </p:nvSpPr>
         <p:spPr>
           <a:xfrm>
-            <a:off x="1115568" y="4718304"/>
+            <a:off x="1115568" y="4672584"/>
             <a:ext cx="6492240" cy="841248"/>
           </a:xfrm>
           <a:prstGeom prst="rect">
@@ -8437,7 +8437,7 @@
                 </a:solidFill>
                 <a:latin typeface="Calibri"/>
               </a:rPr>
-              <a:t>Temporal’s durable event history is itself proof</a:t>
+              <a:t>Live status + replayable event history</a:t>
             </a:r>
             <a:r>
               <a:rPr sz="1550" b="0">
@@ -8446,7 +8446,7 @@
                 </a:solidFill>
                 <a:latin typeface="Calibri"/>
               </a:rPr>
-              <a:t>  of when the agent woke and what it did.</a:t>
+              <a:t>  — queryable in real time; the log is itself an audit.</a:t>
             </a:r>
           </a:p>
         </p:txBody>
@@ -8459,8 +8459,8 @@
         </p:nvSpPr>
         <p:spPr>
           <a:xfrm>
-            <a:off x="7680960" y="2286000"/>
-            <a:ext cx="3291840" cy="3246120"/>
+            <a:off x="7680960" y="2194560"/>
+            <a:ext cx="3291840" cy="3429000"/>
           </a:xfrm>
           <a:prstGeom prst="roundRect">
             <a:avLst/>
@@ -8470,7 +8470,7 @@
           </a:solidFill>
           <a:ln w="19050">
             <a:solidFill>
-              <a:srgbClr val="F26D6D"/>
+              <a:srgbClr val="A68BF0"/>
             </a:solidFill>
           </a:ln>
           <a:effectLst/>
@@ -8505,7 +8505,7 @@
         </p:nvSpPr>
         <p:spPr>
           <a:xfrm>
-            <a:off x="7909560" y="2468880"/>
+            <a:off x="7909560" y="2377440"/>
             <a:ext cx="2834640" cy="457200"/>
           </a:xfrm>
           <a:prstGeom prst="rect">
@@ -8528,13 +8528,13 @@
               </a:spcAft>
             </a:pPr>
             <a:r>
-              <a:rPr sz="1400" b="1">
-                <a:solidFill>
-                  <a:srgbClr val="F26D6D"/>
-                </a:solidFill>
-                <a:latin typeface="Calibri"/>
-              </a:rPr>
-              <a:t>Autonomous action</a:t>
+              <a:rPr sz="1300" b="1">
+                <a:solidFill>
+                  <a:srgbClr val="A68BF0"/>
+                </a:solidFill>
+                <a:latin typeface="Calibri"/>
+              </a:rPr>
+              <a:t>Card replacement saga</a:t>
             </a:r>
           </a:p>
         </p:txBody>
@@ -8547,7 +8547,7 @@
         </p:nvSpPr>
         <p:spPr>
           <a:xfrm>
-            <a:off x="7909560" y="2926080"/>
+            <a:off x="7909560" y="2834640"/>
             <a:ext cx="2834640" cy="457200"/>
           </a:xfrm>
           <a:prstGeom prst="rect">
@@ -8570,13 +8570,13 @@
               </a:spcAft>
             </a:pPr>
             <a:r>
-              <a:rPr sz="1300" b="1">
-                <a:solidFill>
-                  <a:srgbClr val="93A0B4"/>
-                </a:solidFill>
-                <a:latin typeface="Calibri"/>
-              </a:rPr>
-              <a:t>⚡ $4,999 charge · Lagos (CNP)</a:t>
+              <a:rPr sz="1250" b="1">
+                <a:solidFill>
+                  <a:srgbClr val="3FD08A"/>
+                </a:solidFill>
+                <a:latin typeface="Calibri"/>
+              </a:rPr>
+              <a:t>✓ block old card</a:t>
             </a:r>
           </a:p>
         </p:txBody>
@@ -8589,7 +8589,7 @@
         </p:nvSpPr>
         <p:spPr>
           <a:xfrm>
-            <a:off x="7909560" y="3429000"/>
+            <a:off x="7909560" y="3291840"/>
             <a:ext cx="2834640" cy="457200"/>
           </a:xfrm>
           <a:prstGeom prst="rect">
@@ -8612,13 +8612,13 @@
               </a:spcAft>
             </a:pPr>
             <a:r>
-              <a:rPr sz="1300" b="1">
-                <a:solidFill>
-                  <a:srgbClr val="F26D6D"/>
-                </a:solidFill>
-                <a:latin typeface="Calibri"/>
-              </a:rPr>
-              <a:t>🛡️ anomaly_detected</a:t>
+              <a:rPr sz="1250" b="1">
+                <a:solidFill>
+                  <a:srgbClr val="3FD08A"/>
+                </a:solidFill>
+                <a:latin typeface="Calibri"/>
+              </a:rPr>
+              <a:t>✓ charge fee</a:t>
             </a:r>
           </a:p>
         </p:txBody>
@@ -8631,7 +8631,7 @@
         </p:nvSpPr>
         <p:spPr>
           <a:xfrm>
-            <a:off x="7909560" y="3931920"/>
+            <a:off x="7909560" y="3749039"/>
             <a:ext cx="2834640" cy="457200"/>
           </a:xfrm>
           <a:prstGeom prst="rect">
@@ -8654,13 +8654,13 @@
               </a:spcAft>
             </a:pPr>
             <a:r>
-              <a:rPr sz="1300" b="1">
-                <a:solidFill>
-                  <a:srgbClr val="F2B04B"/>
-                </a:solidFill>
-                <a:latin typeface="Calibri"/>
-              </a:rPr>
-              <a:t>🔒 auto_freeze_card</a:t>
+              <a:rPr sz="1250" b="1">
+                <a:solidFill>
+                  <a:srgbClr val="F26D6D"/>
+                </a:solidFill>
+                <a:latin typeface="Calibri"/>
+              </a:rPr>
+              <a:t>✗ order fulfillment — fails</a:t>
             </a:r>
           </a:p>
         </p:txBody>
@@ -8673,7 +8673,7 @@
         </p:nvSpPr>
         <p:spPr>
           <a:xfrm>
-            <a:off x="7909560" y="4434840"/>
+            <a:off x="7909560" y="4206240"/>
             <a:ext cx="2834640" cy="457200"/>
           </a:xfrm>
           <a:prstGeom prst="rect">
@@ -8696,13 +8696,13 @@
               </a:spcAft>
             </a:pPr>
             <a:r>
-              <a:rPr sz="1300" b="1">
-                <a:solidFill>
-                  <a:srgbClr val="3FD08A"/>
-                </a:solidFill>
-                <a:latin typeface="Calibri"/>
-              </a:rPr>
-              <a:t>🔔 alert_raised → member</a:t>
+              <a:rPr sz="1250" b="1">
+                <a:solidFill>
+                  <a:srgbClr val="F2B04B"/>
+                </a:solidFill>
+                <a:latin typeface="Calibri"/>
+              </a:rPr>
+              <a:t>↩ refund fee (compensate)</a:t>
             </a:r>
           </a:p>
         </p:txBody>
@@ -8715,7 +8715,7 @@
         </p:nvSpPr>
         <p:spPr>
           <a:xfrm>
-            <a:off x="7909560" y="4937760"/>
+            <a:off x="7909560" y="4663440"/>
             <a:ext cx="2834640" cy="457200"/>
           </a:xfrm>
           <a:prstGeom prst="rect">
@@ -8738,13 +8738,13 @@
               </a:spcAft>
             </a:pPr>
             <a:r>
-              <a:rPr sz="1300" b="1">
-                <a:solidFill>
-                  <a:srgbClr val="2E8BF0"/>
-                </a:solidFill>
-                <a:latin typeface="Calibri"/>
-              </a:rPr>
-              <a:t>⛓ written to audit chain</a:t>
+              <a:rPr sz="1250" b="1">
+                <a:solidFill>
+                  <a:srgbClr val="F2B04B"/>
+                </a:solidFill>
+                <a:latin typeface="Calibri"/>
+              </a:rPr>
+              <a:t>↩ unblock card (compensate)</a:t>
             </a:r>
           </a:p>
         </p:txBody>
@@ -8757,8 +8757,8 @@
         </p:nvSpPr>
         <p:spPr>
           <a:xfrm>
-            <a:off x="777240" y="6419088"/>
-            <a:ext cx="7315200" cy="274320"/>
+            <a:off x="7909560" y="5120640"/>
+            <a:ext cx="2834640" cy="457200"/>
           </a:xfrm>
           <a:prstGeom prst="rect">
             <a:avLst/>
@@ -8780,6 +8780,48 @@
               </a:spcAft>
             </a:pPr>
             <a:r>
+              <a:rPr sz="1250" b="1">
+                <a:solidFill>
+                  <a:srgbClr val="2E8BF0"/>
+                </a:solidFill>
+                <a:latin typeface="Calibri"/>
+              </a:rPr>
+              <a:t>= rolled back · consistent</a:t>
+            </a:r>
+          </a:p>
+        </p:txBody>
+      </p:sp>
+      <p:sp>
+        <p:nvSpPr>
+          <p:cNvPr id="22" name="TextBox 21"/>
+          <p:cNvSpPr txBox="1"/>
+          <p:nvPr/>
+        </p:nvSpPr>
+        <p:spPr>
+          <a:xfrm>
+            <a:off x="777240" y="6419088"/>
+            <a:ext cx="7315200" cy="274320"/>
+          </a:xfrm>
+          <a:prstGeom prst="rect">
+            <a:avLst/>
+          </a:prstGeom>
+          <a:noFill/>
+        </p:spPr>
+        <p:txBody>
+          <a:bodyPr wrap="square" anchor="t" lIns="0" rIns="0" tIns="0" bIns="0">
+            <a:spAutoFit/>
+          </a:bodyPr>
+          <a:lstStyle/>
+          <a:p>
+            <a:pPr algn="l">
+              <a:spcBef>
+                <a:spcPts val="0"/>
+              </a:spcBef>
+              <a:spcAft>
+                <a:spcPts val="400"/>
+              </a:spcAft>
+            </a:pPr>
+            <a:r>
               <a:rPr sz="900" b="0">
                 <a:solidFill>
                   <a:srgbClr val="93A0B4"/>
@@ -8793,7 +8835,7 @@
       </p:sp>
       <p:sp>
         <p:nvSpPr>
-          <p:cNvPr id="22" name="TextBox 21"/>
+          <p:cNvPr id="23" name="TextBox 22"/>
           <p:cNvSpPr txBox="1"/>
           <p:nvPr/>
         </p:nvSpPr>
@@ -10639,7 +10681,7 @@
                 </a:solidFill>
                 <a:latin typeface="Calibri"/>
               </a:rPr>
-              <a:t>Our audit trail + guardian monitor are the prerequisites for safe autonomy —</a:t>
+              <a:t>Our audit trail + durable compensating workflows are the prerequisites for safe autonomy —</a:t>
             </a:r>
             <a:r>
               <a:rPr sz="1650" b="0">
@@ -11286,7 +11328,7 @@
         <p:spPr>
           <a:xfrm>
             <a:off x="822960" y="3520440"/>
-            <a:ext cx="2651760" cy="566928"/>
+            <a:ext cx="2377440" cy="566928"/>
           </a:xfrm>
           <a:prstGeom prst="roundRect">
             <a:avLst/>
@@ -11296,7 +11338,7 @@
           </a:solidFill>
           <a:ln w="15875">
             <a:solidFill>
-              <a:srgbClr val="F26D6D"/>
+              <a:srgbClr val="A68BF0"/>
             </a:solidFill>
           </a:ln>
           <a:effectLst/>
@@ -11327,7 +11369,7 @@
                 </a:solidFill>
                 <a:latin typeface="Calibri"/>
               </a:rPr>
-              <a:t>Temporal dev server</a:t>
+              <a:t>Temporal server</a:t>
             </a:r>
           </a:p>
         </p:txBody>
@@ -11340,7 +11382,7 @@
         </p:nvSpPr>
         <p:spPr>
           <a:xfrm>
-            <a:off x="3566160" y="3675887"/>
+            <a:off x="3291840" y="3675887"/>
             <a:ext cx="457200" cy="256032"/>
           </a:xfrm>
           <a:prstGeom prst="rightArrow">
@@ -11384,8 +11426,8 @@
         </p:nvSpPr>
         <p:spPr>
           <a:xfrm>
-            <a:off x="4114800" y="3520440"/>
-            <a:ext cx="1737360" cy="566928"/>
+            <a:off x="3840480" y="3520440"/>
+            <a:ext cx="1554480" cy="566928"/>
           </a:xfrm>
           <a:prstGeom prst="roundRect">
             <a:avLst/>
@@ -11395,7 +11437,7 @@
           </a:solidFill>
           <a:ln w="15875">
             <a:solidFill>
-              <a:srgbClr val="F26D6D"/>
+              <a:srgbClr val="A68BF0"/>
             </a:solidFill>
           </a:ln>
           <a:effectLst/>
@@ -11439,7 +11481,7 @@
         </p:nvSpPr>
         <p:spPr>
           <a:xfrm>
-            <a:off x="5943600" y="3675887"/>
+            <a:off x="5486400" y="3675887"/>
             <a:ext cx="457200" cy="256032"/>
           </a:xfrm>
           <a:prstGeom prst="rightArrow">
@@ -11483,8 +11525,8 @@
         </p:nvSpPr>
         <p:spPr>
           <a:xfrm>
-            <a:off x="6492240" y="3520440"/>
-            <a:ext cx="4846320" cy="566928"/>
+            <a:off x="6035040" y="3520440"/>
+            <a:ext cx="5303520" cy="566928"/>
           </a:xfrm>
           <a:prstGeom prst="roundRect">
             <a:avLst/>
@@ -11494,7 +11536,7 @@
           </a:solidFill>
           <a:ln w="15875">
             <a:solidFill>
-              <a:srgbClr val="F26D6D"/>
+              <a:srgbClr val="A68BF0"/>
             </a:solidFill>
           </a:ln>
           <a:effectLst/>
@@ -11525,7 +11567,7 @@
                 </a:solidFill>
                 <a:latin typeface="Calibri"/>
               </a:rPr>
-              <a:t>Monitor workflow → /monitor/tick (detect · freeze · alert)</a:t>
+              <a:t>ServicingCaseWorkflow → saga · compensation · approval</a:t>
             </a:r>
           </a:p>
         </p:txBody>
@@ -11538,8 +11580,261 @@
         </p:nvSpPr>
         <p:spPr>
           <a:xfrm>
-            <a:off x="822960" y="4663440"/>
-            <a:ext cx="10515600" cy="914400"/>
+            <a:off x="822960" y="4160520"/>
+            <a:ext cx="3108960" cy="566928"/>
+          </a:xfrm>
+          <a:prstGeom prst="roundRect">
+            <a:avLst/>
+          </a:prstGeom>
+          <a:solidFill>
+            <a:srgbClr val="141C30"/>
+          </a:solidFill>
+          <a:ln w="15875">
+            <a:solidFill>
+              <a:srgbClr val="2E8BF0"/>
+            </a:solidFill>
+          </a:ln>
+          <a:effectLst/>
+        </p:spPr>
+        <p:style>
+          <a:lnRef idx="1">
+            <a:schemeClr val="accent1"/>
+          </a:lnRef>
+          <a:fillRef idx="3">
+            <a:schemeClr val="accent1"/>
+          </a:fillRef>
+          <a:effectRef idx="2">
+            <a:schemeClr val="accent1"/>
+          </a:effectRef>
+          <a:fontRef idx="minor">
+            <a:schemeClr val="lt1"/>
+          </a:fontRef>
+        </p:style>
+        <p:txBody>
+          <a:bodyPr rtlCol="0" anchor="ctr" wrap="square"/>
+          <a:lstStyle/>
+          <a:p>
+            <a:pPr algn="ctr"/>
+            <a:r>
+              <a:rPr sz="1200" b="1">
+                <a:solidFill>
+                  <a:srgbClr val="F5F7FA"/>
+                </a:solidFill>
+                <a:latin typeface="Calibri"/>
+              </a:rPr>
+              <a:t>Audit chain → /graph</a:t>
+            </a:r>
+          </a:p>
+        </p:txBody>
+      </p:sp>
+      <p:sp>
+        <p:nvSpPr>
+          <p:cNvPr id="17" name="Right Arrow 16"/>
+          <p:cNvSpPr/>
+          <p:nvPr/>
+        </p:nvSpPr>
+        <p:spPr>
+          <a:xfrm>
+            <a:off x="4023360" y="4315968"/>
+            <a:ext cx="457200" cy="256032"/>
+          </a:xfrm>
+          <a:prstGeom prst="rightArrow">
+            <a:avLst/>
+          </a:prstGeom>
+          <a:solidFill>
+            <a:srgbClr val="2E8BF0"/>
+          </a:solidFill>
+          <a:ln>
+            <a:noFill/>
+          </a:ln>
+          <a:effectLst/>
+        </p:spPr>
+        <p:style>
+          <a:lnRef idx="1">
+            <a:schemeClr val="accent1"/>
+          </a:lnRef>
+          <a:fillRef idx="3">
+            <a:schemeClr val="accent1"/>
+          </a:fillRef>
+          <a:effectRef idx="2">
+            <a:schemeClr val="accent1"/>
+          </a:effectRef>
+          <a:fontRef idx="minor">
+            <a:schemeClr val="lt1"/>
+          </a:fontRef>
+        </p:style>
+        <p:txBody>
+          <a:bodyPr rtlCol="0" anchor="ctr"/>
+          <a:lstStyle/>
+          <a:p>
+            <a:pPr algn="ctr"/>
+          </a:p>
+        </p:txBody>
+      </p:sp>
+      <p:sp>
+        <p:nvSpPr>
+          <p:cNvPr id="18" name="Rounded Rectangle 17"/>
+          <p:cNvSpPr/>
+          <p:nvPr/>
+        </p:nvSpPr>
+        <p:spPr>
+          <a:xfrm>
+            <a:off x="4572000" y="4160520"/>
+            <a:ext cx="2743200" cy="566928"/>
+          </a:xfrm>
+          <a:prstGeom prst="roundRect">
+            <a:avLst/>
+          </a:prstGeom>
+          <a:solidFill>
+            <a:srgbClr val="141C30"/>
+          </a:solidFill>
+          <a:ln w="15875">
+            <a:solidFill>
+              <a:srgbClr val="3FD08A"/>
+            </a:solidFill>
+          </a:ln>
+          <a:effectLst/>
+        </p:spPr>
+        <p:style>
+          <a:lnRef idx="1">
+            <a:schemeClr val="accent1"/>
+          </a:lnRef>
+          <a:fillRef idx="3">
+            <a:schemeClr val="accent1"/>
+          </a:fillRef>
+          <a:effectRef idx="2">
+            <a:schemeClr val="accent1"/>
+          </a:effectRef>
+          <a:fontRef idx="minor">
+            <a:schemeClr val="lt1"/>
+          </a:fontRef>
+        </p:style>
+        <p:txBody>
+          <a:bodyPr rtlCol="0" anchor="ctr" wrap="square"/>
+          <a:lstStyle/>
+          <a:p>
+            <a:pPr algn="ctr"/>
+            <a:r>
+              <a:rPr sz="1200" b="1">
+                <a:solidFill>
+                  <a:srgbClr val="F5F7FA"/>
+                </a:solidFill>
+                <a:latin typeface="Calibri"/>
+              </a:rPr>
+              <a:t>Neo4j Aura</a:t>
+            </a:r>
+          </a:p>
+        </p:txBody>
+      </p:sp>
+      <p:sp>
+        <p:nvSpPr>
+          <p:cNvPr id="19" name="Right Arrow 18"/>
+          <p:cNvSpPr/>
+          <p:nvPr/>
+        </p:nvSpPr>
+        <p:spPr>
+          <a:xfrm>
+            <a:off x="7406640" y="4315968"/>
+            <a:ext cx="457200" cy="256032"/>
+          </a:xfrm>
+          <a:prstGeom prst="rightArrow">
+            <a:avLst/>
+          </a:prstGeom>
+          <a:solidFill>
+            <a:srgbClr val="2E8BF0"/>
+          </a:solidFill>
+          <a:ln>
+            <a:noFill/>
+          </a:ln>
+          <a:effectLst/>
+        </p:spPr>
+        <p:style>
+          <a:lnRef idx="1">
+            <a:schemeClr val="accent1"/>
+          </a:lnRef>
+          <a:fillRef idx="3">
+            <a:schemeClr val="accent1"/>
+          </a:fillRef>
+          <a:effectRef idx="2">
+            <a:schemeClr val="accent1"/>
+          </a:effectRef>
+          <a:fontRef idx="minor">
+            <a:schemeClr val="lt1"/>
+          </a:fontRef>
+        </p:style>
+        <p:txBody>
+          <a:bodyPr rtlCol="0" anchor="ctr"/>
+          <a:lstStyle/>
+          <a:p>
+            <a:pPr algn="ctr"/>
+          </a:p>
+        </p:txBody>
+      </p:sp>
+      <p:sp>
+        <p:nvSpPr>
+          <p:cNvPr id="20" name="Rounded Rectangle 19"/>
+          <p:cNvSpPr/>
+          <p:nvPr/>
+        </p:nvSpPr>
+        <p:spPr>
+          <a:xfrm>
+            <a:off x="7955279" y="4160520"/>
+            <a:ext cx="3383280" cy="566928"/>
+          </a:xfrm>
+          <a:prstGeom prst="roundRect">
+            <a:avLst/>
+          </a:prstGeom>
+          <a:solidFill>
+            <a:srgbClr val="141C30"/>
+          </a:solidFill>
+          <a:ln w="15875">
+            <a:solidFill>
+              <a:srgbClr val="3FD08A"/>
+            </a:solidFill>
+          </a:ln>
+          <a:effectLst/>
+        </p:spPr>
+        <p:style>
+          <a:lnRef idx="1">
+            <a:schemeClr val="accent1"/>
+          </a:lnRef>
+          <a:fillRef idx="3">
+            <a:schemeClr val="accent1"/>
+          </a:fillRef>
+          <a:effectRef idx="2">
+            <a:schemeClr val="accent1"/>
+          </a:effectRef>
+          <a:fontRef idx="minor">
+            <a:schemeClr val="lt1"/>
+          </a:fontRef>
+        </p:style>
+        <p:txBody>
+          <a:bodyPr rtlCol="0" anchor="ctr" wrap="square"/>
+          <a:lstStyle/>
+          <a:p>
+            <a:pPr algn="ctr"/>
+            <a:r>
+              <a:rPr sz="1200" b="1">
+                <a:solidFill>
+                  <a:srgbClr val="F5F7FA"/>
+                </a:solidFill>
+                <a:latin typeface="Calibri"/>
+              </a:rPr>
+              <a:t>Cytoscape analyst graph</a:t>
+            </a:r>
+          </a:p>
+        </p:txBody>
+      </p:sp>
+      <p:sp>
+        <p:nvSpPr>
+          <p:cNvPr id="21" name="Rounded Rectangle 20"/>
+          <p:cNvSpPr/>
+          <p:nvPr/>
+        </p:nvSpPr>
+        <p:spPr>
+          <a:xfrm>
+            <a:off x="822960" y="4892040"/>
+            <a:ext cx="10515600" cy="868680"/>
           </a:xfrm>
           <a:prstGeom prst="roundRect">
             <a:avLst/>
@@ -11576,13 +11871,13 @@
       </p:sp>
       <p:sp>
         <p:nvSpPr>
-          <p:cNvPr id="17" name="TextBox 16"/>
+          <p:cNvPr id="22" name="TextBox 21"/>
           <p:cNvSpPr txBox="1"/>
           <p:nvPr/>
         </p:nvSpPr>
         <p:spPr>
           <a:xfrm>
-            <a:off x="1097280" y="4800600"/>
+            <a:off x="1097280" y="5010912"/>
             <a:ext cx="10058400" cy="731520"/>
           </a:xfrm>
           <a:prstGeom prst="rect">
@@ -11605,7 +11900,7 @@
               </a:spcAft>
             </a:pPr>
             <a:r>
-              <a:rPr sz="1400" b="1">
+              <a:rPr sz="1300" b="1">
                 <a:solidFill>
                   <a:srgbClr val="2E8BF0"/>
                 </a:solidFill>
@@ -11614,20 +11909,20 @@
               <a:t>Stack   </a:t>
             </a:r>
             <a:r>
-              <a:rPr sz="1350" b="0">
+              <a:rPr sz="1250" b="0">
                 <a:solidFill>
                   <a:srgbClr val="F5F7FA"/>
                 </a:solidFill>
                 <a:latin typeface="Calibri"/>
               </a:rPr>
-              <a:t>Python · FastAPI · LangChain/LangGraph · Gemini (model-agnostic) · Temporal · Next.js · SHA-256 hash-chain</a:t>
-            </a:r>
-          </a:p>
-        </p:txBody>
-      </p:sp>
-      <p:sp>
-        <p:nvSpPr>
-          <p:cNvPr id="18" name="TextBox 17"/>
+              <a:t>Python · FastAPI · LangGraph · Gemini · Temporal · Neo4j · Next.js · Cytoscape · SHA-256 hash-chain</a:t>
+            </a:r>
+          </a:p>
+        </p:txBody>
+      </p:sp>
+      <p:sp>
+        <p:nvSpPr>
+          <p:cNvPr id="23" name="TextBox 22"/>
           <p:cNvSpPr txBox="1"/>
           <p:nvPr/>
         </p:nvSpPr>
@@ -11669,7 +11964,7 @@
       </p:sp>
       <p:sp>
         <p:nvSpPr>
-          <p:cNvPr id="19" name="TextBox 18"/>
+          <p:cNvPr id="24" name="TextBox 23"/>
           <p:cNvSpPr txBox="1"/>
           <p:nvPr/>
         </p:nvSpPr>
@@ -11711,7 +12006,7 @@
       </p:sp>
       <p:sp>
         <p:nvSpPr>
-          <p:cNvPr id="20" name="TextBox 19"/>
+          <p:cNvPr id="25" name="TextBox 24"/>
           <p:cNvSpPr txBox="1"/>
           <p:nvPr/>
         </p:nvSpPr>

</xml_diff>

<commit_message>
Deck: verified/cited claims, surface Neo4j graph + conversational maturity; add demo-video script
- Slide 8: verified stats with sources — Deloitte 21% mature governance / 74%
  agent use by 2027; full Amex CIO attribution (Radhakrishnan, Forbes 2025);
  add the 'Deloitte names the exact controls we built' point + a Sources line
- Slide 5: add Neo4j analyst-graph bullet
- Slide 3: surface multi-turn follow-ups, voice, safe out-of-scope handling
- Add deck/demo_video_script.md (2:45 storyboard + VO + production checklist)
- Regenerate .pptx + .pdf
</commit_message>
<xml_diff>
--- a/deck/CodeStreet2026_Servicing_Agent.pptx
+++ b/deck/CodeStreet2026_Servicing_Agent.pptx
@@ -5663,8 +5663,8 @@
         </p:nvSpPr>
         <p:spPr>
           <a:xfrm>
-            <a:off x="822960" y="5257800"/>
-            <a:ext cx="10515600" cy="640080"/>
+            <a:off x="822960" y="5212080"/>
+            <a:ext cx="10515600" cy="548640"/>
           </a:xfrm>
           <a:prstGeom prst="rect">
             <a:avLst/>
@@ -5723,6 +5723,57 @@
         </p:nvSpPr>
         <p:spPr>
           <a:xfrm>
+            <a:off x="822960" y="5806440"/>
+            <a:ext cx="10515600" cy="365760"/>
+          </a:xfrm>
+          <a:prstGeom prst="rect">
+            <a:avLst/>
+          </a:prstGeom>
+          <a:noFill/>
+        </p:spPr>
+        <p:txBody>
+          <a:bodyPr wrap="square" anchor="t" lIns="0" rIns="0" tIns="0" bIns="0">
+            <a:spAutoFit/>
+          </a:bodyPr>
+          <a:lstStyle/>
+          <a:p>
+            <a:pPr algn="ctr">
+              <a:spcBef>
+                <a:spcPts val="0"/>
+              </a:spcBef>
+              <a:spcAft>
+                <a:spcPts val="400"/>
+              </a:spcAft>
+            </a:pPr>
+            <a:r>
+              <a:rPr sz="1250" b="1">
+                <a:solidFill>
+                  <a:srgbClr val="2E8BF0"/>
+                </a:solidFill>
+                <a:latin typeface="Calibri"/>
+              </a:rPr>
+              <a:t>Plus  </a:t>
+            </a:r>
+            <a:r>
+              <a:rPr sz="1250" b="0">
+                <a:solidFill>
+                  <a:srgbClr val="93A0B4"/>
+                </a:solidFill>
+                <a:latin typeface="Calibri"/>
+              </a:rPr>
+              <a:t>multi-turn follow-ups (slot-filling) · voice input · safe out-of-scope handling (answer / escalate / clarify)</a:t>
+            </a:r>
+          </a:p>
+        </p:txBody>
+      </p:sp>
+      <p:sp>
+        <p:nvSpPr>
+          <p:cNvPr id="20" name="TextBox 19"/>
+          <p:cNvSpPr txBox="1"/>
+          <p:nvPr/>
+        </p:nvSpPr>
+        <p:spPr>
+          <a:xfrm>
             <a:off x="777240" y="6419088"/>
             <a:ext cx="7315200" cy="274320"/>
           </a:xfrm>
@@ -5759,7 +5810,7 @@
       </p:sp>
       <p:sp>
         <p:nvSpPr>
-          <p:cNvPr id="20" name="TextBox 19"/>
+          <p:cNvPr id="21" name="TextBox 20"/>
           <p:cNvSpPr txBox="1"/>
           <p:nvPr/>
         </p:nvSpPr>
@@ -6905,7 +6956,7 @@
         </p:nvSpPr>
         <p:spPr>
           <a:xfrm>
-            <a:off x="822960" y="2276856"/>
+            <a:off x="822960" y="2185415"/>
             <a:ext cx="109728" cy="109728"/>
           </a:xfrm>
           <a:prstGeom prst="roundRect">
@@ -6949,8 +7000,8 @@
         </p:nvSpPr>
         <p:spPr>
           <a:xfrm>
-            <a:off x="1115568" y="2194560"/>
-            <a:ext cx="6492240" cy="841248"/>
+            <a:off x="1115568" y="2103120"/>
+            <a:ext cx="6492240" cy="749808"/>
           </a:xfrm>
           <a:prstGeom prst="rect">
             <a:avLst/>
@@ -6972,7 +7023,7 @@
               </a:spcAft>
             </a:pPr>
             <a:r>
-              <a:rPr sz="1550" b="1">
+              <a:rPr sz="1500" b="1">
                 <a:solidFill>
                   <a:srgbClr val="F5F7FA"/>
                 </a:solidFill>
@@ -6981,7 +7032,7 @@
               <a:t>Every decision, policy check &amp; backend call is hash-chained (SHA-256)</a:t>
             </a:r>
             <a:r>
-              <a:rPr sz="1550" b="0">
+              <a:rPr sz="1500" b="0">
                 <a:solidFill>
                   <a:srgbClr val="93A0B4"/>
                 </a:solidFill>
@@ -7000,7 +7051,7 @@
         </p:nvSpPr>
         <p:spPr>
           <a:xfrm>
-            <a:off x="822960" y="3118103"/>
+            <a:off x="822960" y="2935223"/>
             <a:ext cx="109728" cy="109728"/>
           </a:xfrm>
           <a:prstGeom prst="roundRect">
@@ -7044,8 +7095,8 @@
         </p:nvSpPr>
         <p:spPr>
           <a:xfrm>
-            <a:off x="1115568" y="3035808"/>
-            <a:ext cx="6492240" cy="841248"/>
+            <a:off x="1115568" y="2852927"/>
+            <a:ext cx="6492240" cy="749808"/>
           </a:xfrm>
           <a:prstGeom prst="rect">
             <a:avLst/>
@@ -7067,7 +7118,7 @@
               </a:spcAft>
             </a:pPr>
             <a:r>
-              <a:rPr sz="1550" b="1">
+              <a:rPr sz="1500" b="1">
                 <a:solidFill>
                   <a:srgbClr val="F5F7FA"/>
                 </a:solidFill>
@@ -7076,13 +7127,13 @@
               <a:t>Edit any past entry and every downstream hash breaks</a:t>
             </a:r>
             <a:r>
-              <a:rPr sz="1550" b="0">
+              <a:rPr sz="1500" b="0">
                 <a:solidFill>
                   <a:srgbClr val="93A0B4"/>
                 </a:solidFill>
                 <a:latin typeface="Calibri"/>
               </a:rPr>
-              <a:t>  — we catch it live in the demo (verify flips to ‘broken @ seq N’).</a:t>
+              <a:t>  — caught live in the demo (verify flips to ‘broken @ seq N’).</a:t>
             </a:r>
           </a:p>
         </p:txBody>
@@ -7095,7 +7146,7 @@
         </p:nvSpPr>
         <p:spPr>
           <a:xfrm>
-            <a:off x="822960" y="3959352"/>
+            <a:off x="822960" y="3685031"/>
             <a:ext cx="109728" cy="109728"/>
           </a:xfrm>
           <a:prstGeom prst="roundRect">
@@ -7139,8 +7190,8 @@
         </p:nvSpPr>
         <p:spPr>
           <a:xfrm>
-            <a:off x="1115568" y="3877056"/>
-            <a:ext cx="6492240" cy="841248"/>
+            <a:off x="1115568" y="3602735"/>
+            <a:ext cx="6492240" cy="749808"/>
           </a:xfrm>
           <a:prstGeom prst="rect">
             <a:avLst/>
@@ -7162,7 +7213,7 @@
               </a:spcAft>
             </a:pPr>
             <a:r>
-              <a:rPr sz="1550" b="1">
+              <a:rPr sz="1500" b="1">
                 <a:solidFill>
                   <a:srgbClr val="F5F7FA"/>
                 </a:solidFill>
@@ -7171,7 +7222,7 @@
               <a:t>Complete chain-of-custody, not sampling</a:t>
             </a:r>
             <a:r>
-              <a:rPr sz="1550" b="0">
+              <a:rPr sz="1500" b="0">
                 <a:solidFill>
                   <a:srgbClr val="93A0B4"/>
                 </a:solidFill>
@@ -7190,7 +7241,7 @@
         </p:nvSpPr>
         <p:spPr>
           <a:xfrm>
-            <a:off x="822960" y="4800600"/>
+            <a:off x="822960" y="4434840"/>
             <a:ext cx="109728" cy="109728"/>
           </a:xfrm>
           <a:prstGeom prst="roundRect">
@@ -7234,8 +7285,8 @@
         </p:nvSpPr>
         <p:spPr>
           <a:xfrm>
-            <a:off x="1115568" y="4718304"/>
-            <a:ext cx="6492240" cy="841248"/>
+            <a:off x="1115568" y="4352544"/>
+            <a:ext cx="6492240" cy="749808"/>
           </a:xfrm>
           <a:prstGeom prst="rect">
             <a:avLst/>
@@ -7257,16 +7308,111 @@
               </a:spcAft>
             </a:pPr>
             <a:r>
-              <a:rPr sz="1550" b="1">
+              <a:rPr sz="1500" b="1">
                 <a:solidFill>
                   <a:srgbClr val="F5F7FA"/>
                 </a:solidFill>
                 <a:latin typeface="Calibri"/>
               </a:rPr>
+              <a:t>Persisted to Neo4j — explorable as an analyst graph</a:t>
+            </a:r>
+            <a:r>
+              <a:rPr sz="1500" b="0">
+                <a:solidFill>
+                  <a:srgbClr val="93A0B4"/>
+                </a:solidFill>
+                <a:latin typeface="Calibri"/>
+              </a:rPr>
+              <a:t>  — query the whole chain of custody, not scroll a log.</a:t>
+            </a:r>
+          </a:p>
+        </p:txBody>
+      </p:sp>
+      <p:sp>
+        <p:nvSpPr>
+          <p:cNvPr id="14" name="Rounded Rectangle 13"/>
+          <p:cNvSpPr/>
+          <p:nvPr/>
+        </p:nvSpPr>
+        <p:spPr>
+          <a:xfrm>
+            <a:off x="822960" y="5184648"/>
+            <a:ext cx="109728" cy="109728"/>
+          </a:xfrm>
+          <a:prstGeom prst="roundRect">
+            <a:avLst/>
+          </a:prstGeom>
+          <a:solidFill>
+            <a:srgbClr val="2E8BF0"/>
+          </a:solidFill>
+          <a:ln>
+            <a:noFill/>
+          </a:ln>
+          <a:effectLst/>
+        </p:spPr>
+        <p:style>
+          <a:lnRef idx="1">
+            <a:schemeClr val="accent1"/>
+          </a:lnRef>
+          <a:fillRef idx="3">
+            <a:schemeClr val="accent1"/>
+          </a:fillRef>
+          <a:effectRef idx="2">
+            <a:schemeClr val="accent1"/>
+          </a:effectRef>
+          <a:fontRef idx="minor">
+            <a:schemeClr val="lt1"/>
+          </a:fontRef>
+        </p:style>
+        <p:txBody>
+          <a:bodyPr rtlCol="0" anchor="ctr"/>
+          <a:lstStyle/>
+          <a:p>
+            <a:pPr algn="ctr"/>
+          </a:p>
+        </p:txBody>
+      </p:sp>
+      <p:sp>
+        <p:nvSpPr>
+          <p:cNvPr id="15" name="TextBox 14"/>
+          <p:cNvSpPr txBox="1"/>
+          <p:nvPr/>
+        </p:nvSpPr>
+        <p:spPr>
+          <a:xfrm>
+            <a:off x="1115568" y="5102352"/>
+            <a:ext cx="6492240" cy="749808"/>
+          </a:xfrm>
+          <a:prstGeom prst="rect">
+            <a:avLst/>
+          </a:prstGeom>
+          <a:noFill/>
+        </p:spPr>
+        <p:txBody>
+          <a:bodyPr wrap="square" anchor="t" lIns="0" rIns="0" tIns="0" bIns="0">
+            <a:spAutoFit/>
+          </a:bodyPr>
+          <a:lstStyle/>
+          <a:p>
+            <a:pPr algn="l">
+              <a:spcBef>
+                <a:spcPts val="0"/>
+              </a:spcBef>
+              <a:spcAft>
+                <a:spcPts val="400"/>
+              </a:spcAft>
+            </a:pPr>
+            <a:r>
+              <a:rPr sz="1500" b="1">
+                <a:solidFill>
+                  <a:srgbClr val="F5F7FA"/>
+                </a:solidFill>
+                <a:latin typeface="Calibri"/>
+              </a:rPr>
               <a:t>Maps to model-risk (SR 11-7) &amp; adverse-action explainability</a:t>
             </a:r>
             <a:r>
-              <a:rPr sz="1550" b="0">
+              <a:rPr sz="1500" b="0">
                 <a:solidFill>
                   <a:srgbClr val="93A0B4"/>
                 </a:solidFill>
@@ -7279,7 +7425,7 @@
       </p:sp>
       <p:sp>
         <p:nvSpPr>
-          <p:cNvPr id="14" name="Rounded Rectangle 13"/>
+          <p:cNvPr id="16" name="Rounded Rectangle 15"/>
           <p:cNvSpPr/>
           <p:nvPr/>
         </p:nvSpPr>
@@ -7325,7 +7471,7 @@
       </p:sp>
       <p:sp>
         <p:nvSpPr>
-          <p:cNvPr id="15" name="TextBox 14"/>
+          <p:cNvPr id="17" name="TextBox 16"/>
           <p:cNvSpPr txBox="1"/>
           <p:nvPr/>
         </p:nvSpPr>
@@ -7376,7 +7522,7 @@
       </p:sp>
       <p:sp>
         <p:nvSpPr>
-          <p:cNvPr id="16" name="Down Arrow 15"/>
+          <p:cNvPr id="18" name="Down Arrow 17"/>
           <p:cNvSpPr/>
           <p:nvPr/>
         </p:nvSpPr>
@@ -7420,7 +7566,7 @@
       </p:sp>
       <p:sp>
         <p:nvSpPr>
-          <p:cNvPr id="17" name="Rounded Rectangle 16"/>
+          <p:cNvPr id="19" name="Rounded Rectangle 18"/>
           <p:cNvSpPr/>
           <p:nvPr/>
         </p:nvSpPr>
@@ -7466,7 +7612,7 @@
       </p:sp>
       <p:sp>
         <p:nvSpPr>
-          <p:cNvPr id="18" name="TextBox 17"/>
+          <p:cNvPr id="20" name="TextBox 19"/>
           <p:cNvSpPr txBox="1"/>
           <p:nvPr/>
         </p:nvSpPr>
@@ -7517,7 +7663,7 @@
       </p:sp>
       <p:sp>
         <p:nvSpPr>
-          <p:cNvPr id="19" name="Down Arrow 18"/>
+          <p:cNvPr id="21" name="Down Arrow 20"/>
           <p:cNvSpPr/>
           <p:nvPr/>
         </p:nvSpPr>
@@ -7561,7 +7707,7 @@
       </p:sp>
       <p:sp>
         <p:nvSpPr>
-          <p:cNvPr id="20" name="Rounded Rectangle 19"/>
+          <p:cNvPr id="22" name="Rounded Rectangle 21"/>
           <p:cNvSpPr/>
           <p:nvPr/>
         </p:nvSpPr>
@@ -7607,7 +7753,7 @@
       </p:sp>
       <p:sp>
         <p:nvSpPr>
-          <p:cNvPr id="21" name="TextBox 20"/>
+          <p:cNvPr id="23" name="TextBox 22"/>
           <p:cNvSpPr txBox="1"/>
           <p:nvPr/>
         </p:nvSpPr>
@@ -7658,7 +7804,7 @@
       </p:sp>
       <p:sp>
         <p:nvSpPr>
-          <p:cNvPr id="22" name="Down Arrow 21"/>
+          <p:cNvPr id="24" name="Down Arrow 23"/>
           <p:cNvSpPr/>
           <p:nvPr/>
         </p:nvSpPr>
@@ -7702,7 +7848,7 @@
       </p:sp>
       <p:sp>
         <p:nvSpPr>
-          <p:cNvPr id="23" name="Rounded Rectangle 22"/>
+          <p:cNvPr id="25" name="Rounded Rectangle 24"/>
           <p:cNvSpPr/>
           <p:nvPr/>
         </p:nvSpPr>
@@ -7748,7 +7894,7 @@
       </p:sp>
       <p:sp>
         <p:nvSpPr>
-          <p:cNvPr id="24" name="TextBox 23"/>
+          <p:cNvPr id="26" name="TextBox 25"/>
           <p:cNvSpPr txBox="1"/>
           <p:nvPr/>
         </p:nvSpPr>
@@ -7799,7 +7945,7 @@
       </p:sp>
       <p:sp>
         <p:nvSpPr>
-          <p:cNvPr id="25" name="TextBox 24"/>
+          <p:cNvPr id="27" name="TextBox 26"/>
           <p:cNvSpPr txBox="1"/>
           <p:nvPr/>
         </p:nvSpPr>
@@ -7841,7 +7987,7 @@
       </p:sp>
       <p:sp>
         <p:nvSpPr>
-          <p:cNvPr id="26" name="TextBox 25"/>
+          <p:cNvPr id="28" name="TextBox 27"/>
           <p:cNvSpPr txBox="1"/>
           <p:nvPr/>
         </p:nvSpPr>
@@ -10418,7 +10564,7 @@
         </p:nvSpPr>
         <p:spPr>
           <a:xfrm>
-            <a:off x="822960" y="2276856"/>
+            <a:off x="822960" y="2093976"/>
             <a:ext cx="109728" cy="109728"/>
           </a:xfrm>
           <a:prstGeom prst="roundRect">
@@ -10462,8 +10608,8 @@
         </p:nvSpPr>
         <p:spPr>
           <a:xfrm>
-            <a:off x="1115568" y="2194560"/>
-            <a:ext cx="10424160" cy="841248"/>
+            <a:off x="1115568" y="2011680"/>
+            <a:ext cx="10424160" cy="822960"/>
           </a:xfrm>
           <a:prstGeom prst="rect">
             <a:avLst/>
@@ -10485,22 +10631,22 @@
               </a:spcAft>
             </a:pPr>
             <a:r>
-              <a:rPr sz="1650" b="1">
+              <a:rPr sz="1550" b="1">
                 <a:solidFill>
                   <a:srgbClr val="F5F7FA"/>
                 </a:solidFill>
                 <a:latin typeface="Calibri"/>
               </a:rPr>
-              <a:t>Amex’s 2026 direction is agentic commerce — agents that decide and act.</a:t>
-            </a:r>
-            <a:r>
-              <a:rPr sz="1650" b="0">
+              <a:t>Amex’s 2026 direction is agentic commerce — agents that decide and act</a:t>
+            </a:r>
+            <a:r>
+              <a:rPr sz="1550" b="0">
                 <a:solidFill>
                   <a:srgbClr val="93A0B4"/>
                 </a:solidFill>
                 <a:latin typeface="Calibri"/>
               </a:rPr>
-              <a:t>  This is exactly that, applied to servicing.</a:t>
+              <a:t>  — this is exactly that, applied to servicing.</a:t>
             </a:r>
           </a:p>
         </p:txBody>
@@ -10513,7 +10659,7 @@
         </p:nvSpPr>
         <p:spPr>
           <a:xfrm>
-            <a:off x="822960" y="3118103"/>
+            <a:off x="822960" y="2916936"/>
             <a:ext cx="109728" cy="109728"/>
           </a:xfrm>
           <a:prstGeom prst="roundRect">
@@ -10557,8 +10703,8 @@
         </p:nvSpPr>
         <p:spPr>
           <a:xfrm>
-            <a:off x="1115568" y="3035808"/>
-            <a:ext cx="10424160" cy="841248"/>
+            <a:off x="1115568" y="2834640"/>
+            <a:ext cx="10424160" cy="822960"/>
           </a:xfrm>
           <a:prstGeom prst="rect">
             <a:avLst/>
@@ -10580,22 +10726,22 @@
               </a:spcAft>
             </a:pPr>
             <a:r>
-              <a:rPr sz="1650" b="1">
+              <a:rPr sz="1550" b="1">
                 <a:solidFill>
                   <a:srgbClr val="F5F7FA"/>
                 </a:solidFill>
                 <a:latin typeface="Calibri"/>
               </a:rPr>
-              <a:t>~80% of financial institutions lack mature agentic-AI governance,</a:t>
-            </a:r>
-            <a:r>
-              <a:rPr sz="1650" b="0">
+              <a:t>Only 21% of enterprises have mature agentic-AI governance, yet 74% expect to use AI agents by 2027</a:t>
+            </a:r>
+            <a:r>
+              <a:rPr sz="1550" b="0">
                 <a:solidFill>
                   <a:srgbClr val="93A0B4"/>
                 </a:solidFill>
                 <a:latin typeface="Calibri"/>
               </a:rPr>
-              <a:t>  yet most expect heavy agent use by 2027 (Deloitte).</a:t>
+              <a:t>  (Deloitte) — most are scaling agents without the guardrails.</a:t>
             </a:r>
           </a:p>
         </p:txBody>
@@ -10608,7 +10754,7 @@
         </p:nvSpPr>
         <p:spPr>
           <a:xfrm>
-            <a:off x="822960" y="3959352"/>
+            <a:off x="822960" y="3739896"/>
             <a:ext cx="109728" cy="109728"/>
           </a:xfrm>
           <a:prstGeom prst="roundRect">
@@ -10652,8 +10798,8 @@
         </p:nvSpPr>
         <p:spPr>
           <a:xfrm>
-            <a:off x="1115568" y="3877056"/>
-            <a:ext cx="10424160" cy="841248"/>
+            <a:off x="1115568" y="3657600"/>
+            <a:ext cx="10424160" cy="822960"/>
           </a:xfrm>
           <a:prstGeom prst="rect">
             <a:avLst/>
@@ -10675,22 +10821,22 @@
               </a:spcAft>
             </a:pPr>
             <a:r>
-              <a:rPr sz="1650" b="1">
+              <a:rPr sz="1550" b="1">
                 <a:solidFill>
                   <a:srgbClr val="F5F7FA"/>
                 </a:solidFill>
                 <a:latin typeface="Calibri"/>
               </a:rPr>
-              <a:t>Our audit trail + durable compensating workflows are the prerequisites for safe autonomy —</a:t>
-            </a:r>
-            <a:r>
-              <a:rPr sz="1650" b="0">
+              <a:t>Deloitte names the missing controls: audit trails of every agent action + human-approval boundaries</a:t>
+            </a:r>
+            <a:r>
+              <a:rPr sz="1550" b="0">
                 <a:solidFill>
                   <a:srgbClr val="93A0B4"/>
                 </a:solidFill>
                 <a:latin typeface="Calibri"/>
               </a:rPr>
-              <a:t>  ‘human oversight’ and ‘responsible use’ built in, not bolted on.</a:t>
+              <a:t>  — the exact two things we built.</a:t>
             </a:r>
           </a:p>
         </p:txBody>
@@ -10703,8 +10849,8 @@
         </p:nvSpPr>
         <p:spPr>
           <a:xfrm>
-            <a:off x="822960" y="5029200"/>
-            <a:ext cx="10515600" cy="960120"/>
+            <a:off x="822960" y="4617720"/>
+            <a:ext cx="10515600" cy="914400"/>
           </a:xfrm>
           <a:prstGeom prst="roundRect">
             <a:avLst/>
@@ -10749,7 +10895,7 @@
         </p:nvSpPr>
         <p:spPr>
           <a:xfrm>
-            <a:off x="1097280" y="5193792"/>
+            <a:off x="1097280" y="4754880"/>
             <a:ext cx="10058400" cy="731520"/>
           </a:xfrm>
           <a:prstGeom prst="rect">
@@ -10781,13 +10927,13 @@
               <a:t>“With every use case, we’ve ensured there is human oversight.”</a:t>
             </a:r>
             <a:r>
-              <a:rPr sz="1300" b="0">
+              <a:rPr sz="1250" b="0">
                 <a:solidFill>
                   <a:srgbClr val="93A0B4"/>
                 </a:solidFill>
                 <a:latin typeface="Calibri"/>
               </a:rPr>
-              <a:t>   — Amex CIO, on responsible AI. We make that oversight provable and scalable.</a:t>
+              <a:t>   — Ravi Radhakrishnan, EVP &amp; CIO, American Express (Forbes, 2025)</a:t>
             </a:r>
           </a:p>
         </p:txBody>
@@ -10800,8 +10946,8 @@
         </p:nvSpPr>
         <p:spPr>
           <a:xfrm>
-            <a:off x="777240" y="6419088"/>
-            <a:ext cx="7315200" cy="274320"/>
+            <a:off x="822960" y="5760720"/>
+            <a:ext cx="10515600" cy="457200"/>
           </a:xfrm>
           <a:prstGeom prst="rect">
             <a:avLst/>
@@ -10823,6 +10969,57 @@
               </a:spcAft>
             </a:pPr>
             <a:r>
+              <a:rPr sz="950" b="1">
+                <a:solidFill>
+                  <a:srgbClr val="2E8BF0"/>
+                </a:solidFill>
+                <a:latin typeface="Calibri"/>
+              </a:rPr>
+              <a:t>Sources:  </a:t>
+            </a:r>
+            <a:r>
+              <a:rPr sz="950" b="0">
+                <a:solidFill>
+                  <a:srgbClr val="93A0B4"/>
+                </a:solidFill>
+                <a:latin typeface="Calibri"/>
+              </a:rPr>
+              <a:t>Deloitte, “Agentic AI is scaling faster than guardrails” (2025)   ·   Forbes / Peter High, “Ravi Radhakrishnan on Driving AI Innovation at American Express” (May 2025)</a:t>
+            </a:r>
+          </a:p>
+        </p:txBody>
+      </p:sp>
+      <p:sp>
+        <p:nvSpPr>
+          <p:cNvPr id="15" name="TextBox 14"/>
+          <p:cNvSpPr txBox="1"/>
+          <p:nvPr/>
+        </p:nvSpPr>
+        <p:spPr>
+          <a:xfrm>
+            <a:off x="777240" y="6419088"/>
+            <a:ext cx="7315200" cy="274320"/>
+          </a:xfrm>
+          <a:prstGeom prst="rect">
+            <a:avLst/>
+          </a:prstGeom>
+          <a:noFill/>
+        </p:spPr>
+        <p:txBody>
+          <a:bodyPr wrap="square" anchor="t" lIns="0" rIns="0" tIns="0" bIns="0">
+            <a:spAutoFit/>
+          </a:bodyPr>
+          <a:lstStyle/>
+          <a:p>
+            <a:pPr algn="l">
+              <a:spcBef>
+                <a:spcPts val="0"/>
+              </a:spcBef>
+              <a:spcAft>
+                <a:spcPts val="400"/>
+              </a:spcAft>
+            </a:pPr>
+            <a:r>
               <a:rPr sz="900" b="0">
                 <a:solidFill>
                   <a:srgbClr val="93A0B4"/>
@@ -10836,7 +11033,7 @@
       </p:sp>
       <p:sp>
         <p:nvSpPr>
-          <p:cNvPr id="15" name="TextBox 14"/>
+          <p:cNvPr id="16" name="TextBox 15"/>
           <p:cNvSpPr txBox="1"/>
           <p:nvPr/>
         </p:nvSpPr>

</xml_diff>

<commit_message>
Add System Design (LLD) slide with Mermaid sequence diagram
- New slide 11: low-level design — embedded Mermaid sequence diagram of a
  durable case (approval signal -> saga loop -> compensation -> rolled_back),
  plus component responsibilities, audit data model, and key API surface
- Add Mermaid sources (deck/diagrams/*.mmd) + rendered PNGs for architecture
  and the durable-case sequence (editable / importable into Excalidraw)
- Deck now 12 slides: Problem -> HLD -> UI -> LLD -> why-Amex
</commit_message>
<xml_diff>
--- a/deck/CodeStreet2026_Servicing_Agent.pptx
+++ b/deck/CodeStreet2026_Servicing_Agent.pptx
@@ -16,6 +16,7 @@
     <p:sldId id="264" r:id="rId15"/>
     <p:sldId id="265" r:id="rId16"/>
     <p:sldId id="266" r:id="rId17"/>
+    <p:sldId id="267" r:id="rId18"/>
   </p:sldIdLst>
   <p:sldSz cx="12191695" cy="6858000" type="screen4x3"/>
   <p:notesSz cx="6858000" cy="9144000"/>
@@ -4825,7 +4826,7 @@
                 </a:solidFill>
                 <a:latin typeface="Calibri"/>
               </a:rPr>
-              <a:t>WHAT’S NEXT</a:t>
+              <a:t>SYSTEM DESIGN</a:t>
             </a:r>
           </a:p>
         </p:txBody>
@@ -4867,30 +4868,56 @@
                 </a:solidFill>
                 <a:latin typeface="Calibri"/>
               </a:rPr>
-              <a:t>From prototype to production</a:t>
-            </a:r>
-          </a:p>
-        </p:txBody>
-      </p:sp>
-      <p:sp>
-        <p:nvSpPr>
-          <p:cNvPr id="6" name="Rounded Rectangle 5"/>
+              <a:t>Low-level design — how a durable case executes</a:t>
+            </a:r>
+          </a:p>
+        </p:txBody>
+      </p:sp>
+      <p:pic>
+        <p:nvPicPr>
+          <p:cNvPr id="6" name="Picture 5" descr="durable_case_sequence.png"/>
+          <p:cNvPicPr>
+            <a:picLocks noChangeAspect="1"/>
+          </p:cNvPicPr>
+          <p:nvPr/>
+        </p:nvPicPr>
+        <p:blipFill>
+          <a:blip r:embed="rId2"/>
+          <a:stretch>
+            <a:fillRect/>
+          </a:stretch>
+        </p:blipFill>
+        <p:spPr>
+          <a:xfrm>
+            <a:off x="777240" y="1965960"/>
+            <a:ext cx="6537960" cy="4290695"/>
+          </a:xfrm>
+          <a:prstGeom prst="rect">
+            <a:avLst/>
+          </a:prstGeom>
+        </p:spPr>
+      </p:pic>
+      <p:sp>
+        <p:nvSpPr>
+          <p:cNvPr id="7" name="Rounded Rectangle 6"/>
           <p:cNvSpPr/>
           <p:nvPr/>
         </p:nvSpPr>
         <p:spPr>
           <a:xfrm>
-            <a:off x="822960" y="2276856"/>
-            <a:ext cx="109728" cy="109728"/>
+            <a:off x="7543800" y="1965960"/>
+            <a:ext cx="3840480" cy="1965960"/>
           </a:xfrm>
           <a:prstGeom prst="roundRect">
             <a:avLst/>
           </a:prstGeom>
           <a:solidFill>
-            <a:srgbClr val="016FD0"/>
+            <a:srgbClr val="E9F0F9"/>
           </a:solidFill>
-          <a:ln>
-            <a:noFill/>
+          <a:ln w="12700">
+            <a:solidFill>
+              <a:srgbClr val="016FD0"/>
+            </a:solidFill>
           </a:ln>
           <a:effectLst/>
         </p:spPr>
@@ -4918,14 +4945,14 @@
       </p:sp>
       <p:sp>
         <p:nvSpPr>
-          <p:cNvPr id="7" name="TextBox 6"/>
+          <p:cNvPr id="8" name="TextBox 7"/>
           <p:cNvSpPr txBox="1"/>
           <p:nvPr/>
         </p:nvSpPr>
         <p:spPr>
           <a:xfrm>
-            <a:off x="1115568" y="2194560"/>
-            <a:ext cx="10424160" cy="841248"/>
+            <a:off x="7772400" y="2084831"/>
+            <a:ext cx="3474720" cy="274320"/>
           </a:xfrm>
           <a:prstGeom prst="rect">
             <a:avLst/>
@@ -4947,67 +4974,14 @@
               </a:spcAft>
             </a:pPr>
             <a:r>
-              <a:rPr sz="1650" b="1">
-                <a:solidFill>
-                  <a:srgbClr val="0F172A"/>
-                </a:solidFill>
-                <a:latin typeface="Calibri"/>
-              </a:rPr>
-              <a:t>Round 2: integrate real servicing APIs, add voice, expand intents,</a:t>
-            </a:r>
-            <a:r>
-              <a:rPr sz="1650" b="0">
-                <a:solidFill>
-                  <a:srgbClr val="5B6673"/>
-                </a:solidFill>
-                <a:latin typeface="Calibri"/>
-              </a:rPr>
-              <a:t>  and add an LLM-judge clarity eval.</a:t>
-            </a:r>
-          </a:p>
-        </p:txBody>
-      </p:sp>
-      <p:sp>
-        <p:nvSpPr>
-          <p:cNvPr id="8" name="Rounded Rectangle 7"/>
-          <p:cNvSpPr/>
-          <p:nvPr/>
-        </p:nvSpPr>
-        <p:spPr>
-          <a:xfrm>
-            <a:off x="822960" y="3118103"/>
-            <a:ext cx="109728" cy="109728"/>
-          </a:xfrm>
-          <a:prstGeom prst="roundRect">
-            <a:avLst/>
-          </a:prstGeom>
-          <a:solidFill>
-            <a:srgbClr val="016FD0"/>
-          </a:solidFill>
-          <a:ln>
-            <a:noFill/>
-          </a:ln>
-          <a:effectLst/>
-        </p:spPr>
-        <p:style>
-          <a:lnRef idx="1">
-            <a:schemeClr val="accent1"/>
-          </a:lnRef>
-          <a:fillRef idx="3">
-            <a:schemeClr val="accent1"/>
-          </a:fillRef>
-          <a:effectRef idx="2">
-            <a:schemeClr val="accent1"/>
-          </a:effectRef>
-          <a:fontRef idx="minor">
-            <a:schemeClr val="lt1"/>
-          </a:fontRef>
-        </p:style>
-        <p:txBody>
-          <a:bodyPr rtlCol="0" anchor="ctr"/>
-          <a:lstStyle/>
-          <a:p>
-            <a:pPr algn="ctr"/>
+              <a:rPr sz="1200" b="1">
+                <a:solidFill>
+                  <a:srgbClr val="002663"/>
+                </a:solidFill>
+                <a:latin typeface="Calibri"/>
+              </a:rPr>
+              <a:t>Components</a:t>
+            </a:r>
           </a:p>
         </p:txBody>
       </p:sp>
@@ -5019,8 +4993,8 @@
         </p:nvSpPr>
         <p:spPr>
           <a:xfrm>
-            <a:off x="1115568" y="3035808"/>
-            <a:ext cx="10424160" cy="841248"/>
+            <a:off x="7772400" y="2395728"/>
+            <a:ext cx="3520440" cy="310896"/>
           </a:xfrm>
           <a:prstGeom prst="rect">
             <a:avLst/>
@@ -5042,80 +5016,36 @@
               </a:spcAft>
             </a:pPr>
             <a:r>
-              <a:rPr sz="1650" b="1">
+              <a:rPr sz="1050" b="1">
                 <a:solidFill>
                   <a:srgbClr val="0F172A"/>
                 </a:solidFill>
                 <a:latin typeface="Calibri"/>
               </a:rPr>
-              <a:t>Production audit store: append-only, write-once storage behind the same hash-chain</a:t>
-            </a:r>
-            <a:r>
-              <a:rPr sz="1650" b="0">
+              <a:t>FastAPI  </a:t>
+            </a:r>
+            <a:r>
+              <a:rPr sz="1000" b="0">
                 <a:solidFill>
                   <a:srgbClr val="5B6673"/>
                 </a:solidFill>
                 <a:latin typeface="Calibri"/>
               </a:rPr>
-              <a:t>  — exportable for auditors.</a:t>
-            </a:r>
-          </a:p>
-        </p:txBody>
-      </p:sp>
-      <p:sp>
-        <p:nvSpPr>
-          <p:cNvPr id="10" name="Rounded Rectangle 9"/>
-          <p:cNvSpPr/>
-          <p:nvPr/>
-        </p:nvSpPr>
-        <p:spPr>
-          <a:xfrm>
-            <a:off x="822960" y="3959352"/>
-            <a:ext cx="109728" cy="109728"/>
-          </a:xfrm>
-          <a:prstGeom prst="roundRect">
-            <a:avLst/>
-          </a:prstGeom>
-          <a:solidFill>
-            <a:srgbClr val="016FD0"/>
-          </a:solidFill>
-          <a:ln>
-            <a:noFill/>
-          </a:ln>
-          <a:effectLst/>
-        </p:spPr>
-        <p:style>
-          <a:lnRef idx="1">
-            <a:schemeClr val="accent1"/>
-          </a:lnRef>
-          <a:fillRef idx="3">
-            <a:schemeClr val="accent1"/>
-          </a:fillRef>
-          <a:effectRef idx="2">
-            <a:schemeClr val="accent1"/>
-          </a:effectRef>
-          <a:fontRef idx="minor">
-            <a:schemeClr val="lt1"/>
-          </a:fontRef>
-        </p:style>
-        <p:txBody>
-          <a:bodyPr rtlCol="0" anchor="ctr"/>
-          <a:lstStyle/>
-          <a:p>
-            <a:pPr algn="ctr"/>
-          </a:p>
-        </p:txBody>
-      </p:sp>
-      <p:sp>
-        <p:nvSpPr>
-          <p:cNvPr id="11" name="TextBox 10"/>
+              <a:t>owns card state + audit chain</a:t>
+            </a:r>
+          </a:p>
+        </p:txBody>
+      </p:sp>
+      <p:sp>
+        <p:nvSpPr>
+          <p:cNvPr id="10" name="TextBox 9"/>
           <p:cNvSpPr txBox="1"/>
           <p:nvPr/>
         </p:nvSpPr>
         <p:spPr>
           <a:xfrm>
-            <a:off x="1115568" y="3877056"/>
-            <a:ext cx="10424160" cy="841248"/>
+            <a:off x="7772400" y="2743200"/>
+            <a:ext cx="3520440" cy="310896"/>
           </a:xfrm>
           <a:prstGeom prst="rect">
             <a:avLst/>
@@ -5137,80 +5067,36 @@
               </a:spcAft>
             </a:pPr>
             <a:r>
-              <a:rPr sz="1650" b="1">
+              <a:rPr sz="1050" b="1">
                 <a:solidFill>
                   <a:srgbClr val="0F172A"/>
                 </a:solidFill>
                 <a:latin typeface="Calibri"/>
               </a:rPr>
-              <a:t>Guardrails &amp; governance: per-action risk tiers, kill-switch, policy versioning</a:t>
-            </a:r>
-            <a:r>
-              <a:rPr sz="1650" b="0">
+              <a:t>LangGraph  </a:t>
+            </a:r>
+            <a:r>
+              <a:rPr sz="1000" b="0">
                 <a:solidFill>
                   <a:srgbClr val="5B6673"/>
                 </a:solidFill>
                 <a:latin typeface="Calibri"/>
               </a:rPr>
-              <a:t>  — the governance substrate for Amex agents.</a:t>
-            </a:r>
-          </a:p>
-        </p:txBody>
-      </p:sp>
-      <p:sp>
-        <p:nvSpPr>
-          <p:cNvPr id="12" name="Rounded Rectangle 11"/>
-          <p:cNvSpPr/>
-          <p:nvPr/>
-        </p:nvSpPr>
-        <p:spPr>
-          <a:xfrm>
-            <a:off x="822960" y="5029200"/>
-            <a:ext cx="10515600" cy="960120"/>
-          </a:xfrm>
-          <a:prstGeom prst="roundRect">
-            <a:avLst/>
-          </a:prstGeom>
-          <a:solidFill>
-            <a:srgbClr val="002663"/>
-          </a:solidFill>
-          <a:ln>
-            <a:noFill/>
-          </a:ln>
-          <a:effectLst/>
-        </p:spPr>
-        <p:style>
-          <a:lnRef idx="1">
-            <a:schemeClr val="accent1"/>
-          </a:lnRef>
-          <a:fillRef idx="3">
-            <a:schemeClr val="accent1"/>
-          </a:fillRef>
-          <a:effectRef idx="2">
-            <a:schemeClr val="accent1"/>
-          </a:effectRef>
-          <a:fontRef idx="minor">
-            <a:schemeClr val="lt1"/>
-          </a:fontRef>
-        </p:style>
-        <p:txBody>
-          <a:bodyPr rtlCol="0" anchor="ctr"/>
-          <a:lstStyle/>
-          <a:p>
-            <a:pPr algn="ctr"/>
-          </a:p>
-        </p:txBody>
-      </p:sp>
-      <p:sp>
-        <p:nvSpPr>
-          <p:cNvPr id="13" name="TextBox 12"/>
+              <a:t>classify · policy · flows · assist</a:t>
+            </a:r>
+          </a:p>
+        </p:txBody>
+      </p:sp>
+      <p:sp>
+        <p:nvSpPr>
+          <p:cNvPr id="11" name="TextBox 10"/>
           <p:cNvSpPr txBox="1"/>
           <p:nvPr/>
         </p:nvSpPr>
         <p:spPr>
           <a:xfrm>
-            <a:off x="1097280" y="5230368"/>
-            <a:ext cx="10058400" cy="640080"/>
+            <a:off x="7772400" y="3090672"/>
+            <a:ext cx="3520440" cy="310896"/>
           </a:xfrm>
           <a:prstGeom prst="rect">
             <a:avLst/>
@@ -5232,36 +5118,36 @@
               </a:spcAft>
             </a:pPr>
             <a:r>
-              <a:rPr sz="1800" b="1">
-                <a:solidFill>
-                  <a:srgbClr val="FFFFFF"/>
-                </a:solidFill>
-                <a:latin typeface="Calibri"/>
-              </a:rPr>
-              <a:t>The ask:  </a:t>
-            </a:r>
-            <a:r>
-              <a:rPr sz="1700" b="0">
-                <a:solidFill>
-                  <a:srgbClr val="FFFFFF"/>
-                </a:solidFill>
-                <a:latin typeface="Calibri"/>
-              </a:rPr>
-              <a:t>advance us to the prototype round — the core already works end-to-end.</a:t>
-            </a:r>
-          </a:p>
-        </p:txBody>
-      </p:sp>
-      <p:sp>
-        <p:nvSpPr>
-          <p:cNvPr id="14" name="TextBox 13"/>
+              <a:rPr sz="1050" b="1">
+                <a:solidFill>
+                  <a:srgbClr val="0F172A"/>
+                </a:solidFill>
+                <a:latin typeface="Calibri"/>
+              </a:rPr>
+              <a:t>Temporal worker  </a:t>
+            </a:r>
+            <a:r>
+              <a:rPr sz="1000" b="0">
+                <a:solidFill>
+                  <a:srgbClr val="5B6673"/>
+                </a:solidFill>
+                <a:latin typeface="Calibri"/>
+              </a:rPr>
+              <a:t>durable saga + compensation</a:t>
+            </a:r>
+          </a:p>
+        </p:txBody>
+      </p:sp>
+      <p:sp>
+        <p:nvSpPr>
+          <p:cNvPr id="12" name="TextBox 11"/>
           <p:cNvSpPr txBox="1"/>
           <p:nvPr/>
         </p:nvSpPr>
         <p:spPr>
           <a:xfrm>
-            <a:off x="777240" y="6419088"/>
-            <a:ext cx="7315200" cy="274320"/>
+            <a:off x="7772400" y="3438144"/>
+            <a:ext cx="3520440" cy="310896"/>
           </a:xfrm>
           <a:prstGeom prst="rect">
             <a:avLst/>
@@ -5283,6 +5169,416 @@
               </a:spcAft>
             </a:pPr>
             <a:r>
+              <a:rPr sz="1050" b="1">
+                <a:solidFill>
+                  <a:srgbClr val="0F172A"/>
+                </a:solidFill>
+                <a:latin typeface="Calibri"/>
+              </a:rPr>
+              <a:t>Neo4j Aura  </a:t>
+            </a:r>
+            <a:r>
+              <a:rPr sz="1000" b="0">
+                <a:solidFill>
+                  <a:srgbClr val="5B6673"/>
+                </a:solidFill>
+                <a:latin typeface="Calibri"/>
+              </a:rPr>
+              <a:t>audit graph for analysts</a:t>
+            </a:r>
+          </a:p>
+        </p:txBody>
+      </p:sp>
+      <p:sp>
+        <p:nvSpPr>
+          <p:cNvPr id="13" name="Rounded Rectangle 12"/>
+          <p:cNvSpPr/>
+          <p:nvPr/>
+        </p:nvSpPr>
+        <p:spPr>
+          <a:xfrm>
+            <a:off x="7543800" y="4114800"/>
+            <a:ext cx="3840480" cy="2176272"/>
+          </a:xfrm>
+          <a:prstGeom prst="roundRect">
+            <a:avLst/>
+          </a:prstGeom>
+          <a:solidFill>
+            <a:srgbClr val="E9F0F9"/>
+          </a:solidFill>
+          <a:ln w="12700">
+            <a:solidFill>
+              <a:srgbClr val="016FD0"/>
+            </a:solidFill>
+          </a:ln>
+          <a:effectLst/>
+        </p:spPr>
+        <p:style>
+          <a:lnRef idx="1">
+            <a:schemeClr val="accent1"/>
+          </a:lnRef>
+          <a:fillRef idx="3">
+            <a:schemeClr val="accent1"/>
+          </a:fillRef>
+          <a:effectRef idx="2">
+            <a:schemeClr val="accent1"/>
+          </a:effectRef>
+          <a:fontRef idx="minor">
+            <a:schemeClr val="lt1"/>
+          </a:fontRef>
+        </p:style>
+        <p:txBody>
+          <a:bodyPr rtlCol="0" anchor="ctr"/>
+          <a:lstStyle/>
+          <a:p>
+            <a:pPr algn="ctr"/>
+          </a:p>
+        </p:txBody>
+      </p:sp>
+      <p:sp>
+        <p:nvSpPr>
+          <p:cNvPr id="14" name="TextBox 13"/>
+          <p:cNvSpPr txBox="1"/>
+          <p:nvPr/>
+        </p:nvSpPr>
+        <p:spPr>
+          <a:xfrm>
+            <a:off x="7772400" y="4224528"/>
+            <a:ext cx="3474720" cy="274320"/>
+          </a:xfrm>
+          <a:prstGeom prst="rect">
+            <a:avLst/>
+          </a:prstGeom>
+          <a:noFill/>
+        </p:spPr>
+        <p:txBody>
+          <a:bodyPr wrap="square" anchor="t" lIns="0" rIns="0" tIns="0" bIns="0">
+            <a:spAutoFit/>
+          </a:bodyPr>
+          <a:lstStyle/>
+          <a:p>
+            <a:pPr algn="l">
+              <a:spcBef>
+                <a:spcPts val="0"/>
+              </a:spcBef>
+              <a:spcAft>
+                <a:spcPts val="400"/>
+              </a:spcAft>
+            </a:pPr>
+            <a:r>
+              <a:rPr sz="1200" b="1">
+                <a:solidFill>
+                  <a:srgbClr val="002663"/>
+                </a:solidFill>
+                <a:latin typeface="Calibri"/>
+              </a:rPr>
+              <a:t>Audit entry (hash-chained)</a:t>
+            </a:r>
+          </a:p>
+        </p:txBody>
+      </p:sp>
+      <p:sp>
+        <p:nvSpPr>
+          <p:cNvPr id="15" name="TextBox 14"/>
+          <p:cNvSpPr txBox="1"/>
+          <p:nvPr/>
+        </p:nvSpPr>
+        <p:spPr>
+          <a:xfrm>
+            <a:off x="7772400" y="4517136"/>
+            <a:ext cx="3520440" cy="457200"/>
+          </a:xfrm>
+          <a:prstGeom prst="rect">
+            <a:avLst/>
+          </a:prstGeom>
+          <a:noFill/>
+        </p:spPr>
+        <p:txBody>
+          <a:bodyPr wrap="square" anchor="t" lIns="0" rIns="0" tIns="0" bIns="0">
+            <a:spAutoFit/>
+          </a:bodyPr>
+          <a:lstStyle/>
+          <a:p>
+            <a:pPr algn="l">
+              <a:spcBef>
+                <a:spcPts val="0"/>
+              </a:spcBef>
+              <a:spcAft>
+                <a:spcPts val="400"/>
+              </a:spcAft>
+            </a:pPr>
+            <a:r>
+              <a:rPr sz="950" b="0">
+                <a:solidFill>
+                  <a:srgbClr val="0F172A"/>
+                </a:solidFill>
+                <a:latin typeface="Courier New"/>
+              </a:rPr>
+              <a:t>{ seq, actor, action,</a:t>
+            </a:r>
+          </a:p>
+          <a:p>
+            <a:pPr algn="l">
+              <a:spcBef>
+                <a:spcPts val="0"/>
+              </a:spcBef>
+              <a:spcAft>
+                <a:spcPts val="400"/>
+              </a:spcAft>
+            </a:pPr>
+            <a:r>
+              <a:rPr sz="950" b="0">
+                <a:solidFill>
+                  <a:srgbClr val="0F172A"/>
+                </a:solidFill>
+                <a:latin typeface="Courier New"/>
+              </a:rPr>
+              <a:t>  payload, prev_hash, hash }</a:t>
+            </a:r>
+          </a:p>
+        </p:txBody>
+      </p:sp>
+      <p:sp>
+        <p:nvSpPr>
+          <p:cNvPr id="16" name="TextBox 15"/>
+          <p:cNvSpPr txBox="1"/>
+          <p:nvPr/>
+        </p:nvSpPr>
+        <p:spPr>
+          <a:xfrm>
+            <a:off x="7772400" y="5138928"/>
+            <a:ext cx="3474720" cy="274320"/>
+          </a:xfrm>
+          <a:prstGeom prst="rect">
+            <a:avLst/>
+          </a:prstGeom>
+          <a:noFill/>
+        </p:spPr>
+        <p:txBody>
+          <a:bodyPr wrap="square" anchor="t" lIns="0" rIns="0" tIns="0" bIns="0">
+            <a:spAutoFit/>
+          </a:bodyPr>
+          <a:lstStyle/>
+          <a:p>
+            <a:pPr algn="l">
+              <a:spcBef>
+                <a:spcPts val="0"/>
+              </a:spcBef>
+              <a:spcAft>
+                <a:spcPts val="400"/>
+              </a:spcAft>
+            </a:pPr>
+            <a:r>
+              <a:rPr sz="1200" b="1">
+                <a:solidFill>
+                  <a:srgbClr val="002663"/>
+                </a:solidFill>
+                <a:latin typeface="Calibri"/>
+              </a:rPr>
+              <a:t>Key APIs</a:t>
+            </a:r>
+          </a:p>
+        </p:txBody>
+      </p:sp>
+      <p:sp>
+        <p:nvSpPr>
+          <p:cNvPr id="17" name="TextBox 16"/>
+          <p:cNvSpPr txBox="1"/>
+          <p:nvPr/>
+        </p:nvSpPr>
+        <p:spPr>
+          <a:xfrm>
+            <a:off x="7772400" y="5431536"/>
+            <a:ext cx="3520440" cy="201168"/>
+          </a:xfrm>
+          <a:prstGeom prst="rect">
+            <a:avLst/>
+          </a:prstGeom>
+          <a:noFill/>
+        </p:spPr>
+        <p:txBody>
+          <a:bodyPr wrap="square" anchor="t" lIns="0" rIns="0" tIns="0" bIns="0">
+            <a:spAutoFit/>
+          </a:bodyPr>
+          <a:lstStyle/>
+          <a:p>
+            <a:pPr algn="l">
+              <a:spcBef>
+                <a:spcPts val="0"/>
+              </a:spcBef>
+              <a:spcAft>
+                <a:spcPts val="400"/>
+              </a:spcAft>
+            </a:pPr>
+            <a:r>
+              <a:rPr sz="950" b="0">
+                <a:solidFill>
+                  <a:srgbClr val="0F172A"/>
+                </a:solidFill>
+                <a:latin typeface="Courier New"/>
+              </a:rPr>
+              <a:t>POST /chat</a:t>
+            </a:r>
+          </a:p>
+        </p:txBody>
+      </p:sp>
+      <p:sp>
+        <p:nvSpPr>
+          <p:cNvPr id="18" name="TextBox 17"/>
+          <p:cNvSpPr txBox="1"/>
+          <p:nvPr/>
+        </p:nvSpPr>
+        <p:spPr>
+          <a:xfrm>
+            <a:off x="7772400" y="5646420"/>
+            <a:ext cx="3520440" cy="201168"/>
+          </a:xfrm>
+          <a:prstGeom prst="rect">
+            <a:avLst/>
+          </a:prstGeom>
+          <a:noFill/>
+        </p:spPr>
+        <p:txBody>
+          <a:bodyPr wrap="square" anchor="t" lIns="0" rIns="0" tIns="0" bIns="0">
+            <a:spAutoFit/>
+          </a:bodyPr>
+          <a:lstStyle/>
+          <a:p>
+            <a:pPr algn="l">
+              <a:spcBef>
+                <a:spcPts val="0"/>
+              </a:spcBef>
+              <a:spcAft>
+                <a:spcPts val="400"/>
+              </a:spcAft>
+            </a:pPr>
+            <a:r>
+              <a:rPr sz="950" b="0">
+                <a:solidFill>
+                  <a:srgbClr val="0F172A"/>
+                </a:solidFill>
+                <a:latin typeface="Courier New"/>
+              </a:rPr>
+              <a:t>POST /cases/start · /decision</a:t>
+            </a:r>
+          </a:p>
+        </p:txBody>
+      </p:sp>
+      <p:sp>
+        <p:nvSpPr>
+          <p:cNvPr id="19" name="TextBox 18"/>
+          <p:cNvSpPr txBox="1"/>
+          <p:nvPr/>
+        </p:nvSpPr>
+        <p:spPr>
+          <a:xfrm>
+            <a:off x="7772400" y="5861304"/>
+            <a:ext cx="3520440" cy="201168"/>
+          </a:xfrm>
+          <a:prstGeom prst="rect">
+            <a:avLst/>
+          </a:prstGeom>
+          <a:noFill/>
+        </p:spPr>
+        <p:txBody>
+          <a:bodyPr wrap="square" anchor="t" lIns="0" rIns="0" tIns="0" bIns="0">
+            <a:spAutoFit/>
+          </a:bodyPr>
+          <a:lstStyle/>
+          <a:p>
+            <a:pPr algn="l">
+              <a:spcBef>
+                <a:spcPts val="0"/>
+              </a:spcBef>
+              <a:spcAft>
+                <a:spcPts val="400"/>
+              </a:spcAft>
+            </a:pPr>
+            <a:r>
+              <a:rPr sz="950" b="0">
+                <a:solidFill>
+                  <a:srgbClr val="0F172A"/>
+                </a:solidFill>
+                <a:latin typeface="Courier New"/>
+              </a:rPr>
+              <a:t>POST /internal/action/{action}</a:t>
+            </a:r>
+          </a:p>
+        </p:txBody>
+      </p:sp>
+      <p:sp>
+        <p:nvSpPr>
+          <p:cNvPr id="20" name="TextBox 19"/>
+          <p:cNvSpPr txBox="1"/>
+          <p:nvPr/>
+        </p:nvSpPr>
+        <p:spPr>
+          <a:xfrm>
+            <a:off x="7772400" y="6076188"/>
+            <a:ext cx="3520440" cy="201168"/>
+          </a:xfrm>
+          <a:prstGeom prst="rect">
+            <a:avLst/>
+          </a:prstGeom>
+          <a:noFill/>
+        </p:spPr>
+        <p:txBody>
+          <a:bodyPr wrap="square" anchor="t" lIns="0" rIns="0" tIns="0" bIns="0">
+            <a:spAutoFit/>
+          </a:bodyPr>
+          <a:lstStyle/>
+          <a:p>
+            <a:pPr algn="l">
+              <a:spcBef>
+                <a:spcPts val="0"/>
+              </a:spcBef>
+              <a:spcAft>
+                <a:spcPts val="400"/>
+              </a:spcAft>
+            </a:pPr>
+            <a:r>
+              <a:rPr sz="950" b="0">
+                <a:solidFill>
+                  <a:srgbClr val="0F172A"/>
+                </a:solidFill>
+                <a:latin typeface="Courier New"/>
+              </a:rPr>
+              <a:t>GET  /cases · /graph</a:t>
+            </a:r>
+          </a:p>
+        </p:txBody>
+      </p:sp>
+      <p:sp>
+        <p:nvSpPr>
+          <p:cNvPr id="21" name="TextBox 20"/>
+          <p:cNvSpPr txBox="1"/>
+          <p:nvPr/>
+        </p:nvSpPr>
+        <p:spPr>
+          <a:xfrm>
+            <a:off x="777240" y="6419088"/>
+            <a:ext cx="7315200" cy="274320"/>
+          </a:xfrm>
+          <a:prstGeom prst="rect">
+            <a:avLst/>
+          </a:prstGeom>
+          <a:noFill/>
+        </p:spPr>
+        <p:txBody>
+          <a:bodyPr wrap="square" anchor="t" lIns="0" rIns="0" tIns="0" bIns="0">
+            <a:spAutoFit/>
+          </a:bodyPr>
+          <a:lstStyle/>
+          <a:p>
+            <a:pPr algn="l">
+              <a:spcBef>
+                <a:spcPts val="0"/>
+              </a:spcBef>
+              <a:spcAft>
+                <a:spcPts val="400"/>
+              </a:spcAft>
+            </a:pPr>
+            <a:r>
               <a:rPr sz="900" b="0">
                 <a:solidFill>
                   <a:srgbClr val="5B6673"/>
@@ -5296,7 +5592,7 @@
       </p:sp>
       <p:sp>
         <p:nvSpPr>
-          <p:cNvPr id="15" name="TextBox 14"/>
+          <p:cNvPr id="22" name="TextBox 21"/>
           <p:cNvSpPr txBox="1"/>
           <p:nvPr/>
         </p:nvSpPr>
@@ -5332,6 +5628,660 @@
                 <a:latin typeface="Calibri"/>
               </a:rPr>
               <a:t>11</a:t>
+            </a:r>
+          </a:p>
+        </p:txBody>
+      </p:sp>
+    </p:spTree>
+  </p:cSld>
+  <p:clrMapOvr>
+    <a:masterClrMapping/>
+  </p:clrMapOvr>
+</p:sld>
+</file>
+
+<file path=ppt/slides/slide12.xml><?xml version="1.0" encoding="utf-8"?>
+<p:sld xmlns:a="http://schemas.openxmlformats.org/drawingml/2006/main" xmlns:p="http://schemas.openxmlformats.org/presentationml/2006/main" xmlns:r="http://schemas.openxmlformats.org/officeDocument/2006/relationships">
+  <p:cSld>
+    <p:spTree>
+      <p:nvGrpSpPr>
+        <p:cNvPr id="1" name=""/>
+        <p:cNvGrpSpPr/>
+        <p:nvPr/>
+      </p:nvGrpSpPr>
+      <p:grpSpPr/>
+      <p:sp>
+        <p:nvSpPr>
+          <p:cNvPr id="2" name="Rectangle 1"/>
+          <p:cNvSpPr/>
+          <p:nvPr/>
+        </p:nvSpPr>
+        <p:spPr>
+          <a:xfrm>
+            <a:off x="0" y="0"/>
+            <a:ext cx="12191695" cy="6858000"/>
+          </a:xfrm>
+          <a:prstGeom prst="rect">
+            <a:avLst/>
+          </a:prstGeom>
+          <a:solidFill>
+            <a:srgbClr val="F6F9FD"/>
+          </a:solidFill>
+          <a:ln>
+            <a:noFill/>
+          </a:ln>
+          <a:effectLst/>
+        </p:spPr>
+        <p:style>
+          <a:lnRef idx="1">
+            <a:schemeClr val="accent1"/>
+          </a:lnRef>
+          <a:fillRef idx="3">
+            <a:schemeClr val="accent1"/>
+          </a:fillRef>
+          <a:effectRef idx="2">
+            <a:schemeClr val="accent1"/>
+          </a:effectRef>
+          <a:fontRef idx="minor">
+            <a:schemeClr val="lt1"/>
+          </a:fontRef>
+        </p:style>
+        <p:txBody>
+          <a:bodyPr rtlCol="0" anchor="ctr"/>
+          <a:lstStyle/>
+          <a:p>
+            <a:pPr algn="ctr"/>
+          </a:p>
+        </p:txBody>
+      </p:sp>
+      <p:sp>
+        <p:nvSpPr>
+          <p:cNvPr id="3" name="Rectangle 2"/>
+          <p:cNvSpPr/>
+          <p:nvPr/>
+        </p:nvSpPr>
+        <p:spPr>
+          <a:xfrm>
+            <a:off x="0" y="0"/>
+            <a:ext cx="164592" cy="6858000"/>
+          </a:xfrm>
+          <a:prstGeom prst="rect">
+            <a:avLst/>
+          </a:prstGeom>
+          <a:solidFill>
+            <a:srgbClr val="016FD0"/>
+          </a:solidFill>
+          <a:ln>
+            <a:noFill/>
+          </a:ln>
+          <a:effectLst/>
+        </p:spPr>
+        <p:style>
+          <a:lnRef idx="1">
+            <a:schemeClr val="accent1"/>
+          </a:lnRef>
+          <a:fillRef idx="3">
+            <a:schemeClr val="accent1"/>
+          </a:fillRef>
+          <a:effectRef idx="2">
+            <a:schemeClr val="accent1"/>
+          </a:effectRef>
+          <a:fontRef idx="minor">
+            <a:schemeClr val="lt1"/>
+          </a:fontRef>
+        </p:style>
+        <p:txBody>
+          <a:bodyPr rtlCol="0" anchor="ctr"/>
+          <a:lstStyle/>
+          <a:p>
+            <a:pPr algn="ctr"/>
+          </a:p>
+        </p:txBody>
+      </p:sp>
+      <p:sp>
+        <p:nvSpPr>
+          <p:cNvPr id="4" name="TextBox 3"/>
+          <p:cNvSpPr txBox="1"/>
+          <p:nvPr/>
+        </p:nvSpPr>
+        <p:spPr>
+          <a:xfrm>
+            <a:off x="777240" y="502920"/>
+            <a:ext cx="10058400" cy="365760"/>
+          </a:xfrm>
+          <a:prstGeom prst="rect">
+            <a:avLst/>
+          </a:prstGeom>
+          <a:noFill/>
+        </p:spPr>
+        <p:txBody>
+          <a:bodyPr wrap="square" anchor="t" lIns="0" rIns="0" tIns="0" bIns="0">
+            <a:spAutoFit/>
+          </a:bodyPr>
+          <a:lstStyle/>
+          <a:p>
+            <a:pPr algn="l">
+              <a:spcBef>
+                <a:spcPts val="0"/>
+              </a:spcBef>
+              <a:spcAft>
+                <a:spcPts val="400"/>
+              </a:spcAft>
+            </a:pPr>
+            <a:r>
+              <a:rPr sz="1300" b="1">
+                <a:solidFill>
+                  <a:srgbClr val="016FD0"/>
+                </a:solidFill>
+                <a:latin typeface="Calibri"/>
+              </a:rPr>
+              <a:t>WHAT’S NEXT</a:t>
+            </a:r>
+          </a:p>
+        </p:txBody>
+      </p:sp>
+      <p:sp>
+        <p:nvSpPr>
+          <p:cNvPr id="5" name="TextBox 4"/>
+          <p:cNvSpPr txBox="1"/>
+          <p:nvPr/>
+        </p:nvSpPr>
+        <p:spPr>
+          <a:xfrm>
+            <a:off x="749808" y="841248"/>
+            <a:ext cx="10607040" cy="1097280"/>
+          </a:xfrm>
+          <a:prstGeom prst="rect">
+            <a:avLst/>
+          </a:prstGeom>
+          <a:noFill/>
+        </p:spPr>
+        <p:txBody>
+          <a:bodyPr wrap="square" anchor="t" lIns="0" rIns="0" tIns="0" bIns="0">
+            <a:spAutoFit/>
+          </a:bodyPr>
+          <a:lstStyle/>
+          <a:p>
+            <a:pPr algn="l">
+              <a:spcBef>
+                <a:spcPts val="0"/>
+              </a:spcBef>
+              <a:spcAft>
+                <a:spcPts val="400"/>
+              </a:spcAft>
+            </a:pPr>
+            <a:r>
+              <a:rPr sz="3200" b="1">
+                <a:solidFill>
+                  <a:srgbClr val="0F172A"/>
+                </a:solidFill>
+                <a:latin typeface="Calibri"/>
+              </a:rPr>
+              <a:t>From prototype to production</a:t>
+            </a:r>
+          </a:p>
+        </p:txBody>
+      </p:sp>
+      <p:sp>
+        <p:nvSpPr>
+          <p:cNvPr id="6" name="Rounded Rectangle 5"/>
+          <p:cNvSpPr/>
+          <p:nvPr/>
+        </p:nvSpPr>
+        <p:spPr>
+          <a:xfrm>
+            <a:off x="822960" y="2276856"/>
+            <a:ext cx="109728" cy="109728"/>
+          </a:xfrm>
+          <a:prstGeom prst="roundRect">
+            <a:avLst/>
+          </a:prstGeom>
+          <a:solidFill>
+            <a:srgbClr val="016FD0"/>
+          </a:solidFill>
+          <a:ln>
+            <a:noFill/>
+          </a:ln>
+          <a:effectLst/>
+        </p:spPr>
+        <p:style>
+          <a:lnRef idx="1">
+            <a:schemeClr val="accent1"/>
+          </a:lnRef>
+          <a:fillRef idx="3">
+            <a:schemeClr val="accent1"/>
+          </a:fillRef>
+          <a:effectRef idx="2">
+            <a:schemeClr val="accent1"/>
+          </a:effectRef>
+          <a:fontRef idx="minor">
+            <a:schemeClr val="lt1"/>
+          </a:fontRef>
+        </p:style>
+        <p:txBody>
+          <a:bodyPr rtlCol="0" anchor="ctr"/>
+          <a:lstStyle/>
+          <a:p>
+            <a:pPr algn="ctr"/>
+          </a:p>
+        </p:txBody>
+      </p:sp>
+      <p:sp>
+        <p:nvSpPr>
+          <p:cNvPr id="7" name="TextBox 6"/>
+          <p:cNvSpPr txBox="1"/>
+          <p:nvPr/>
+        </p:nvSpPr>
+        <p:spPr>
+          <a:xfrm>
+            <a:off x="1115568" y="2194560"/>
+            <a:ext cx="10424160" cy="841248"/>
+          </a:xfrm>
+          <a:prstGeom prst="rect">
+            <a:avLst/>
+          </a:prstGeom>
+          <a:noFill/>
+        </p:spPr>
+        <p:txBody>
+          <a:bodyPr wrap="square" anchor="t" lIns="0" rIns="0" tIns="0" bIns="0">
+            <a:spAutoFit/>
+          </a:bodyPr>
+          <a:lstStyle/>
+          <a:p>
+            <a:pPr algn="l">
+              <a:spcBef>
+                <a:spcPts val="0"/>
+              </a:spcBef>
+              <a:spcAft>
+                <a:spcPts val="400"/>
+              </a:spcAft>
+            </a:pPr>
+            <a:r>
+              <a:rPr sz="1650" b="1">
+                <a:solidFill>
+                  <a:srgbClr val="0F172A"/>
+                </a:solidFill>
+                <a:latin typeface="Calibri"/>
+              </a:rPr>
+              <a:t>Round 2: integrate real servicing APIs, add voice, expand intents,</a:t>
+            </a:r>
+            <a:r>
+              <a:rPr sz="1650" b="0">
+                <a:solidFill>
+                  <a:srgbClr val="5B6673"/>
+                </a:solidFill>
+                <a:latin typeface="Calibri"/>
+              </a:rPr>
+              <a:t>  and add an LLM-judge clarity eval.</a:t>
+            </a:r>
+          </a:p>
+        </p:txBody>
+      </p:sp>
+      <p:sp>
+        <p:nvSpPr>
+          <p:cNvPr id="8" name="Rounded Rectangle 7"/>
+          <p:cNvSpPr/>
+          <p:nvPr/>
+        </p:nvSpPr>
+        <p:spPr>
+          <a:xfrm>
+            <a:off x="822960" y="3118103"/>
+            <a:ext cx="109728" cy="109728"/>
+          </a:xfrm>
+          <a:prstGeom prst="roundRect">
+            <a:avLst/>
+          </a:prstGeom>
+          <a:solidFill>
+            <a:srgbClr val="016FD0"/>
+          </a:solidFill>
+          <a:ln>
+            <a:noFill/>
+          </a:ln>
+          <a:effectLst/>
+        </p:spPr>
+        <p:style>
+          <a:lnRef idx="1">
+            <a:schemeClr val="accent1"/>
+          </a:lnRef>
+          <a:fillRef idx="3">
+            <a:schemeClr val="accent1"/>
+          </a:fillRef>
+          <a:effectRef idx="2">
+            <a:schemeClr val="accent1"/>
+          </a:effectRef>
+          <a:fontRef idx="minor">
+            <a:schemeClr val="lt1"/>
+          </a:fontRef>
+        </p:style>
+        <p:txBody>
+          <a:bodyPr rtlCol="0" anchor="ctr"/>
+          <a:lstStyle/>
+          <a:p>
+            <a:pPr algn="ctr"/>
+          </a:p>
+        </p:txBody>
+      </p:sp>
+      <p:sp>
+        <p:nvSpPr>
+          <p:cNvPr id="9" name="TextBox 8"/>
+          <p:cNvSpPr txBox="1"/>
+          <p:nvPr/>
+        </p:nvSpPr>
+        <p:spPr>
+          <a:xfrm>
+            <a:off x="1115568" y="3035808"/>
+            <a:ext cx="10424160" cy="841248"/>
+          </a:xfrm>
+          <a:prstGeom prst="rect">
+            <a:avLst/>
+          </a:prstGeom>
+          <a:noFill/>
+        </p:spPr>
+        <p:txBody>
+          <a:bodyPr wrap="square" anchor="t" lIns="0" rIns="0" tIns="0" bIns="0">
+            <a:spAutoFit/>
+          </a:bodyPr>
+          <a:lstStyle/>
+          <a:p>
+            <a:pPr algn="l">
+              <a:spcBef>
+                <a:spcPts val="0"/>
+              </a:spcBef>
+              <a:spcAft>
+                <a:spcPts val="400"/>
+              </a:spcAft>
+            </a:pPr>
+            <a:r>
+              <a:rPr sz="1650" b="1">
+                <a:solidFill>
+                  <a:srgbClr val="0F172A"/>
+                </a:solidFill>
+                <a:latin typeface="Calibri"/>
+              </a:rPr>
+              <a:t>Production audit store: append-only, write-once storage behind the same hash-chain</a:t>
+            </a:r>
+            <a:r>
+              <a:rPr sz="1650" b="0">
+                <a:solidFill>
+                  <a:srgbClr val="5B6673"/>
+                </a:solidFill>
+                <a:latin typeface="Calibri"/>
+              </a:rPr>
+              <a:t>  — exportable for auditors.</a:t>
+            </a:r>
+          </a:p>
+        </p:txBody>
+      </p:sp>
+      <p:sp>
+        <p:nvSpPr>
+          <p:cNvPr id="10" name="Rounded Rectangle 9"/>
+          <p:cNvSpPr/>
+          <p:nvPr/>
+        </p:nvSpPr>
+        <p:spPr>
+          <a:xfrm>
+            <a:off x="822960" y="3959352"/>
+            <a:ext cx="109728" cy="109728"/>
+          </a:xfrm>
+          <a:prstGeom prst="roundRect">
+            <a:avLst/>
+          </a:prstGeom>
+          <a:solidFill>
+            <a:srgbClr val="016FD0"/>
+          </a:solidFill>
+          <a:ln>
+            <a:noFill/>
+          </a:ln>
+          <a:effectLst/>
+        </p:spPr>
+        <p:style>
+          <a:lnRef idx="1">
+            <a:schemeClr val="accent1"/>
+          </a:lnRef>
+          <a:fillRef idx="3">
+            <a:schemeClr val="accent1"/>
+          </a:fillRef>
+          <a:effectRef idx="2">
+            <a:schemeClr val="accent1"/>
+          </a:effectRef>
+          <a:fontRef idx="minor">
+            <a:schemeClr val="lt1"/>
+          </a:fontRef>
+        </p:style>
+        <p:txBody>
+          <a:bodyPr rtlCol="0" anchor="ctr"/>
+          <a:lstStyle/>
+          <a:p>
+            <a:pPr algn="ctr"/>
+          </a:p>
+        </p:txBody>
+      </p:sp>
+      <p:sp>
+        <p:nvSpPr>
+          <p:cNvPr id="11" name="TextBox 10"/>
+          <p:cNvSpPr txBox="1"/>
+          <p:nvPr/>
+        </p:nvSpPr>
+        <p:spPr>
+          <a:xfrm>
+            <a:off x="1115568" y="3877056"/>
+            <a:ext cx="10424160" cy="841248"/>
+          </a:xfrm>
+          <a:prstGeom prst="rect">
+            <a:avLst/>
+          </a:prstGeom>
+          <a:noFill/>
+        </p:spPr>
+        <p:txBody>
+          <a:bodyPr wrap="square" anchor="t" lIns="0" rIns="0" tIns="0" bIns="0">
+            <a:spAutoFit/>
+          </a:bodyPr>
+          <a:lstStyle/>
+          <a:p>
+            <a:pPr algn="l">
+              <a:spcBef>
+                <a:spcPts val="0"/>
+              </a:spcBef>
+              <a:spcAft>
+                <a:spcPts val="400"/>
+              </a:spcAft>
+            </a:pPr>
+            <a:r>
+              <a:rPr sz="1650" b="1">
+                <a:solidFill>
+                  <a:srgbClr val="0F172A"/>
+                </a:solidFill>
+                <a:latin typeface="Calibri"/>
+              </a:rPr>
+              <a:t>Guardrails &amp; governance: per-action risk tiers, kill-switch, policy versioning</a:t>
+            </a:r>
+            <a:r>
+              <a:rPr sz="1650" b="0">
+                <a:solidFill>
+                  <a:srgbClr val="5B6673"/>
+                </a:solidFill>
+                <a:latin typeface="Calibri"/>
+              </a:rPr>
+              <a:t>  — the governance substrate for Amex agents.</a:t>
+            </a:r>
+          </a:p>
+        </p:txBody>
+      </p:sp>
+      <p:sp>
+        <p:nvSpPr>
+          <p:cNvPr id="12" name="Rounded Rectangle 11"/>
+          <p:cNvSpPr/>
+          <p:nvPr/>
+        </p:nvSpPr>
+        <p:spPr>
+          <a:xfrm>
+            <a:off x="822960" y="5029200"/>
+            <a:ext cx="10515600" cy="960120"/>
+          </a:xfrm>
+          <a:prstGeom prst="roundRect">
+            <a:avLst/>
+          </a:prstGeom>
+          <a:solidFill>
+            <a:srgbClr val="002663"/>
+          </a:solidFill>
+          <a:ln>
+            <a:noFill/>
+          </a:ln>
+          <a:effectLst/>
+        </p:spPr>
+        <p:style>
+          <a:lnRef idx="1">
+            <a:schemeClr val="accent1"/>
+          </a:lnRef>
+          <a:fillRef idx="3">
+            <a:schemeClr val="accent1"/>
+          </a:fillRef>
+          <a:effectRef idx="2">
+            <a:schemeClr val="accent1"/>
+          </a:effectRef>
+          <a:fontRef idx="minor">
+            <a:schemeClr val="lt1"/>
+          </a:fontRef>
+        </p:style>
+        <p:txBody>
+          <a:bodyPr rtlCol="0" anchor="ctr"/>
+          <a:lstStyle/>
+          <a:p>
+            <a:pPr algn="ctr"/>
+          </a:p>
+        </p:txBody>
+      </p:sp>
+      <p:sp>
+        <p:nvSpPr>
+          <p:cNvPr id="13" name="TextBox 12"/>
+          <p:cNvSpPr txBox="1"/>
+          <p:nvPr/>
+        </p:nvSpPr>
+        <p:spPr>
+          <a:xfrm>
+            <a:off x="1097280" y="5230368"/>
+            <a:ext cx="10058400" cy="640080"/>
+          </a:xfrm>
+          <a:prstGeom prst="rect">
+            <a:avLst/>
+          </a:prstGeom>
+          <a:noFill/>
+        </p:spPr>
+        <p:txBody>
+          <a:bodyPr wrap="square" anchor="t" lIns="0" rIns="0" tIns="0" bIns="0">
+            <a:spAutoFit/>
+          </a:bodyPr>
+          <a:lstStyle/>
+          <a:p>
+            <a:pPr algn="l">
+              <a:spcBef>
+                <a:spcPts val="0"/>
+              </a:spcBef>
+              <a:spcAft>
+                <a:spcPts val="400"/>
+              </a:spcAft>
+            </a:pPr>
+            <a:r>
+              <a:rPr sz="1800" b="1">
+                <a:solidFill>
+                  <a:srgbClr val="FFFFFF"/>
+                </a:solidFill>
+                <a:latin typeface="Calibri"/>
+              </a:rPr>
+              <a:t>The ask:  </a:t>
+            </a:r>
+            <a:r>
+              <a:rPr sz="1700" b="0">
+                <a:solidFill>
+                  <a:srgbClr val="FFFFFF"/>
+                </a:solidFill>
+                <a:latin typeface="Calibri"/>
+              </a:rPr>
+              <a:t>advance us to the prototype round — the core already works end-to-end.</a:t>
+            </a:r>
+          </a:p>
+        </p:txBody>
+      </p:sp>
+      <p:sp>
+        <p:nvSpPr>
+          <p:cNvPr id="14" name="TextBox 13"/>
+          <p:cNvSpPr txBox="1"/>
+          <p:nvPr/>
+        </p:nvSpPr>
+        <p:spPr>
+          <a:xfrm>
+            <a:off x="777240" y="6419088"/>
+            <a:ext cx="7315200" cy="274320"/>
+          </a:xfrm>
+          <a:prstGeom prst="rect">
+            <a:avLst/>
+          </a:prstGeom>
+          <a:noFill/>
+        </p:spPr>
+        <p:txBody>
+          <a:bodyPr wrap="square" anchor="t" lIns="0" rIns="0" tIns="0" bIns="0">
+            <a:spAutoFit/>
+          </a:bodyPr>
+          <a:lstStyle/>
+          <a:p>
+            <a:pPr algn="l">
+              <a:spcBef>
+                <a:spcPts val="0"/>
+              </a:spcBef>
+              <a:spcAft>
+                <a:spcPts val="400"/>
+              </a:spcAft>
+            </a:pPr>
+            <a:r>
+              <a:rPr sz="900" b="0">
+                <a:solidFill>
+                  <a:srgbClr val="5B6673"/>
+                </a:solidFill>
+                <a:latin typeface="Calibri"/>
+              </a:rPr>
+              <a:t>End-to-End Servicing Agent · CodeStreet 2026</a:t>
+            </a:r>
+          </a:p>
+        </p:txBody>
+      </p:sp>
+      <p:sp>
+        <p:nvSpPr>
+          <p:cNvPr id="15" name="TextBox 14"/>
+          <p:cNvSpPr txBox="1"/>
+          <p:nvPr/>
+        </p:nvSpPr>
+        <p:spPr>
+          <a:xfrm>
+            <a:off x="10972800" y="6419088"/>
+            <a:ext cx="822960" cy="274320"/>
+          </a:xfrm>
+          <a:prstGeom prst="rect">
+            <a:avLst/>
+          </a:prstGeom>
+          <a:noFill/>
+        </p:spPr>
+        <p:txBody>
+          <a:bodyPr wrap="square" anchor="t" lIns="0" rIns="0" tIns="0" bIns="0">
+            <a:spAutoFit/>
+          </a:bodyPr>
+          <a:lstStyle/>
+          <a:p>
+            <a:pPr algn="r">
+              <a:spcBef>
+                <a:spcPts val="0"/>
+              </a:spcBef>
+              <a:spcAft>
+                <a:spcPts val="400"/>
+              </a:spcAft>
+            </a:pPr>
+            <a:r>
+              <a:rPr sz="900" b="0">
+                <a:solidFill>
+                  <a:srgbClr val="5B6673"/>
+                </a:solidFill>
+                <a:latin typeface="Calibri"/>
+              </a:rPr>
+              <a:t>12</a:t>
             </a:r>
           </a:p>
         </p:txBody>

</xml_diff>

<commit_message>
Real eval numbers on the metrics slide + real UI screenshots in the deck
- Eval harness: reset state per case + complete the multi-turn slot-fill; add
  policy-violations (0) and audit-integrity (100%) checks. Measured: 90%
  classification, 80% first-contact resolution, 86.7% correct handling
- Slide 8 shows these measured numbers
- Slide 4 (product): replace the wireframe with a real Playwright screenshot of
  the running console (policy citations, counterfactual, cases) + annotations
- Add /reset endpoint + reset_seed() for clean demos/captures
- Add screenshot.cjs (Playwright capture) + captured UI PNGs
</commit_message>
<xml_diff>
--- a/deck/CodeStreet2026_Servicing_Agent.pptx
+++ b/deck/CodeStreet2026_Servicing_Agent.pptx
@@ -8869,106 +8869,40 @@
           </a:p>
         </p:txBody>
       </p:sp>
-      <p:sp>
-        <p:nvSpPr>
-          <p:cNvPr id="6" name="Rounded Rectangle 5"/>
-          <p:cNvSpPr/>
-          <p:nvPr/>
-        </p:nvSpPr>
-        <p:spPr>
-          <a:xfrm>
-            <a:off x="822960" y="1965960"/>
-            <a:ext cx="10515600" cy="3703320"/>
-          </a:xfrm>
-          <a:prstGeom prst="roundRect">
-            <a:avLst/>
-          </a:prstGeom>
-          <a:solidFill>
-            <a:srgbClr val="FFFFFF"/>
-          </a:solidFill>
-          <a:ln w="15875">
-            <a:solidFill>
-              <a:srgbClr val="016FD0"/>
-            </a:solidFill>
-          </a:ln>
-          <a:effectLst/>
-        </p:spPr>
-        <p:style>
-          <a:lnRef idx="1">
-            <a:schemeClr val="accent1"/>
-          </a:lnRef>
-          <a:fillRef idx="3">
-            <a:schemeClr val="accent1"/>
-          </a:fillRef>
-          <a:effectRef idx="2">
-            <a:schemeClr val="accent1"/>
-          </a:effectRef>
-          <a:fontRef idx="minor">
-            <a:schemeClr val="lt1"/>
-          </a:fontRef>
-        </p:style>
-        <p:txBody>
-          <a:bodyPr rtlCol="0" anchor="ctr"/>
-          <a:lstStyle/>
-          <a:p>
-            <a:pPr algn="ctr"/>
-          </a:p>
-        </p:txBody>
-      </p:sp>
-      <p:sp>
-        <p:nvSpPr>
-          <p:cNvPr id="7" name="Rounded Rectangle 6"/>
-          <p:cNvSpPr/>
-          <p:nvPr/>
-        </p:nvSpPr>
-        <p:spPr>
-          <a:xfrm>
-            <a:off x="1051560" y="2121408"/>
-            <a:ext cx="10058400" cy="457200"/>
-          </a:xfrm>
-          <a:prstGeom prst="roundRect">
-            <a:avLst/>
-          </a:prstGeom>
-          <a:solidFill>
-            <a:srgbClr val="E9F0F9"/>
-          </a:solidFill>
-          <a:ln>
-            <a:noFill/>
-          </a:ln>
-          <a:effectLst/>
-        </p:spPr>
-        <p:style>
-          <a:lnRef idx="1">
-            <a:schemeClr val="accent1"/>
-          </a:lnRef>
-          <a:fillRef idx="3">
-            <a:schemeClr val="accent1"/>
-          </a:fillRef>
-          <a:effectRef idx="2">
-            <a:schemeClr val="accent1"/>
-          </a:effectRef>
-          <a:fontRef idx="minor">
-            <a:schemeClr val="lt1"/>
-          </a:fontRef>
-        </p:style>
-        <p:txBody>
-          <a:bodyPr rtlCol="0" anchor="ctr"/>
-          <a:lstStyle/>
-          <a:p>
-            <a:pPr algn="ctr"/>
-          </a:p>
-        </p:txBody>
-      </p:sp>
-      <p:sp>
-        <p:nvSpPr>
-          <p:cNvPr id="8" name="TextBox 7"/>
+      <p:pic>
+        <p:nvPicPr>
+          <p:cNvPr id="6" name="Picture 5" descr="ui_main.png"/>
+          <p:cNvPicPr>
+            <a:picLocks noChangeAspect="1"/>
+          </p:cNvPicPr>
+          <p:nvPr/>
+        </p:nvPicPr>
+        <p:blipFill>
+          <a:blip r:embed="rId2"/>
+          <a:stretch>
+            <a:fillRect/>
+          </a:stretch>
+        </p:blipFill>
+        <p:spPr>
+          <a:xfrm>
+            <a:off x="777240" y="1874519"/>
+            <a:ext cx="6858000" cy="4286250"/>
+          </a:xfrm>
+          <a:prstGeom prst="rect">
+            <a:avLst/>
+          </a:prstGeom>
+        </p:spPr>
+      </p:pic>
+      <p:sp>
+        <p:nvSpPr>
+          <p:cNvPr id="7" name="TextBox 6"/>
           <p:cNvSpPr txBox="1"/>
           <p:nvPr/>
         </p:nvSpPr>
         <p:spPr>
           <a:xfrm>
-            <a:off x="1234440" y="2212848"/>
-            <a:ext cx="4572000" cy="320040"/>
+            <a:off x="8275320" y="1965960"/>
+            <a:ext cx="3108960" cy="365760"/>
           </a:xfrm>
           <a:prstGeom prst="rect">
             <a:avLst/>
@@ -8990,75 +8924,33 @@
               </a:spcAft>
             </a:pPr>
             <a:r>
-              <a:rPr sz="1100" b="1">
+              <a:rPr sz="1300" b="1">
                 <a:solidFill>
                   <a:srgbClr val="002663"/>
                 </a:solidFill>
                 <a:latin typeface="Calibri"/>
               </a:rPr>
-              <a:t>End-to-End Servicing Agent</a:t>
-            </a:r>
-          </a:p>
-        </p:txBody>
-      </p:sp>
-      <p:sp>
-        <p:nvSpPr>
-          <p:cNvPr id="9" name="TextBox 8"/>
-          <p:cNvSpPr txBox="1"/>
-          <p:nvPr/>
-        </p:nvSpPr>
-        <p:spPr>
-          <a:xfrm>
-            <a:off x="6035040" y="2231136"/>
-            <a:ext cx="4892040" cy="320040"/>
-          </a:xfrm>
-          <a:prstGeom prst="rect">
-            <a:avLst/>
-          </a:prstGeom>
-          <a:noFill/>
-        </p:spPr>
-        <p:txBody>
-          <a:bodyPr wrap="square" anchor="t" lIns="0" rIns="0" tIns="0" bIns="0">
-            <a:spAutoFit/>
-          </a:bodyPr>
-          <a:lstStyle/>
-          <a:p>
-            <a:pPr algn="r">
-              <a:spcBef>
-                <a:spcPts val="0"/>
-              </a:spcBef>
-              <a:spcAft>
-                <a:spcPts val="400"/>
-              </a:spcAft>
-            </a:pPr>
-            <a:r>
-              <a:rPr sz="950" b="0">
-                <a:solidFill>
-                  <a:srgbClr val="5B6673"/>
-                </a:solidFill>
-                <a:latin typeface="Calibri"/>
-              </a:rPr>
-              <a:t>New card · Card→rollback · $50k limit          Priya Sharma ▾</a:t>
-            </a:r>
-          </a:p>
-        </p:txBody>
-      </p:sp>
-      <p:sp>
-        <p:nvSpPr>
-          <p:cNvPr id="10" name="Rounded Rectangle 9"/>
+              <a:t>What you’re seeing</a:t>
+            </a:r>
+          </a:p>
+        </p:txBody>
+      </p:sp>
+      <p:sp>
+        <p:nvSpPr>
+          <p:cNvPr id="8" name="Rounded Rectangle 7"/>
           <p:cNvSpPr/>
           <p:nvPr/>
         </p:nvSpPr>
         <p:spPr>
           <a:xfrm>
-            <a:off x="1051560" y="2724912"/>
-            <a:ext cx="5943600" cy="2816352"/>
+            <a:off x="8001000" y="2551176"/>
+            <a:ext cx="109728" cy="109728"/>
           </a:xfrm>
           <a:prstGeom prst="roundRect">
             <a:avLst/>
           </a:prstGeom>
           <a:solidFill>
-            <a:srgbClr val="E9F0F9"/>
+            <a:srgbClr val="016FD0"/>
           </a:solidFill>
           <a:ln>
             <a:noFill/>
@@ -9089,14 +8981,14 @@
       </p:sp>
       <p:sp>
         <p:nvSpPr>
-          <p:cNvPr id="11" name="TextBox 10"/>
+          <p:cNvPr id="9" name="TextBox 8"/>
           <p:cNvSpPr txBox="1"/>
           <p:nvPr/>
         </p:nvSpPr>
         <p:spPr>
           <a:xfrm>
-            <a:off x="1280160" y="2834640"/>
-            <a:ext cx="3657600" cy="274320"/>
+            <a:off x="8275320" y="2514600"/>
+            <a:ext cx="3063240" cy="640080"/>
           </a:xfrm>
           <a:prstGeom prst="rect">
             <a:avLst/>
@@ -9118,82 +9010,15 @@
               </a:spcAft>
             </a:pPr>
             <a:r>
-              <a:rPr sz="1000" b="1">
-                <a:solidFill>
-                  <a:srgbClr val="002663"/>
-                </a:solidFill>
-                <a:latin typeface="Calibri"/>
-              </a:rPr>
-              <a:t>Conversation</a:t>
-            </a:r>
-          </a:p>
-        </p:txBody>
-      </p:sp>
-      <p:sp>
-        <p:nvSpPr>
-          <p:cNvPr id="12" name="Rounded Rectangle 11"/>
-          <p:cNvSpPr/>
-          <p:nvPr/>
-        </p:nvSpPr>
-        <p:spPr>
-          <a:xfrm>
-            <a:off x="3794760" y="3200400"/>
-            <a:ext cx="2926080" cy="411480"/>
-          </a:xfrm>
-          <a:prstGeom prst="roundRect">
-            <a:avLst/>
-          </a:prstGeom>
-          <a:solidFill>
-            <a:srgbClr val="016FD0"/>
-          </a:solidFill>
-          <a:ln>
-            <a:noFill/>
-          </a:ln>
-          <a:effectLst/>
-        </p:spPr>
-        <p:style>
-          <a:lnRef idx="1">
-            <a:schemeClr val="accent1"/>
-          </a:lnRef>
-          <a:fillRef idx="3">
-            <a:schemeClr val="accent1"/>
-          </a:fillRef>
-          <a:effectRef idx="2">
-            <a:schemeClr val="accent1"/>
-          </a:effectRef>
-          <a:fontRef idx="minor">
-            <a:schemeClr val="lt1"/>
-          </a:fontRef>
-        </p:style>
-        <p:txBody>
-          <a:bodyPr rtlCol="0" anchor="ctr"/>
-          <a:lstStyle/>
-          <a:p>
-            <a:pPr algn="ctr"/>
-          </a:p>
-        </p:txBody>
-      </p:sp>
-      <p:sp>
-        <p:nvSpPr>
-          <p:cNvPr id="13" name="TextBox 12"/>
-          <p:cNvSpPr txBox="1"/>
-          <p:nvPr/>
-        </p:nvSpPr>
-        <p:spPr>
-          <a:xfrm>
-            <a:off x="3931920" y="3282696"/>
-            <a:ext cx="2651760" cy="274320"/>
-          </a:xfrm>
-          <a:prstGeom prst="rect">
-            <a:avLst/>
-          </a:prstGeom>
-          <a:noFill/>
-        </p:spPr>
-        <p:txBody>
-          <a:bodyPr wrap="square" anchor="t" lIns="0" rIns="0" tIns="0" bIns="0">
-            <a:spAutoFit/>
-          </a:bodyPr>
-          <a:lstStyle/>
+              <a:rPr sz="1200" b="1">
+                <a:solidFill>
+                  <a:srgbClr val="0F172A"/>
+                </a:solidFill>
+                <a:latin typeface="Calibri"/>
+              </a:rPr>
+              <a:t>Policy citation in every reply</a:t>
+            </a:r>
+          </a:p>
           <a:p>
             <a:pPr algn="l">
               <a:spcBef>
@@ -9204,38 +9029,36 @@
               </a:spcAft>
             </a:pPr>
             <a:r>
-              <a:rPr sz="950" b="0">
-                <a:solidFill>
-                  <a:srgbClr val="FFFFFF"/>
-                </a:solidFill>
-                <a:latin typeface="Calibri"/>
-              </a:rPr>
-              <a:t>Please waive my $39 late fee</a:t>
-            </a:r>
-          </a:p>
-        </p:txBody>
-      </p:sp>
-      <p:sp>
-        <p:nvSpPr>
-          <p:cNvPr id="14" name="Rounded Rectangle 13"/>
+              <a:rPr sz="1050" b="0">
+                <a:solidFill>
+                  <a:srgbClr val="5B6673"/>
+                </a:solidFill>
+                <a:latin typeface="Calibri"/>
+              </a:rPr>
+              <a:t>“auto-approved under FEE-AUTO v1.2”</a:t>
+            </a:r>
+          </a:p>
+        </p:txBody>
+      </p:sp>
+      <p:sp>
+        <p:nvSpPr>
+          <p:cNvPr id="10" name="Rounded Rectangle 9"/>
           <p:cNvSpPr/>
           <p:nvPr/>
         </p:nvSpPr>
         <p:spPr>
           <a:xfrm>
-            <a:off x="1325880" y="3794760"/>
-            <a:ext cx="4389120" cy="731520"/>
+            <a:off x="8001000" y="3392424"/>
+            <a:ext cx="109728" cy="109728"/>
           </a:xfrm>
           <a:prstGeom prst="roundRect">
             <a:avLst/>
           </a:prstGeom>
           <a:solidFill>
-            <a:srgbClr val="FFFFFF"/>
+            <a:srgbClr val="059669"/>
           </a:solidFill>
-          <a:ln w="12700">
-            <a:solidFill>
-              <a:srgbClr val="E9F0F9"/>
-            </a:solidFill>
+          <a:ln>
+            <a:noFill/>
           </a:ln>
           <a:effectLst/>
         </p:spPr>
@@ -9263,14 +9086,14 @@
       </p:sp>
       <p:sp>
         <p:nvSpPr>
-          <p:cNvPr id="15" name="TextBox 14"/>
+          <p:cNvPr id="11" name="TextBox 10"/>
           <p:cNvSpPr txBox="1"/>
           <p:nvPr/>
         </p:nvSpPr>
         <p:spPr>
           <a:xfrm>
-            <a:off x="1463040" y="3877056"/>
-            <a:ext cx="4114800" cy="594360"/>
+            <a:off x="8275320" y="3355848"/>
+            <a:ext cx="3063240" cy="640080"/>
           </a:xfrm>
           <a:prstGeom prst="rect">
             <a:avLst/>
@@ -9292,22 +9115,13 @@
               </a:spcAft>
             </a:pPr>
             <a:r>
-              <a:rPr sz="850" b="1">
-                <a:solidFill>
-                  <a:srgbClr val="059669"/>
-                </a:solidFill>
-                <a:latin typeface="Calibri"/>
-              </a:rPr>
-              <a:t>resolved   </a:t>
-            </a:r>
-            <a:r>
-              <a:rPr sz="850" b="0">
-                <a:solidFill>
-                  <a:srgbClr val="5B6673"/>
-                </a:solidFill>
-                <a:latin typeface="Calibri"/>
-              </a:rPr>
-              <a:t>fee_reversal · 96%</a:t>
+              <a:rPr sz="1200" b="1">
+                <a:solidFill>
+                  <a:srgbClr val="0F172A"/>
+                </a:solidFill>
+                <a:latin typeface="Calibri"/>
+              </a:rPr>
+              <a:t>Counterfactual on escalation</a:t>
             </a:r>
           </a:p>
           <a:p>
@@ -9320,27 +9134,71 @@
               </a:spcAft>
             </a:pPr>
             <a:r>
-              <a:rPr sz="950" b="0">
-                <a:solidFill>
-                  <a:srgbClr val="0F172A"/>
-                </a:solidFill>
-                <a:latin typeface="Calibri"/>
-              </a:rPr>
-              <a:t>Done — I’ve reversed the $39 late fee.</a:t>
-            </a:r>
-          </a:p>
-        </p:txBody>
-      </p:sp>
-      <p:sp>
-        <p:nvSpPr>
-          <p:cNvPr id="16" name="TextBox 15"/>
+              <a:rPr sz="1050" b="0">
+                <a:solidFill>
+                  <a:srgbClr val="5B6673"/>
+                </a:solidFill>
+                <a:latin typeface="Calibri"/>
+              </a:rPr>
+              <a:t>“I can auto-approve up to $13,000 now”</a:t>
+            </a:r>
+          </a:p>
+        </p:txBody>
+      </p:sp>
+      <p:sp>
+        <p:nvSpPr>
+          <p:cNvPr id="12" name="Rounded Rectangle 11"/>
+          <p:cNvSpPr/>
+          <p:nvPr/>
+        </p:nvSpPr>
+        <p:spPr>
+          <a:xfrm>
+            <a:off x="8001000" y="4233672"/>
+            <a:ext cx="109728" cy="109728"/>
+          </a:xfrm>
+          <a:prstGeom prst="roundRect">
+            <a:avLst/>
+          </a:prstGeom>
+          <a:solidFill>
+            <a:srgbClr val="B45309"/>
+          </a:solidFill>
+          <a:ln>
+            <a:noFill/>
+          </a:ln>
+          <a:effectLst/>
+        </p:spPr>
+        <p:style>
+          <a:lnRef idx="1">
+            <a:schemeClr val="accent1"/>
+          </a:lnRef>
+          <a:fillRef idx="3">
+            <a:schemeClr val="accent1"/>
+          </a:fillRef>
+          <a:effectRef idx="2">
+            <a:schemeClr val="accent1"/>
+          </a:effectRef>
+          <a:fontRef idx="minor">
+            <a:schemeClr val="lt1"/>
+          </a:fontRef>
+        </p:style>
+        <p:txBody>
+          <a:bodyPr rtlCol="0" anchor="ctr"/>
+          <a:lstStyle/>
+          <a:p>
+            <a:pPr algn="ctr"/>
+          </a:p>
+        </p:txBody>
+      </p:sp>
+      <p:sp>
+        <p:nvSpPr>
+          <p:cNvPr id="13" name="TextBox 12"/>
           <p:cNvSpPr txBox="1"/>
           <p:nvPr/>
         </p:nvSpPr>
         <p:spPr>
           <a:xfrm>
-            <a:off x="1325880" y="5074920"/>
-            <a:ext cx="5486400" cy="365760"/>
+            <a:off x="8275320" y="4197096"/>
+            <a:ext cx="3063240" cy="640080"/>
           </a:xfrm>
           <a:prstGeom prst="rect">
             <a:avLst/>
@@ -9362,386 +9220,15 @@
               </a:spcAft>
             </a:pPr>
             <a:r>
-              <a:rPr sz="900" b="0">
-                <a:solidFill>
-                  <a:srgbClr val="5B6673"/>
-                </a:solidFill>
-                <a:latin typeface="Calibri"/>
-              </a:rPr>
-              <a:t>Priya Sharma · limit $10,000 · standing Good · open fees 0</a:t>
-            </a:r>
-          </a:p>
-        </p:txBody>
-      </p:sp>
-      <p:sp>
-        <p:nvSpPr>
-          <p:cNvPr id="17" name="Rounded Rectangle 16"/>
-          <p:cNvSpPr/>
-          <p:nvPr/>
-        </p:nvSpPr>
-        <p:spPr>
-          <a:xfrm>
-            <a:off x="7178040" y="2724912"/>
-            <a:ext cx="4069080" cy="2816352"/>
-          </a:xfrm>
-          <a:prstGeom prst="roundRect">
-            <a:avLst/>
-          </a:prstGeom>
-          <a:solidFill>
-            <a:srgbClr val="E9F0F9"/>
-          </a:solidFill>
-          <a:ln>
-            <a:noFill/>
-          </a:ln>
-          <a:effectLst/>
-        </p:spPr>
-        <p:style>
-          <a:lnRef idx="1">
-            <a:schemeClr val="accent1"/>
-          </a:lnRef>
-          <a:fillRef idx="3">
-            <a:schemeClr val="accent1"/>
-          </a:fillRef>
-          <a:effectRef idx="2">
-            <a:schemeClr val="accent1"/>
-          </a:effectRef>
-          <a:fontRef idx="minor">
-            <a:schemeClr val="lt1"/>
-          </a:fontRef>
-        </p:style>
-        <p:txBody>
-          <a:bodyPr rtlCol="0" anchor="ctr"/>
-          <a:lstStyle/>
-          <a:p>
-            <a:pPr algn="ctr"/>
-          </a:p>
-        </p:txBody>
-      </p:sp>
-      <p:sp>
-        <p:nvSpPr>
-          <p:cNvPr id="18" name="Rounded Rectangle 17"/>
-          <p:cNvSpPr/>
-          <p:nvPr/>
-        </p:nvSpPr>
-        <p:spPr>
-          <a:xfrm>
-            <a:off x="7360920" y="2834640"/>
-            <a:ext cx="1188720" cy="329184"/>
-          </a:xfrm>
-          <a:prstGeom prst="roundRect">
-            <a:avLst/>
-          </a:prstGeom>
-          <a:solidFill>
-            <a:srgbClr val="016FD0"/>
-          </a:solidFill>
-          <a:ln>
-            <a:noFill/>
-          </a:ln>
-          <a:effectLst/>
-        </p:spPr>
-        <p:style>
-          <a:lnRef idx="1">
-            <a:schemeClr val="accent1"/>
-          </a:lnRef>
-          <a:fillRef idx="3">
-            <a:schemeClr val="accent1"/>
-          </a:fillRef>
-          <a:effectRef idx="2">
-            <a:schemeClr val="accent1"/>
-          </a:effectRef>
-          <a:fontRef idx="minor">
-            <a:schemeClr val="lt1"/>
-          </a:fontRef>
-        </p:style>
-        <p:txBody>
-          <a:bodyPr rtlCol="0" anchor="ctr"/>
-          <a:lstStyle/>
-          <a:p>
-            <a:pPr algn="ctr"/>
-          </a:p>
-        </p:txBody>
-      </p:sp>
-      <p:sp>
-        <p:nvSpPr>
-          <p:cNvPr id="19" name="TextBox 18"/>
-          <p:cNvSpPr txBox="1"/>
-          <p:nvPr/>
-        </p:nvSpPr>
-        <p:spPr>
-          <a:xfrm>
-            <a:off x="7360920" y="2907792"/>
-            <a:ext cx="1188720" cy="256032"/>
-          </a:xfrm>
-          <a:prstGeom prst="rect">
-            <a:avLst/>
-          </a:prstGeom>
-          <a:noFill/>
-        </p:spPr>
-        <p:txBody>
-          <a:bodyPr wrap="square" anchor="t" lIns="0" rIns="0" tIns="0" bIns="0">
-            <a:spAutoFit/>
-          </a:bodyPr>
-          <a:lstStyle/>
-          <a:p>
-            <a:pPr algn="ctr">
-              <a:spcBef>
-                <a:spcPts val="0"/>
-              </a:spcBef>
-              <a:spcAft>
-                <a:spcPts val="400"/>
-              </a:spcAft>
-            </a:pPr>
-            <a:r>
-              <a:rPr sz="900" b="1">
-                <a:solidFill>
-                  <a:srgbClr val="FFFFFF"/>
-                </a:solidFill>
-                <a:latin typeface="Calibri"/>
-              </a:rPr>
-              <a:t>Cases</a:t>
-            </a:r>
-          </a:p>
-        </p:txBody>
-      </p:sp>
-      <p:sp>
-        <p:nvSpPr>
-          <p:cNvPr id="20" name="Rounded Rectangle 19"/>
-          <p:cNvSpPr/>
-          <p:nvPr/>
-        </p:nvSpPr>
-        <p:spPr>
-          <a:xfrm>
-            <a:off x="8641080" y="2834640"/>
-            <a:ext cx="1188720" cy="329184"/>
-          </a:xfrm>
-          <a:prstGeom prst="roundRect">
-            <a:avLst/>
-          </a:prstGeom>
-          <a:solidFill>
-            <a:srgbClr val="FFFFFF"/>
-          </a:solidFill>
-          <a:ln>
-            <a:noFill/>
-          </a:ln>
-          <a:effectLst/>
-        </p:spPr>
-        <p:style>
-          <a:lnRef idx="1">
-            <a:schemeClr val="accent1"/>
-          </a:lnRef>
-          <a:fillRef idx="3">
-            <a:schemeClr val="accent1"/>
-          </a:fillRef>
-          <a:effectRef idx="2">
-            <a:schemeClr val="accent1"/>
-          </a:effectRef>
-          <a:fontRef idx="minor">
-            <a:schemeClr val="lt1"/>
-          </a:fontRef>
-        </p:style>
-        <p:txBody>
-          <a:bodyPr rtlCol="0" anchor="ctr"/>
-          <a:lstStyle/>
-          <a:p>
-            <a:pPr algn="ctr"/>
-          </a:p>
-        </p:txBody>
-      </p:sp>
-      <p:sp>
-        <p:nvSpPr>
-          <p:cNvPr id="21" name="TextBox 20"/>
-          <p:cNvSpPr txBox="1"/>
-          <p:nvPr/>
-        </p:nvSpPr>
-        <p:spPr>
-          <a:xfrm>
-            <a:off x="8641080" y="2907792"/>
-            <a:ext cx="1188720" cy="256032"/>
-          </a:xfrm>
-          <a:prstGeom prst="rect">
-            <a:avLst/>
-          </a:prstGeom>
-          <a:noFill/>
-        </p:spPr>
-        <p:txBody>
-          <a:bodyPr wrap="square" anchor="t" lIns="0" rIns="0" tIns="0" bIns="0">
-            <a:spAutoFit/>
-          </a:bodyPr>
-          <a:lstStyle/>
-          <a:p>
-            <a:pPr algn="ctr">
-              <a:spcBef>
-                <a:spcPts val="0"/>
-              </a:spcBef>
-              <a:spcAft>
-                <a:spcPts val="400"/>
-              </a:spcAft>
-            </a:pPr>
-            <a:r>
-              <a:rPr sz="900" b="1">
-                <a:solidFill>
-                  <a:srgbClr val="5B6673"/>
-                </a:solidFill>
-                <a:latin typeface="Calibri"/>
-              </a:rPr>
-              <a:t>Audit</a:t>
-            </a:r>
-          </a:p>
-        </p:txBody>
-      </p:sp>
-      <p:sp>
-        <p:nvSpPr>
-          <p:cNvPr id="22" name="Rounded Rectangle 21"/>
-          <p:cNvSpPr/>
-          <p:nvPr/>
-        </p:nvSpPr>
-        <p:spPr>
-          <a:xfrm>
-            <a:off x="9921240" y="2834640"/>
-            <a:ext cx="1188720" cy="329184"/>
-          </a:xfrm>
-          <a:prstGeom prst="roundRect">
-            <a:avLst/>
-          </a:prstGeom>
-          <a:solidFill>
-            <a:srgbClr val="FFFFFF"/>
-          </a:solidFill>
-          <a:ln>
-            <a:noFill/>
-          </a:ln>
-          <a:effectLst/>
-        </p:spPr>
-        <p:style>
-          <a:lnRef idx="1">
-            <a:schemeClr val="accent1"/>
-          </a:lnRef>
-          <a:fillRef idx="3">
-            <a:schemeClr val="accent1"/>
-          </a:fillRef>
-          <a:effectRef idx="2">
-            <a:schemeClr val="accent1"/>
-          </a:effectRef>
-          <a:fontRef idx="minor">
-            <a:schemeClr val="lt1"/>
-          </a:fontRef>
-        </p:style>
-        <p:txBody>
-          <a:bodyPr rtlCol="0" anchor="ctr"/>
-          <a:lstStyle/>
-          <a:p>
-            <a:pPr algn="ctr"/>
-          </a:p>
-        </p:txBody>
-      </p:sp>
-      <p:sp>
-        <p:nvSpPr>
-          <p:cNvPr id="23" name="TextBox 22"/>
-          <p:cNvSpPr txBox="1"/>
-          <p:nvPr/>
-        </p:nvSpPr>
-        <p:spPr>
-          <a:xfrm>
-            <a:off x="9921240" y="2907792"/>
-            <a:ext cx="1188720" cy="256032"/>
-          </a:xfrm>
-          <a:prstGeom prst="rect">
-            <a:avLst/>
-          </a:prstGeom>
-          <a:noFill/>
-        </p:spPr>
-        <p:txBody>
-          <a:bodyPr wrap="square" anchor="t" lIns="0" rIns="0" tIns="0" bIns="0">
-            <a:spAutoFit/>
-          </a:bodyPr>
-          <a:lstStyle/>
-          <a:p>
-            <a:pPr algn="ctr">
-              <a:spcBef>
-                <a:spcPts val="0"/>
-              </a:spcBef>
-              <a:spcAft>
-                <a:spcPts val="400"/>
-              </a:spcAft>
-            </a:pPr>
-            <a:r>
-              <a:rPr sz="900" b="1">
-                <a:solidFill>
-                  <a:srgbClr val="5B6673"/>
-                </a:solidFill>
-                <a:latin typeface="Calibri"/>
-              </a:rPr>
-              <a:t>Graph</a:t>
-            </a:r>
-          </a:p>
-        </p:txBody>
-      </p:sp>
-      <p:sp>
-        <p:nvSpPr>
-          <p:cNvPr id="24" name="Rounded Rectangle 23"/>
-          <p:cNvSpPr/>
-          <p:nvPr/>
-        </p:nvSpPr>
-        <p:spPr>
-          <a:xfrm>
-            <a:off x="7360920" y="3291840"/>
-            <a:ext cx="3703320" cy="2139696"/>
-          </a:xfrm>
-          <a:prstGeom prst="roundRect">
-            <a:avLst/>
-          </a:prstGeom>
-          <a:solidFill>
-            <a:srgbClr val="FFFFFF"/>
-          </a:solidFill>
-          <a:ln w="12700">
-            <a:solidFill>
-              <a:srgbClr val="E9F0F9"/>
-            </a:solidFill>
-          </a:ln>
-          <a:effectLst/>
-        </p:spPr>
-        <p:style>
-          <a:lnRef idx="1">
-            <a:schemeClr val="accent1"/>
-          </a:lnRef>
-          <a:fillRef idx="3">
-            <a:schemeClr val="accent1"/>
-          </a:fillRef>
-          <a:effectRef idx="2">
-            <a:schemeClr val="accent1"/>
-          </a:effectRef>
-          <a:fontRef idx="minor">
-            <a:schemeClr val="lt1"/>
-          </a:fontRef>
-        </p:style>
-        <p:txBody>
-          <a:bodyPr rtlCol="0" anchor="ctr"/>
-          <a:lstStyle/>
-          <a:p>
-            <a:pPr algn="ctr"/>
-          </a:p>
-        </p:txBody>
-      </p:sp>
-      <p:sp>
-        <p:nvSpPr>
-          <p:cNvPr id="25" name="TextBox 24"/>
-          <p:cNvSpPr txBox="1"/>
-          <p:nvPr/>
-        </p:nvSpPr>
-        <p:spPr>
-          <a:xfrm>
-            <a:off x="7543800" y="3401568"/>
-            <a:ext cx="2560320" cy="274320"/>
-          </a:xfrm>
-          <a:prstGeom prst="rect">
-            <a:avLst/>
-          </a:prstGeom>
-          <a:noFill/>
-        </p:spPr>
-        <p:txBody>
-          <a:bodyPr wrap="square" anchor="t" lIns="0" rIns="0" tIns="0" bIns="0">
-            <a:spAutoFit/>
-          </a:bodyPr>
-          <a:lstStyle/>
+              <a:rPr sz="1200" b="1">
+                <a:solidFill>
+                  <a:srgbClr val="0F172A"/>
+                </a:solidFill>
+                <a:latin typeface="Calibri"/>
+              </a:rPr>
+              <a:t>Escalation with full handoff context</a:t>
+            </a:r>
+          </a:p>
           <a:p>
             <a:pPr algn="l">
               <a:spcBef>
@@ -9752,33 +9239,33 @@
               </a:spcAft>
             </a:pPr>
             <a:r>
-              <a:rPr sz="900" b="1">
-                <a:solidFill>
-                  <a:srgbClr val="0F172A"/>
-                </a:solidFill>
-                <a:latin typeface="Calibri"/>
-              </a:rPr>
-              <a:t>Card replacement · M-1001</a:t>
-            </a:r>
-          </a:p>
-        </p:txBody>
-      </p:sp>
-      <p:sp>
-        <p:nvSpPr>
-          <p:cNvPr id="26" name="Rounded Rectangle 25"/>
+              <a:rPr sz="1050" b="0">
+                <a:solidFill>
+                  <a:srgbClr val="5B6673"/>
+                </a:solidFill>
+                <a:latin typeface="Calibri"/>
+              </a:rPr>
+              <a:t>the specialist gets everything</a:t>
+            </a:r>
+          </a:p>
+        </p:txBody>
+      </p:sp>
+      <p:sp>
+        <p:nvSpPr>
+          <p:cNvPr id="14" name="Rounded Rectangle 13"/>
           <p:cNvSpPr/>
           <p:nvPr/>
         </p:nvSpPr>
         <p:spPr>
           <a:xfrm>
-            <a:off x="10149840" y="3401568"/>
-            <a:ext cx="777240" cy="256032"/>
+            <a:off x="8001000" y="5074920"/>
+            <a:ext cx="109728" cy="109728"/>
           </a:xfrm>
           <a:prstGeom prst="roundRect">
             <a:avLst/>
           </a:prstGeom>
           <a:solidFill>
-            <a:srgbClr val="B45309"/>
+            <a:srgbClr val="6D4FC4"/>
           </a:solidFill>
           <a:ln>
             <a:noFill/>
@@ -9809,56 +9296,14 @@
       </p:sp>
       <p:sp>
         <p:nvSpPr>
-          <p:cNvPr id="27" name="TextBox 26"/>
+          <p:cNvPr id="15" name="TextBox 14"/>
           <p:cNvSpPr txBox="1"/>
           <p:nvPr/>
         </p:nvSpPr>
         <p:spPr>
           <a:xfrm>
-            <a:off x="10149840" y="3438144"/>
-            <a:ext cx="777240" cy="219456"/>
-          </a:xfrm>
-          <a:prstGeom prst="rect">
-            <a:avLst/>
-          </a:prstGeom>
-          <a:noFill/>
-        </p:spPr>
-        <p:txBody>
-          <a:bodyPr wrap="square" anchor="t" lIns="0" rIns="0" tIns="0" bIns="0">
-            <a:spAutoFit/>
-          </a:bodyPr>
-          <a:lstStyle/>
-          <a:p>
-            <a:pPr algn="ctr">
-              <a:spcBef>
-                <a:spcPts val="0"/>
-              </a:spcBef>
-              <a:spcAft>
-                <a:spcPts val="400"/>
-              </a:spcAft>
-            </a:pPr>
-            <a:r>
-              <a:rPr sz="750" b="1">
-                <a:solidFill>
-                  <a:srgbClr val="FFFFFF"/>
-                </a:solidFill>
-                <a:latin typeface="Calibri"/>
-              </a:rPr>
-              <a:t>rolled back</a:t>
-            </a:r>
-          </a:p>
-        </p:txBody>
-      </p:sp>
-      <p:sp>
-        <p:nvSpPr>
-          <p:cNvPr id="28" name="TextBox 27"/>
-          <p:cNvSpPr txBox="1"/>
-          <p:nvPr/>
-        </p:nvSpPr>
-        <p:spPr>
-          <a:xfrm>
-            <a:off x="7589520" y="3822191"/>
-            <a:ext cx="3383280" cy="274320"/>
+            <a:off x="8275320" y="5038344"/>
+            <a:ext cx="3063240" cy="640080"/>
           </a:xfrm>
           <a:prstGeom prst="rect">
             <a:avLst/>
@@ -9880,38 +9325,15 @@
               </a:spcAft>
             </a:pPr>
             <a:r>
-              <a:rPr sz="900" b="1">
-                <a:solidFill>
-                  <a:srgbClr val="B45309"/>
-                </a:solidFill>
-                <a:latin typeface="Calibri"/>
-              </a:rPr>
-              <a:t>● block old card    ↩ compensated</a:t>
-            </a:r>
-          </a:p>
-        </p:txBody>
-      </p:sp>
-      <p:sp>
-        <p:nvSpPr>
-          <p:cNvPr id="29" name="TextBox 28"/>
-          <p:cNvSpPr txBox="1"/>
-          <p:nvPr/>
-        </p:nvSpPr>
-        <p:spPr>
-          <a:xfrm>
-            <a:off x="7589520" y="4187952"/>
-            <a:ext cx="3383280" cy="274320"/>
-          </a:xfrm>
-          <a:prstGeom prst="rect">
-            <a:avLst/>
-          </a:prstGeom>
-          <a:noFill/>
-        </p:spPr>
-        <p:txBody>
-          <a:bodyPr wrap="square" anchor="t" lIns="0" rIns="0" tIns="0" bIns="0">
-            <a:spAutoFit/>
-          </a:bodyPr>
-          <a:lstStyle/>
+              <a:rPr sz="1200" b="1">
+                <a:solidFill>
+                  <a:srgbClr val="0F172A"/>
+                </a:solidFill>
+                <a:latin typeface="Calibri"/>
+              </a:rPr>
+              <a:t>Durable cases + live audit / graph</a:t>
+            </a:r>
+          </a:p>
           <a:p>
             <a:pPr algn="l">
               <a:spcBef>
@@ -9922,27 +9344,27 @@
               </a:spcAft>
             </a:pPr>
             <a:r>
-              <a:rPr sz="900" b="1">
-                <a:solidFill>
-                  <a:srgbClr val="B45309"/>
-                </a:solidFill>
-                <a:latin typeface="Calibri"/>
-              </a:rPr>
-              <a:t>● charge fee    ↩ compensated</a:t>
-            </a:r>
-          </a:p>
-        </p:txBody>
-      </p:sp>
-      <p:sp>
-        <p:nvSpPr>
-          <p:cNvPr id="30" name="TextBox 29"/>
+              <a:rPr sz="1050" b="0">
+                <a:solidFill>
+                  <a:srgbClr val="5B6673"/>
+                </a:solidFill>
+                <a:latin typeface="Calibri"/>
+              </a:rPr>
+              <a:t>one screen, in real time</a:t>
+            </a:r>
+          </a:p>
+        </p:txBody>
+      </p:sp>
+      <p:sp>
+        <p:nvSpPr>
+          <p:cNvPr id="16" name="TextBox 15"/>
           <p:cNvSpPr txBox="1"/>
           <p:nvPr/>
         </p:nvSpPr>
         <p:spPr>
           <a:xfrm>
-            <a:off x="7589520" y="4553712"/>
-            <a:ext cx="3383280" cy="274320"/>
+            <a:off x="8275320" y="5943600"/>
+            <a:ext cx="3108960" cy="274320"/>
           </a:xfrm>
           <a:prstGeom prst="rect">
             <a:avLst/>
@@ -9964,27 +9386,27 @@
               </a:spcAft>
             </a:pPr>
             <a:r>
-              <a:rPr sz="900" b="1">
-                <a:solidFill>
-                  <a:srgbClr val="C0362C"/>
-                </a:solidFill>
-                <a:latin typeface="Calibri"/>
-              </a:rPr>
-              <a:t>✗ order new card — fails</a:t>
-            </a:r>
-          </a:p>
-        </p:txBody>
-      </p:sp>
-      <p:sp>
-        <p:nvSpPr>
-          <p:cNvPr id="31" name="TextBox 30"/>
+              <a:rPr sz="1000" b="0">
+                <a:solidFill>
+                  <a:srgbClr val="5B6673"/>
+                </a:solidFill>
+                <a:latin typeface="Calibri"/>
+              </a:rPr>
+              <a:t>Live capture of the running app</a:t>
+            </a:r>
+          </a:p>
+        </p:txBody>
+      </p:sp>
+      <p:sp>
+        <p:nvSpPr>
+          <p:cNvPr id="17" name="TextBox 16"/>
           <p:cNvSpPr txBox="1"/>
           <p:nvPr/>
         </p:nvSpPr>
         <p:spPr>
           <a:xfrm>
-            <a:off x="7589520" y="4919472"/>
-            <a:ext cx="3383280" cy="274320"/>
+            <a:off x="777240" y="6419088"/>
+            <a:ext cx="7315200" cy="274320"/>
           </a:xfrm>
           <a:prstGeom prst="rect">
             <a:avLst/>
@@ -10006,96 +9428,12 @@
               </a:spcAft>
             </a:pPr>
             <a:r>
-              <a:rPr sz="900" b="1">
+              <a:rPr sz="900" b="0">
                 <a:solidFill>
                   <a:srgbClr val="5B6673"/>
                 </a:solidFill>
                 <a:latin typeface="Calibri"/>
               </a:rPr>
-              <a:t>○ notify member</a:t>
-            </a:r>
-          </a:p>
-        </p:txBody>
-      </p:sp>
-      <p:sp>
-        <p:nvSpPr>
-          <p:cNvPr id="32" name="TextBox 31"/>
-          <p:cNvSpPr txBox="1"/>
-          <p:nvPr/>
-        </p:nvSpPr>
-        <p:spPr>
-          <a:xfrm>
-            <a:off x="822960" y="5806440"/>
-            <a:ext cx="10515600" cy="365760"/>
-          </a:xfrm>
-          <a:prstGeom prst="rect">
-            <a:avLst/>
-          </a:prstGeom>
-          <a:noFill/>
-        </p:spPr>
-        <p:txBody>
-          <a:bodyPr wrap="square" anchor="t" lIns="0" rIns="0" tIns="0" bIns="0">
-            <a:spAutoFit/>
-          </a:bodyPr>
-          <a:lstStyle/>
-          <a:p>
-            <a:pPr algn="ctr">
-              <a:spcBef>
-                <a:spcPts val="0"/>
-              </a:spcBef>
-              <a:spcAft>
-                <a:spcPts val="400"/>
-              </a:spcAft>
-            </a:pPr>
-            <a:r>
-              <a:rPr sz="1200" b="0">
-                <a:solidFill>
-                  <a:srgbClr val="5B6673"/>
-                </a:solidFill>
-                <a:latin typeface="Calibri"/>
-              </a:rPr>
-              <a:t>Members chat · underwriters approve in-line · analysts inspect the audit trail and Neo4j graph — one screen.</a:t>
-            </a:r>
-          </a:p>
-        </p:txBody>
-      </p:sp>
-      <p:sp>
-        <p:nvSpPr>
-          <p:cNvPr id="33" name="TextBox 32"/>
-          <p:cNvSpPr txBox="1"/>
-          <p:nvPr/>
-        </p:nvSpPr>
-        <p:spPr>
-          <a:xfrm>
-            <a:off x="777240" y="6419088"/>
-            <a:ext cx="7315200" cy="274320"/>
-          </a:xfrm>
-          <a:prstGeom prst="rect">
-            <a:avLst/>
-          </a:prstGeom>
-          <a:noFill/>
-        </p:spPr>
-        <p:txBody>
-          <a:bodyPr wrap="square" anchor="t" lIns="0" rIns="0" tIns="0" bIns="0">
-            <a:spAutoFit/>
-          </a:bodyPr>
-          <a:lstStyle/>
-          <a:p>
-            <a:pPr algn="l">
-              <a:spcBef>
-                <a:spcPts val="0"/>
-              </a:spcBef>
-              <a:spcAft>
-                <a:spcPts val="400"/>
-              </a:spcAft>
-            </a:pPr>
-            <a:r>
-              <a:rPr sz="900" b="0">
-                <a:solidFill>
-                  <a:srgbClr val="5B6673"/>
-                </a:solidFill>
-                <a:latin typeface="Calibri"/>
-              </a:rPr>
               <a:t>End-to-End Servicing Agent · CodeStreet 2026</a:t>
             </a:r>
           </a:p>
@@ -10103,7 +9441,7 @@
       </p:sp>
       <p:sp>
         <p:nvSpPr>
-          <p:cNvPr id="34" name="TextBox 33"/>
+          <p:cNvPr id="18" name="TextBox 17"/>
           <p:cNvSpPr txBox="1"/>
           <p:nvPr/>
         </p:nvSpPr>
@@ -14990,7 +14328,7 @@
                 </a:solidFill>
                 <a:latin typeface="Calibri"/>
               </a:rPr>
-              <a:t>90% baseline → 95%+ w/ LLM</a:t>
+              <a:t>90%  (n=20)</a:t>
             </a:r>
           </a:p>
         </p:txBody>
@@ -15032,7 +14370,7 @@
                 </a:solidFill>
                 <a:latin typeface="Calibri"/>
               </a:rPr>
-              <a:t>labeled eval set (deterministic)</a:t>
+              <a:t>labeled eval set · LLM target ≥95%</a:t>
             </a:r>
           </a:p>
         </p:txBody>
@@ -15118,7 +14456,7 @@
                 </a:solidFill>
                 <a:latin typeface="Calibri"/>
               </a:rPr>
-              <a:t>First-contact resolution (in-scope)</a:t>
+              <a:t>First-contact resolution</a:t>
             </a:r>
           </a:p>
         </p:txBody>
@@ -15160,7 +14498,7 @@
                 </a:solidFill>
                 <a:latin typeface="Calibri"/>
               </a:rPr>
-              <a:t>measured per run</a:t>
+              <a:t>80%  (12/15)</a:t>
             </a:r>
           </a:p>
         </p:txBody>
@@ -15202,7 +14540,7 @@
                 </a:solidFill>
                 <a:latin typeface="Calibri"/>
               </a:rPr>
-              <a:t>outcome check (deterministic)</a:t>
+              <a:t>multi-turn outcome check</a:t>
             </a:r>
           </a:p>
         </p:txBody>
@@ -15288,7 +14626,7 @@
                 </a:solidFill>
                 <a:latin typeface="Calibri"/>
               </a:rPr>
-              <a:t>Policy violations</a:t>
+              <a:t>Correct handling (resolve / safe-escalate)</a:t>
             </a:r>
           </a:p>
         </p:txBody>
@@ -15326,11 +14664,11 @@
             <a:r>
               <a:rPr sz="1350" b="1">
                 <a:solidFill>
-                  <a:srgbClr val="016FD0"/>
-                </a:solidFill>
-                <a:latin typeface="Calibri"/>
-              </a:rPr>
-              <a:t>0</a:t>
+                  <a:srgbClr val="059669"/>
+                </a:solidFill>
+                <a:latin typeface="Calibri"/>
+              </a:rPr>
+              <a:t>86.7%</a:t>
             </a:r>
           </a:p>
         </p:txBody>
@@ -15372,7 +14710,7 @@
                 </a:solidFill>
                 <a:latin typeface="Calibri"/>
               </a:rPr>
-              <a:t>never auto-approve over cap</a:t>
+              <a:t>outcome check, in-scope</a:t>
             </a:r>
           </a:p>
         </p:txBody>
@@ -15458,7 +14796,7 @@
                 </a:solidFill>
                 <a:latin typeface="Calibri"/>
               </a:rPr>
-              <a:t>Audit completeness &amp; integrity</a:t>
+              <a:t>Policy violations</a:t>
             </a:r>
           </a:p>
         </p:txBody>
@@ -15500,7 +14838,7 @@
                 </a:solidFill>
                 <a:latin typeface="Calibri"/>
               </a:rPr>
-              <a:t>100%</a:t>
+              <a:t>0</a:t>
             </a:r>
           </a:p>
         </p:txBody>
@@ -15542,7 +14880,7 @@
                 </a:solidFill>
                 <a:latin typeface="Calibri"/>
               </a:rPr>
-              <a:t>chain verification</a:t>
+              <a:t>engine caps enforced + verified</a:t>
             </a:r>
           </a:p>
         </p:txBody>
@@ -15628,7 +14966,7 @@
                 </a:solidFill>
                 <a:latin typeface="Calibri"/>
               </a:rPr>
-              <a:t>Response clarity</a:t>
+              <a:t>Audit integrity</a:t>
             </a:r>
           </a:p>
         </p:txBody>
@@ -15666,11 +15004,11 @@
             <a:r>
               <a:rPr sz="1350" b="1">
                 <a:solidFill>
-                  <a:srgbClr val="5B6673"/>
-                </a:solidFill>
-                <a:latin typeface="Calibri"/>
-              </a:rPr>
-              <a:t>LLM-judge rubric (1–5)</a:t>
+                  <a:srgbClr val="016FD0"/>
+                </a:solidFill>
+                <a:latin typeface="Calibri"/>
+              </a:rPr>
+              <a:t>100% intact</a:t>
             </a:r>
           </a:p>
         </p:txBody>
@@ -15712,7 +15050,7 @@
                 </a:solidFill>
                 <a:latin typeface="Calibri"/>
               </a:rPr>
-              <a:t>planned</a:t>
+              <a:t>hash-chain verification</a:t>
             </a:r>
           </a:p>
         </p:txBody>

</xml_diff>

<commit_message>
Slide 6: embed the real Neo4j audit graph (clean capture)
- Replace the hand-drawn hash-chain visual with a live-captured Neo4j audit
  graph showing policy-rule nodes (FEE-AUTO, LIMIT-CAP) linked via APPLIED_RULE
- Add a lighter screenshot_graph.cjs capture (fewer entries => readable graph)
  and the cropped ui_graph_panel.png
</commit_message>
<xml_diff>
--- a/deck/CodeStreet2026_Servicing_Agent.pptx
+++ b/deck/CodeStreet2026_Servicing_Agent.pptx
@@ -11285,18 +11285,18 @@
         </p:nvSpPr>
         <p:spPr>
           <a:xfrm>
-            <a:off x="7680960" y="2286000"/>
-            <a:ext cx="3291840" cy="658368"/>
+            <a:off x="7635240" y="2103120"/>
+            <a:ext cx="3749039" cy="3977639"/>
           </a:xfrm>
           <a:prstGeom prst="roundRect">
             <a:avLst/>
           </a:prstGeom>
           <a:solidFill>
-            <a:srgbClr val="E9F0F9"/>
+            <a:srgbClr val="FFFFFF"/>
           </a:solidFill>
-          <a:ln w="15875">
+          <a:ln w="12700">
             <a:solidFill>
-              <a:srgbClr val="6D4FC4"/>
+              <a:srgbClr val="016FD0"/>
             </a:solidFill>
           </a:ln>
           <a:effectLst/>
@@ -11323,16 +11323,40 @@
           </a:p>
         </p:txBody>
       </p:sp>
-      <p:sp>
-        <p:nvSpPr>
-          <p:cNvPr id="17" name="TextBox 16"/>
+      <p:pic>
+        <p:nvPicPr>
+          <p:cNvPr id="17" name="Picture 16" descr="ui_graph_panel.png"/>
+          <p:cNvPicPr>
+            <a:picLocks noChangeAspect="1"/>
+          </p:cNvPicPr>
+          <p:nvPr/>
+        </p:nvPicPr>
+        <p:blipFill>
+          <a:blip r:embed="rId2"/>
+          <a:stretch>
+            <a:fillRect/>
+          </a:stretch>
+        </p:blipFill>
+        <p:spPr>
+          <a:xfrm>
+            <a:off x="8138160" y="2240280"/>
+            <a:ext cx="2597307" cy="3611880"/>
+          </a:xfrm>
+          <a:prstGeom prst="rect">
+            <a:avLst/>
+          </a:prstGeom>
+        </p:spPr>
+      </p:pic>
+      <p:sp>
+        <p:nvSpPr>
+          <p:cNvPr id="18" name="TextBox 17"/>
           <p:cNvSpPr txBox="1"/>
           <p:nvPr/>
         </p:nvSpPr>
         <p:spPr>
           <a:xfrm>
-            <a:off x="7863840" y="2377440"/>
-            <a:ext cx="2926080" cy="457200"/>
+            <a:off x="7635240" y="5888736"/>
+            <a:ext cx="3749039" cy="274320"/>
           </a:xfrm>
           <a:prstGeom prst="rect">
             <a:avLst/>
@@ -11345,135 +11369,36 @@
           </a:bodyPr>
           <a:lstStyle/>
           <a:p>
-            <a:pPr algn="l">
-              <a:spcBef>
-                <a:spcPts val="0"/>
-              </a:spcBef>
-              <a:spcAft>
-                <a:spcPts val="400"/>
-              </a:spcAft>
-            </a:pPr>
-            <a:r>
-              <a:rPr sz="1300" b="1">
-                <a:solidFill>
-                  <a:srgbClr val="0F172A"/>
-                </a:solidFill>
-                <a:latin typeface="Calibri"/>
-              </a:rPr>
-              <a:t>#0 request</a:t>
-            </a:r>
-            <a:r>
-              <a:rPr sz="1000" b="0">
+            <a:pPr algn="ctr">
+              <a:spcBef>
+                <a:spcPts val="0"/>
+              </a:spcBef>
+              <a:spcAft>
+                <a:spcPts val="400"/>
+              </a:spcAft>
+            </a:pPr>
+            <a:r>
+              <a:rPr sz="900" b="0">
                 <a:solidFill>
                   <a:srgbClr val="5B6673"/>
                 </a:solidFill>
                 <a:latin typeface="Calibri"/>
               </a:rPr>
-              <a:t>   hash◄prev</a:t>
-            </a:r>
-          </a:p>
-        </p:txBody>
-      </p:sp>
-      <p:sp>
-        <p:nvSpPr>
-          <p:cNvPr id="18" name="Down Arrow 17"/>
-          <p:cNvSpPr/>
-          <p:nvPr/>
-        </p:nvSpPr>
-        <p:spPr>
-          <a:xfrm>
-            <a:off x="9144000" y="2944368"/>
-            <a:ext cx="182880" cy="201168"/>
-          </a:xfrm>
-          <a:prstGeom prst="downArrow">
-            <a:avLst/>
-          </a:prstGeom>
-          <a:solidFill>
-            <a:srgbClr val="016FD0"/>
-          </a:solidFill>
-          <a:ln>
-            <a:noFill/>
-          </a:ln>
-          <a:effectLst/>
-        </p:spPr>
-        <p:style>
-          <a:lnRef idx="1">
-            <a:schemeClr val="accent1"/>
-          </a:lnRef>
-          <a:fillRef idx="3">
-            <a:schemeClr val="accent1"/>
-          </a:fillRef>
-          <a:effectRef idx="2">
-            <a:schemeClr val="accent1"/>
-          </a:effectRef>
-          <a:fontRef idx="minor">
-            <a:schemeClr val="lt1"/>
-          </a:fontRef>
-        </p:style>
-        <p:txBody>
-          <a:bodyPr rtlCol="0" anchor="ctr"/>
-          <a:lstStyle/>
-          <a:p>
-            <a:pPr algn="ctr"/>
-          </a:p>
-        </p:txBody>
-      </p:sp>
-      <p:sp>
-        <p:nvSpPr>
-          <p:cNvPr id="19" name="Rounded Rectangle 18"/>
-          <p:cNvSpPr/>
-          <p:nvPr/>
-        </p:nvSpPr>
-        <p:spPr>
-          <a:xfrm>
-            <a:off x="7680960" y="3154680"/>
-            <a:ext cx="3291840" cy="658368"/>
-          </a:xfrm>
-          <a:prstGeom prst="roundRect">
-            <a:avLst/>
-          </a:prstGeom>
-          <a:solidFill>
-            <a:srgbClr val="E9F0F9"/>
-          </a:solidFill>
-          <a:ln w="15875">
-            <a:solidFill>
-              <a:srgbClr val="B45309"/>
-            </a:solidFill>
-          </a:ln>
-          <a:effectLst/>
-        </p:spPr>
-        <p:style>
-          <a:lnRef idx="1">
-            <a:schemeClr val="accent1"/>
-          </a:lnRef>
-          <a:fillRef idx="3">
-            <a:schemeClr val="accent1"/>
-          </a:fillRef>
-          <a:effectRef idx="2">
-            <a:schemeClr val="accent1"/>
-          </a:effectRef>
-          <a:fontRef idx="minor">
-            <a:schemeClr val="lt1"/>
-          </a:fontRef>
-        </p:style>
-        <p:txBody>
-          <a:bodyPr rtlCol="0" anchor="ctr"/>
-          <a:lstStyle/>
-          <a:p>
-            <a:pPr algn="ctr"/>
-          </a:p>
-        </p:txBody>
-      </p:sp>
-      <p:sp>
-        <p:nvSpPr>
-          <p:cNvPr id="20" name="TextBox 19"/>
+              <a:t>Live Neo4j graph — policy rules are nodes (APPLIED_RULE)</a:t>
+            </a:r>
+          </a:p>
+        </p:txBody>
+      </p:sp>
+      <p:sp>
+        <p:nvSpPr>
+          <p:cNvPr id="19" name="TextBox 18"/>
           <p:cNvSpPr txBox="1"/>
           <p:nvPr/>
         </p:nvSpPr>
         <p:spPr>
           <a:xfrm>
-            <a:off x="7863840" y="3246120"/>
-            <a:ext cx="2926080" cy="457200"/>
+            <a:off x="777240" y="6419088"/>
+            <a:ext cx="7315200" cy="274320"/>
           </a:xfrm>
           <a:prstGeom prst="rect">
             <a:avLst/>
@@ -11495,345 +11420,12 @@
               </a:spcAft>
             </a:pPr>
             <a:r>
-              <a:rPr sz="1300" b="1">
-                <a:solidFill>
-                  <a:srgbClr val="0F172A"/>
-                </a:solidFill>
-                <a:latin typeface="Calibri"/>
-              </a:rPr>
-              <a:t>#1 policy</a:t>
-            </a:r>
-            <a:r>
-              <a:rPr sz="1000" b="0">
+              <a:rPr sz="900" b="0">
                 <a:solidFill>
                   <a:srgbClr val="5B6673"/>
                 </a:solidFill>
                 <a:latin typeface="Calibri"/>
               </a:rPr>
-              <a:t>   hash◄prev</a:t>
-            </a:r>
-          </a:p>
-        </p:txBody>
-      </p:sp>
-      <p:sp>
-        <p:nvSpPr>
-          <p:cNvPr id="21" name="Down Arrow 20"/>
-          <p:cNvSpPr/>
-          <p:nvPr/>
-        </p:nvSpPr>
-        <p:spPr>
-          <a:xfrm>
-            <a:off x="9144000" y="3813048"/>
-            <a:ext cx="182880" cy="201168"/>
-          </a:xfrm>
-          <a:prstGeom prst="downArrow">
-            <a:avLst/>
-          </a:prstGeom>
-          <a:solidFill>
-            <a:srgbClr val="016FD0"/>
-          </a:solidFill>
-          <a:ln>
-            <a:noFill/>
-          </a:ln>
-          <a:effectLst/>
-        </p:spPr>
-        <p:style>
-          <a:lnRef idx="1">
-            <a:schemeClr val="accent1"/>
-          </a:lnRef>
-          <a:fillRef idx="3">
-            <a:schemeClr val="accent1"/>
-          </a:fillRef>
-          <a:effectRef idx="2">
-            <a:schemeClr val="accent1"/>
-          </a:effectRef>
-          <a:fontRef idx="minor">
-            <a:schemeClr val="lt1"/>
-          </a:fontRef>
-        </p:style>
-        <p:txBody>
-          <a:bodyPr rtlCol="0" anchor="ctr"/>
-          <a:lstStyle/>
-          <a:p>
-            <a:pPr algn="ctr"/>
-          </a:p>
-        </p:txBody>
-      </p:sp>
-      <p:sp>
-        <p:nvSpPr>
-          <p:cNvPr id="22" name="Rounded Rectangle 21"/>
-          <p:cNvSpPr/>
-          <p:nvPr/>
-        </p:nvSpPr>
-        <p:spPr>
-          <a:xfrm>
-            <a:off x="7680960" y="4023360"/>
-            <a:ext cx="3291840" cy="658368"/>
-          </a:xfrm>
-          <a:prstGeom prst="roundRect">
-            <a:avLst/>
-          </a:prstGeom>
-          <a:solidFill>
-            <a:srgbClr val="E9F0F9"/>
-          </a:solidFill>
-          <a:ln w="15875">
-            <a:solidFill>
-              <a:srgbClr val="059669"/>
-            </a:solidFill>
-          </a:ln>
-          <a:effectLst/>
-        </p:spPr>
-        <p:style>
-          <a:lnRef idx="1">
-            <a:schemeClr val="accent1"/>
-          </a:lnRef>
-          <a:fillRef idx="3">
-            <a:schemeClr val="accent1"/>
-          </a:fillRef>
-          <a:effectRef idx="2">
-            <a:schemeClr val="accent1"/>
-          </a:effectRef>
-          <a:fontRef idx="minor">
-            <a:schemeClr val="lt1"/>
-          </a:fontRef>
-        </p:style>
-        <p:txBody>
-          <a:bodyPr rtlCol="0" anchor="ctr"/>
-          <a:lstStyle/>
-          <a:p>
-            <a:pPr algn="ctr"/>
-          </a:p>
-        </p:txBody>
-      </p:sp>
-      <p:sp>
-        <p:nvSpPr>
-          <p:cNvPr id="23" name="TextBox 22"/>
-          <p:cNvSpPr txBox="1"/>
-          <p:nvPr/>
-        </p:nvSpPr>
-        <p:spPr>
-          <a:xfrm>
-            <a:off x="7863840" y="4114800"/>
-            <a:ext cx="2926080" cy="457200"/>
-          </a:xfrm>
-          <a:prstGeom prst="rect">
-            <a:avLst/>
-          </a:prstGeom>
-          <a:noFill/>
-        </p:spPr>
-        <p:txBody>
-          <a:bodyPr wrap="square" anchor="t" lIns="0" rIns="0" tIns="0" bIns="0">
-            <a:spAutoFit/>
-          </a:bodyPr>
-          <a:lstStyle/>
-          <a:p>
-            <a:pPr algn="l">
-              <a:spcBef>
-                <a:spcPts val="0"/>
-              </a:spcBef>
-              <a:spcAft>
-                <a:spcPts val="400"/>
-              </a:spcAft>
-            </a:pPr>
-            <a:r>
-              <a:rPr sz="1300" b="1">
-                <a:solidFill>
-                  <a:srgbClr val="0F172A"/>
-                </a:solidFill>
-                <a:latin typeface="Calibri"/>
-              </a:rPr>
-              <a:t>#2 backend</a:t>
-            </a:r>
-            <a:r>
-              <a:rPr sz="1000" b="0">
-                <a:solidFill>
-                  <a:srgbClr val="5B6673"/>
-                </a:solidFill>
-                <a:latin typeface="Calibri"/>
-              </a:rPr>
-              <a:t>   hash◄prev</a:t>
-            </a:r>
-          </a:p>
-        </p:txBody>
-      </p:sp>
-      <p:sp>
-        <p:nvSpPr>
-          <p:cNvPr id="24" name="Down Arrow 23"/>
-          <p:cNvSpPr/>
-          <p:nvPr/>
-        </p:nvSpPr>
-        <p:spPr>
-          <a:xfrm>
-            <a:off x="9144000" y="4681728"/>
-            <a:ext cx="182880" cy="201168"/>
-          </a:xfrm>
-          <a:prstGeom prst="downArrow">
-            <a:avLst/>
-          </a:prstGeom>
-          <a:solidFill>
-            <a:srgbClr val="016FD0"/>
-          </a:solidFill>
-          <a:ln>
-            <a:noFill/>
-          </a:ln>
-          <a:effectLst/>
-        </p:spPr>
-        <p:style>
-          <a:lnRef idx="1">
-            <a:schemeClr val="accent1"/>
-          </a:lnRef>
-          <a:fillRef idx="3">
-            <a:schemeClr val="accent1"/>
-          </a:fillRef>
-          <a:effectRef idx="2">
-            <a:schemeClr val="accent1"/>
-          </a:effectRef>
-          <a:fontRef idx="minor">
-            <a:schemeClr val="lt1"/>
-          </a:fontRef>
-        </p:style>
-        <p:txBody>
-          <a:bodyPr rtlCol="0" anchor="ctr"/>
-          <a:lstStyle/>
-          <a:p>
-            <a:pPr algn="ctr"/>
-          </a:p>
-        </p:txBody>
-      </p:sp>
-      <p:sp>
-        <p:nvSpPr>
-          <p:cNvPr id="25" name="Rounded Rectangle 24"/>
-          <p:cNvSpPr/>
-          <p:nvPr/>
-        </p:nvSpPr>
-        <p:spPr>
-          <a:xfrm>
-            <a:off x="7680960" y="4892040"/>
-            <a:ext cx="3291840" cy="658368"/>
-          </a:xfrm>
-          <a:prstGeom prst="roundRect">
-            <a:avLst/>
-          </a:prstGeom>
-          <a:solidFill>
-            <a:srgbClr val="E9F0F9"/>
-          </a:solidFill>
-          <a:ln w="15875">
-            <a:solidFill>
-              <a:srgbClr val="016FD0"/>
-            </a:solidFill>
-          </a:ln>
-          <a:effectLst/>
-        </p:spPr>
-        <p:style>
-          <a:lnRef idx="1">
-            <a:schemeClr val="accent1"/>
-          </a:lnRef>
-          <a:fillRef idx="3">
-            <a:schemeClr val="accent1"/>
-          </a:fillRef>
-          <a:effectRef idx="2">
-            <a:schemeClr val="accent1"/>
-          </a:effectRef>
-          <a:fontRef idx="minor">
-            <a:schemeClr val="lt1"/>
-          </a:fontRef>
-        </p:style>
-        <p:txBody>
-          <a:bodyPr rtlCol="0" anchor="ctr"/>
-          <a:lstStyle/>
-          <a:p>
-            <a:pPr algn="ctr"/>
-          </a:p>
-        </p:txBody>
-      </p:sp>
-      <p:sp>
-        <p:nvSpPr>
-          <p:cNvPr id="26" name="TextBox 25"/>
-          <p:cNvSpPr txBox="1"/>
-          <p:nvPr/>
-        </p:nvSpPr>
-        <p:spPr>
-          <a:xfrm>
-            <a:off x="7863840" y="4983479"/>
-            <a:ext cx="2926080" cy="457200"/>
-          </a:xfrm>
-          <a:prstGeom prst="rect">
-            <a:avLst/>
-          </a:prstGeom>
-          <a:noFill/>
-        </p:spPr>
-        <p:txBody>
-          <a:bodyPr wrap="square" anchor="t" lIns="0" rIns="0" tIns="0" bIns="0">
-            <a:spAutoFit/>
-          </a:bodyPr>
-          <a:lstStyle/>
-          <a:p>
-            <a:pPr algn="l">
-              <a:spcBef>
-                <a:spcPts val="0"/>
-              </a:spcBef>
-              <a:spcAft>
-                <a:spcPts val="400"/>
-              </a:spcAft>
-            </a:pPr>
-            <a:r>
-              <a:rPr sz="1300" b="1">
-                <a:solidFill>
-                  <a:srgbClr val="0F172A"/>
-                </a:solidFill>
-                <a:latin typeface="Calibri"/>
-              </a:rPr>
-              <a:t>#3 agent</a:t>
-            </a:r>
-            <a:r>
-              <a:rPr sz="1000" b="0">
-                <a:solidFill>
-                  <a:srgbClr val="5B6673"/>
-                </a:solidFill>
-                <a:latin typeface="Calibri"/>
-              </a:rPr>
-              <a:t>   hash◄prev</a:t>
-            </a:r>
-          </a:p>
-        </p:txBody>
-      </p:sp>
-      <p:sp>
-        <p:nvSpPr>
-          <p:cNvPr id="27" name="TextBox 26"/>
-          <p:cNvSpPr txBox="1"/>
-          <p:nvPr/>
-        </p:nvSpPr>
-        <p:spPr>
-          <a:xfrm>
-            <a:off x="777240" y="6419088"/>
-            <a:ext cx="7315200" cy="274320"/>
-          </a:xfrm>
-          <a:prstGeom prst="rect">
-            <a:avLst/>
-          </a:prstGeom>
-          <a:noFill/>
-        </p:spPr>
-        <p:txBody>
-          <a:bodyPr wrap="square" anchor="t" lIns="0" rIns="0" tIns="0" bIns="0">
-            <a:spAutoFit/>
-          </a:bodyPr>
-          <a:lstStyle/>
-          <a:p>
-            <a:pPr algn="l">
-              <a:spcBef>
-                <a:spcPts val="0"/>
-              </a:spcBef>
-              <a:spcAft>
-                <a:spcPts val="400"/>
-              </a:spcAft>
-            </a:pPr>
-            <a:r>
-              <a:rPr sz="900" b="0">
-                <a:solidFill>
-                  <a:srgbClr val="5B6673"/>
-                </a:solidFill>
-                <a:latin typeface="Calibri"/>
-              </a:rPr>
               <a:t>End-to-End Servicing Agent · CodeStreet 2026</a:t>
             </a:r>
           </a:p>
@@ -11841,7 +11433,7 @@
       </p:sp>
       <p:sp>
         <p:nvSpPr>
-          <p:cNvPr id="28" name="TextBox 27"/>
+          <p:cNvPr id="20" name="TextBox 19"/>
           <p:cNvSpPr txBox="1"/>
           <p:nvPr/>
         </p:nvSpPr>

</xml_diff>

<commit_message>
Timeline audit graph + theme-alignment deck fixes
- GraphView: replace force layout with a sequence timeline — entries top-down
  in seq order (NEXT spine), actors/member/session in columns, policy rules
  right-aligned to the decision that fired them; only NEXT/APPLIED_RULE labeled
- Evals: measure escalation handoff completeness (brief names 'quality of
  human escalation handoffs') — 100% carry summary+reason+context
- Deck: handoff-completeness row on metrics; slide 6 header echoes 'verifiable';
  title slide gains demo-video + repo link line; fresh timeline graph capture
</commit_message>
<xml_diff>
--- a/deck/CodeStreet2026_Servicing_Agent.pptx
+++ b/deck/CodeStreet2026_Servicing_Agent.pptx
@@ -3514,6 +3514,75 @@
           </a:p>
         </p:txBody>
       </p:sp>
+      <p:sp>
+        <p:nvSpPr>
+          <p:cNvPr id="10" name="TextBox 9"/>
+          <p:cNvSpPr txBox="1"/>
+          <p:nvPr/>
+        </p:nvSpPr>
+        <p:spPr>
+          <a:xfrm>
+            <a:off x="822960" y="5897880"/>
+            <a:ext cx="10058400" cy="457200"/>
+          </a:xfrm>
+          <a:prstGeom prst="rect">
+            <a:avLst/>
+          </a:prstGeom>
+          <a:noFill/>
+        </p:spPr>
+        <p:txBody>
+          <a:bodyPr wrap="square" anchor="t" lIns="0" rIns="0" tIns="0" bIns="0">
+            <a:spAutoFit/>
+          </a:bodyPr>
+          <a:lstStyle/>
+          <a:p>
+            <a:pPr algn="l">
+              <a:spcBef>
+                <a:spcPts val="0"/>
+              </a:spcBef>
+              <a:spcAft>
+                <a:spcPts val="400"/>
+              </a:spcAft>
+            </a:pPr>
+            <a:r>
+              <a:rPr sz="1400" b="0">
+                <a:solidFill>
+                  <a:srgbClr val="5B6673"/>
+                </a:solidFill>
+                <a:latin typeface="Calibri"/>
+              </a:rPr>
+              <a:t>Demo video:  </a:t>
+            </a:r>
+            <a:r>
+              <a:rPr sz="1400" b="1">
+                <a:solidFill>
+                  <a:srgbClr val="016FD0"/>
+                </a:solidFill>
+                <a:latin typeface="Calibri"/>
+              </a:rPr>
+              <a:t>&lt;link&gt;</a:t>
+            </a:r>
+            <a:r>
+              <a:rPr sz="1400" b="0">
+                <a:solidFill>
+                  <a:srgbClr val="5B6673"/>
+                </a:solidFill>
+                <a:latin typeface="Calibri"/>
+              </a:rPr>
+              <a:t>      Repo:  </a:t>
+            </a:r>
+            <a:r>
+              <a:rPr sz="1400" b="1">
+                <a:solidFill>
+                  <a:srgbClr val="016FD0"/>
+                </a:solidFill>
+                <a:latin typeface="Calibri"/>
+              </a:rPr>
+              <a:t>github.com/VaibhavDangaich/Codestreet_2026</a:t>
+            </a:r>
+          </a:p>
+        </p:txBody>
+      </p:sp>
     </p:spTree>
   </p:cSld>
   <p:clrMapOvr>
@@ -10797,7 +10866,7 @@
                 </a:solidFill>
                 <a:latin typeface="Calibri"/>
               </a:rPr>
-              <a:t>Tamper-evident audit trail — trust by architecture</a:t>
+              <a:t>A verifiable, tamper-evident audit trail</a:t>
             </a:r>
           </a:p>
         </p:txBody>
@@ -13891,7 +13960,7 @@
         </p:nvSpPr>
         <p:spPr>
           <a:xfrm>
-            <a:off x="5852160" y="2724912"/>
+            <a:off x="5852160" y="2706624"/>
             <a:ext cx="2743200" cy="365760"/>
           </a:xfrm>
           <a:prstGeom prst="rect">
@@ -13914,7 +13983,7 @@
               </a:spcAft>
             </a:pPr>
             <a:r>
-              <a:rPr sz="1350" b="1">
+              <a:rPr sz="1300" b="1">
                 <a:solidFill>
                   <a:srgbClr val="059669"/>
                 </a:solidFill>
@@ -13933,7 +14002,7 @@
         </p:nvSpPr>
         <p:spPr>
           <a:xfrm>
-            <a:off x="8595360" y="2724912"/>
+            <a:off x="8595360" y="2706624"/>
             <a:ext cx="2743200" cy="365760"/>
           </a:xfrm>
           <a:prstGeom prst="rect">
@@ -13956,7 +14025,7 @@
               </a:spcAft>
             </a:pPr>
             <a:r>
-              <a:rPr sz="1250" b="0">
+              <a:rPr sz="1200" b="0">
                 <a:solidFill>
                   <a:srgbClr val="5B6673"/>
                 </a:solidFill>
@@ -13975,7 +14044,7 @@
         </p:nvSpPr>
         <p:spPr>
           <a:xfrm>
-            <a:off x="822960" y="3172968"/>
+            <a:off x="822960" y="3118104"/>
             <a:ext cx="10515600" cy="566928"/>
           </a:xfrm>
           <a:prstGeom prst="rect">
@@ -14019,7 +14088,7 @@
         </p:nvSpPr>
         <p:spPr>
           <a:xfrm>
-            <a:off x="1005840" y="3291840"/>
+            <a:off x="1005840" y="3236976"/>
             <a:ext cx="4754880" cy="365760"/>
           </a:xfrm>
           <a:prstGeom prst="rect">
@@ -14061,7 +14130,7 @@
         </p:nvSpPr>
         <p:spPr>
           <a:xfrm>
-            <a:off x="5852160" y="3291840"/>
+            <a:off x="5852160" y="3218688"/>
             <a:ext cx="2743200" cy="365760"/>
           </a:xfrm>
           <a:prstGeom prst="rect">
@@ -14084,7 +14153,7 @@
               </a:spcAft>
             </a:pPr>
             <a:r>
-              <a:rPr sz="1350" b="1">
+              <a:rPr sz="1300" b="1">
                 <a:solidFill>
                   <a:srgbClr val="059669"/>
                 </a:solidFill>
@@ -14103,7 +14172,7 @@
         </p:nvSpPr>
         <p:spPr>
           <a:xfrm>
-            <a:off x="8595360" y="3291840"/>
+            <a:off x="8595360" y="3218688"/>
             <a:ext cx="2743200" cy="365760"/>
           </a:xfrm>
           <a:prstGeom prst="rect">
@@ -14126,7 +14195,7 @@
               </a:spcAft>
             </a:pPr>
             <a:r>
-              <a:rPr sz="1250" b="0">
+              <a:rPr sz="1200" b="0">
                 <a:solidFill>
                   <a:srgbClr val="5B6673"/>
                 </a:solidFill>
@@ -14145,7 +14214,7 @@
         </p:nvSpPr>
         <p:spPr>
           <a:xfrm>
-            <a:off x="822960" y="3739896"/>
+            <a:off x="822960" y="3630168"/>
             <a:ext cx="10515600" cy="566928"/>
           </a:xfrm>
           <a:prstGeom prst="rect">
@@ -14189,7 +14258,7 @@
         </p:nvSpPr>
         <p:spPr>
           <a:xfrm>
-            <a:off x="1005840" y="3858768"/>
+            <a:off x="1005840" y="3749040"/>
             <a:ext cx="4754880" cy="365760"/>
           </a:xfrm>
           <a:prstGeom prst="rect">
@@ -14231,7 +14300,7 @@
         </p:nvSpPr>
         <p:spPr>
           <a:xfrm>
-            <a:off x="5852160" y="3858768"/>
+            <a:off x="5852160" y="3730752"/>
             <a:ext cx="2743200" cy="365760"/>
           </a:xfrm>
           <a:prstGeom prst="rect">
@@ -14254,7 +14323,7 @@
               </a:spcAft>
             </a:pPr>
             <a:r>
-              <a:rPr sz="1350" b="1">
+              <a:rPr sz="1300" b="1">
                 <a:solidFill>
                   <a:srgbClr val="059669"/>
                 </a:solidFill>
@@ -14273,7 +14342,7 @@
         </p:nvSpPr>
         <p:spPr>
           <a:xfrm>
-            <a:off x="8595360" y="3858768"/>
+            <a:off x="8595360" y="3730752"/>
             <a:ext cx="2743200" cy="365760"/>
           </a:xfrm>
           <a:prstGeom prst="rect">
@@ -14296,7 +14365,7 @@
               </a:spcAft>
             </a:pPr>
             <a:r>
-              <a:rPr sz="1250" b="0">
+              <a:rPr sz="1200" b="0">
                 <a:solidFill>
                   <a:srgbClr val="5B6673"/>
                 </a:solidFill>
@@ -14315,7 +14384,7 @@
         </p:nvSpPr>
         <p:spPr>
           <a:xfrm>
-            <a:off x="822960" y="4306824"/>
+            <a:off x="822960" y="4142232"/>
             <a:ext cx="10515600" cy="566928"/>
           </a:xfrm>
           <a:prstGeom prst="rect">
@@ -14359,7 +14428,7 @@
         </p:nvSpPr>
         <p:spPr>
           <a:xfrm>
-            <a:off x="1005840" y="4425696"/>
+            <a:off x="1005840" y="4261104"/>
             <a:ext cx="4754880" cy="365760"/>
           </a:xfrm>
           <a:prstGeom prst="rect">
@@ -14388,7 +14457,7 @@
                 </a:solidFill>
                 <a:latin typeface="Calibri"/>
               </a:rPr>
-              <a:t>Policy violations</a:t>
+              <a:t>Escalation handoff completeness</a:t>
             </a:r>
           </a:p>
         </p:txBody>
@@ -14401,7 +14470,7 @@
         </p:nvSpPr>
         <p:spPr>
           <a:xfrm>
-            <a:off x="5852160" y="4425696"/>
+            <a:off x="5852160" y="4242816"/>
             <a:ext cx="2743200" cy="365760"/>
           </a:xfrm>
           <a:prstGeom prst="rect">
@@ -14424,13 +14493,13 @@
               </a:spcAft>
             </a:pPr>
             <a:r>
-              <a:rPr sz="1350" b="1">
-                <a:solidFill>
-                  <a:srgbClr val="016FD0"/>
-                </a:solidFill>
-                <a:latin typeface="Calibri"/>
-              </a:rPr>
-              <a:t>0</a:t>
+              <a:rPr sz="1300" b="1">
+                <a:solidFill>
+                  <a:srgbClr val="059669"/>
+                </a:solidFill>
+                <a:latin typeface="Calibri"/>
+              </a:rPr>
+              <a:t>100%</a:t>
             </a:r>
           </a:p>
         </p:txBody>
@@ -14443,7 +14512,7 @@
         </p:nvSpPr>
         <p:spPr>
           <a:xfrm>
-            <a:off x="8595360" y="4425696"/>
+            <a:off x="8595360" y="4242816"/>
             <a:ext cx="2743200" cy="365760"/>
           </a:xfrm>
           <a:prstGeom prst="rect">
@@ -14466,13 +14535,13 @@
               </a:spcAft>
             </a:pPr>
             <a:r>
-              <a:rPr sz="1250" b="0">
+              <a:rPr sz="1200" b="0">
                 <a:solidFill>
                   <a:srgbClr val="5B6673"/>
                 </a:solidFill>
                 <a:latin typeface="Calibri"/>
               </a:rPr>
-              <a:t>engine caps enforced + verified</a:t>
+              <a:t>summary + reason + context present</a:t>
             </a:r>
           </a:p>
         </p:txBody>
@@ -14485,7 +14554,7 @@
         </p:nvSpPr>
         <p:spPr>
           <a:xfrm>
-            <a:off x="822960" y="4873752"/>
+            <a:off x="822960" y="4654296"/>
             <a:ext cx="10515600" cy="566928"/>
           </a:xfrm>
           <a:prstGeom prst="rect">
@@ -14529,7 +14598,7 @@
         </p:nvSpPr>
         <p:spPr>
           <a:xfrm>
-            <a:off x="1005840" y="4992624"/>
+            <a:off x="1005840" y="4773168"/>
             <a:ext cx="4754880" cy="365760"/>
           </a:xfrm>
           <a:prstGeom prst="rect">
@@ -14558,7 +14627,7 @@
                 </a:solidFill>
                 <a:latin typeface="Calibri"/>
               </a:rPr>
-              <a:t>Audit integrity</a:t>
+              <a:t>Policy violations</a:t>
             </a:r>
           </a:p>
         </p:txBody>
@@ -14571,7 +14640,7 @@
         </p:nvSpPr>
         <p:spPr>
           <a:xfrm>
-            <a:off x="5852160" y="4992624"/>
+            <a:off x="5852160" y="4754880"/>
             <a:ext cx="2743200" cy="365760"/>
           </a:xfrm>
           <a:prstGeom prst="rect">
@@ -14594,13 +14663,13 @@
               </a:spcAft>
             </a:pPr>
             <a:r>
-              <a:rPr sz="1350" b="1">
+              <a:rPr sz="1300" b="1">
                 <a:solidFill>
                   <a:srgbClr val="016FD0"/>
                 </a:solidFill>
                 <a:latin typeface="Calibri"/>
               </a:rPr>
-              <a:t>100% intact</a:t>
+              <a:t>0</a:t>
             </a:r>
           </a:p>
         </p:txBody>
@@ -14613,7 +14682,7 @@
         </p:nvSpPr>
         <p:spPr>
           <a:xfrm>
-            <a:off x="8595360" y="4992624"/>
+            <a:off x="8595360" y="4754880"/>
             <a:ext cx="2743200" cy="365760"/>
           </a:xfrm>
           <a:prstGeom prst="rect">
@@ -14636,27 +14705,71 @@
               </a:spcAft>
             </a:pPr>
             <a:r>
-              <a:rPr sz="1250" b="0">
+              <a:rPr sz="1200" b="0">
                 <a:solidFill>
                   <a:srgbClr val="5B6673"/>
                 </a:solidFill>
                 <a:latin typeface="Calibri"/>
               </a:rPr>
-              <a:t>hash-chain verification</a:t>
-            </a:r>
-          </a:p>
-        </p:txBody>
-      </p:sp>
-      <p:sp>
-        <p:nvSpPr>
-          <p:cNvPr id="30" name="TextBox 29"/>
+              <a:t>engine caps enforced + verified</a:t>
+            </a:r>
+          </a:p>
+        </p:txBody>
+      </p:sp>
+      <p:sp>
+        <p:nvSpPr>
+          <p:cNvPr id="30" name="Rectangle 29"/>
+          <p:cNvSpPr/>
+          <p:nvPr/>
+        </p:nvSpPr>
+        <p:spPr>
+          <a:xfrm>
+            <a:off x="822960" y="5166360"/>
+            <a:ext cx="10515600" cy="566928"/>
+          </a:xfrm>
+          <a:prstGeom prst="rect">
+            <a:avLst/>
+          </a:prstGeom>
+          <a:solidFill>
+            <a:srgbClr val="F6F9FD"/>
+          </a:solidFill>
+          <a:ln>
+            <a:noFill/>
+          </a:ln>
+          <a:effectLst/>
+        </p:spPr>
+        <p:style>
+          <a:lnRef idx="1">
+            <a:schemeClr val="accent1"/>
+          </a:lnRef>
+          <a:fillRef idx="3">
+            <a:schemeClr val="accent1"/>
+          </a:fillRef>
+          <a:effectRef idx="2">
+            <a:schemeClr val="accent1"/>
+          </a:effectRef>
+          <a:fontRef idx="minor">
+            <a:schemeClr val="lt1"/>
+          </a:fontRef>
+        </p:style>
+        <p:txBody>
+          <a:bodyPr rtlCol="0" anchor="ctr"/>
+          <a:lstStyle/>
+          <a:p>
+            <a:pPr algn="ctr"/>
+          </a:p>
+        </p:txBody>
+      </p:sp>
+      <p:sp>
+        <p:nvSpPr>
+          <p:cNvPr id="31" name="TextBox 30"/>
           <p:cNvSpPr txBox="1"/>
           <p:nvPr/>
         </p:nvSpPr>
         <p:spPr>
           <a:xfrm>
-            <a:off x="822960" y="5623560"/>
-            <a:ext cx="10515600" cy="822960"/>
+            <a:off x="1005840" y="5285232"/>
+            <a:ext cx="4754880" cy="365760"/>
           </a:xfrm>
           <a:prstGeom prst="rect">
             <a:avLst/>
@@ -14678,36 +14791,27 @@
               </a:spcAft>
             </a:pPr>
             <a:r>
-              <a:rPr sz="1300" b="1">
+              <a:rPr sz="1350" b="1">
                 <a:solidFill>
                   <a:srgbClr val="0F172A"/>
                 </a:solidFill>
                 <a:latin typeface="Calibri"/>
               </a:rPr>
-              <a:t>We report TRUE resolution + escalation rate — not just deflection. </a:t>
-            </a:r>
-            <a:r>
-              <a:rPr sz="1300" b="0">
-                <a:solidFill>
-                  <a:srgbClr val="5B6673"/>
-                </a:solidFill>
-                <a:latin typeface="Calibri"/>
-              </a:rPr>
-              <a:t>Financial-services deflection is realistically 25–45%; finance teams target &lt;1% error, because one wrong answer is a compliance event.</a:t>
-            </a:r>
-          </a:p>
-        </p:txBody>
-      </p:sp>
-      <p:sp>
-        <p:nvSpPr>
-          <p:cNvPr id="31" name="TextBox 30"/>
+              <a:t>Audit integrity</a:t>
+            </a:r>
+          </a:p>
+        </p:txBody>
+      </p:sp>
+      <p:sp>
+        <p:nvSpPr>
+          <p:cNvPr id="32" name="TextBox 31"/>
           <p:cNvSpPr txBox="1"/>
           <p:nvPr/>
         </p:nvSpPr>
         <p:spPr>
           <a:xfrm>
-            <a:off x="777240" y="6419088"/>
-            <a:ext cx="7315200" cy="274320"/>
+            <a:off x="5852160" y="5266944"/>
+            <a:ext cx="2743200" cy="365760"/>
           </a:xfrm>
           <a:prstGeom prst="rect">
             <a:avLst/>
@@ -14729,6 +14833,141 @@
               </a:spcAft>
             </a:pPr>
             <a:r>
+              <a:rPr sz="1300" b="1">
+                <a:solidFill>
+                  <a:srgbClr val="016FD0"/>
+                </a:solidFill>
+                <a:latin typeface="Calibri"/>
+              </a:rPr>
+              <a:t>100% intact</a:t>
+            </a:r>
+          </a:p>
+        </p:txBody>
+      </p:sp>
+      <p:sp>
+        <p:nvSpPr>
+          <p:cNvPr id="33" name="TextBox 32"/>
+          <p:cNvSpPr txBox="1"/>
+          <p:nvPr/>
+        </p:nvSpPr>
+        <p:spPr>
+          <a:xfrm>
+            <a:off x="8595360" y="5266944"/>
+            <a:ext cx="2743200" cy="365760"/>
+          </a:xfrm>
+          <a:prstGeom prst="rect">
+            <a:avLst/>
+          </a:prstGeom>
+          <a:noFill/>
+        </p:spPr>
+        <p:txBody>
+          <a:bodyPr wrap="square" anchor="t" lIns="0" rIns="0" tIns="0" bIns="0">
+            <a:spAutoFit/>
+          </a:bodyPr>
+          <a:lstStyle/>
+          <a:p>
+            <a:pPr algn="l">
+              <a:spcBef>
+                <a:spcPts val="0"/>
+              </a:spcBef>
+              <a:spcAft>
+                <a:spcPts val="400"/>
+              </a:spcAft>
+            </a:pPr>
+            <a:r>
+              <a:rPr sz="1200" b="0">
+                <a:solidFill>
+                  <a:srgbClr val="5B6673"/>
+                </a:solidFill>
+                <a:latin typeface="Calibri"/>
+              </a:rPr>
+              <a:t>hash-chain verification</a:t>
+            </a:r>
+          </a:p>
+        </p:txBody>
+      </p:sp>
+      <p:sp>
+        <p:nvSpPr>
+          <p:cNvPr id="34" name="TextBox 33"/>
+          <p:cNvSpPr txBox="1"/>
+          <p:nvPr/>
+        </p:nvSpPr>
+        <p:spPr>
+          <a:xfrm>
+            <a:off x="822960" y="5843016"/>
+            <a:ext cx="10515600" cy="548640"/>
+          </a:xfrm>
+          <a:prstGeom prst="rect">
+            <a:avLst/>
+          </a:prstGeom>
+          <a:noFill/>
+        </p:spPr>
+        <p:txBody>
+          <a:bodyPr wrap="square" anchor="t" lIns="0" rIns="0" tIns="0" bIns="0">
+            <a:spAutoFit/>
+          </a:bodyPr>
+          <a:lstStyle/>
+          <a:p>
+            <a:pPr algn="l">
+              <a:spcBef>
+                <a:spcPts val="0"/>
+              </a:spcBef>
+              <a:spcAft>
+                <a:spcPts val="400"/>
+              </a:spcAft>
+            </a:pPr>
+            <a:r>
+              <a:rPr sz="1250" b="1">
+                <a:solidFill>
+                  <a:srgbClr val="0F172A"/>
+                </a:solidFill>
+                <a:latin typeface="Calibri"/>
+              </a:rPr>
+              <a:t>We report TRUE resolution + handoff quality — not just deflection </a:t>
+            </a:r>
+            <a:r>
+              <a:rPr sz="1250" b="0">
+                <a:solidFill>
+                  <a:srgbClr val="5B6673"/>
+                </a:solidFill>
+                <a:latin typeface="Calibri"/>
+              </a:rPr>
+              <a:t>(financial-services deflection is realistically 25–45%; one wrong answer is a compliance event, so the target error rate is &lt;1%).</a:t>
+            </a:r>
+          </a:p>
+        </p:txBody>
+      </p:sp>
+      <p:sp>
+        <p:nvSpPr>
+          <p:cNvPr id="35" name="TextBox 34"/>
+          <p:cNvSpPr txBox="1"/>
+          <p:nvPr/>
+        </p:nvSpPr>
+        <p:spPr>
+          <a:xfrm>
+            <a:off x="777240" y="6419088"/>
+            <a:ext cx="7315200" cy="274320"/>
+          </a:xfrm>
+          <a:prstGeom prst="rect">
+            <a:avLst/>
+          </a:prstGeom>
+          <a:noFill/>
+        </p:spPr>
+        <p:txBody>
+          <a:bodyPr wrap="square" anchor="t" lIns="0" rIns="0" tIns="0" bIns="0">
+            <a:spAutoFit/>
+          </a:bodyPr>
+          <a:lstStyle/>
+          <a:p>
+            <a:pPr algn="l">
+              <a:spcBef>
+                <a:spcPts val="0"/>
+              </a:spcBef>
+              <a:spcAft>
+                <a:spcPts val="400"/>
+              </a:spcAft>
+            </a:pPr>
+            <a:r>
               <a:rPr sz="900" b="0">
                 <a:solidFill>
                   <a:srgbClr val="5B6673"/>
@@ -14742,7 +14981,7 @@
       </p:sp>
       <p:sp>
         <p:nvSpPr>
-          <p:cNvPr id="32" name="TextBox 31"/>
+          <p:cNvPr id="36" name="TextBox 35"/>
           <p:cNvSpPr txBox="1"/>
           <p:nvPr/>
         </p:nvSpPr>

</xml_diff>

<commit_message>
Graph edge visibility + research-backed uniqueness claims on deck
- GraphView: darken column edges (visible on light bg), white-backed
  APPLIED_RULE labels, drop redundant NEXT labels
- Slide 8: research-verified novelty line (no prior example of rule citations
  in replies / counterfactual offers in servicing)
- Slide 10: verified industry claim — no deployed bank assistant performs
  autonomous account write-actions (Erica/Fargo/Capital One) + sources
- Fresh clean timeline graph capture for slide 6
</commit_message>
<xml_diff>
--- a/deck/CodeStreet2026_Servicing_Agent.pptx
+++ b/deck/CodeStreet2026_Servicing_Agent.pptx
@@ -3781,7 +3781,7 @@
         </p:nvSpPr>
         <p:spPr>
           <a:xfrm>
-            <a:off x="822960" y="2093976"/>
+            <a:off x="822960" y="2002536"/>
             <a:ext cx="109728" cy="109728"/>
           </a:xfrm>
           <a:prstGeom prst="roundRect">
@@ -3825,8 +3825,8 @@
         </p:nvSpPr>
         <p:spPr>
           <a:xfrm>
-            <a:off x="1115568" y="2011680"/>
-            <a:ext cx="10424160" cy="822960"/>
+            <a:off x="1115568" y="1920240"/>
+            <a:ext cx="10424160" cy="731520"/>
           </a:xfrm>
           <a:prstGeom prst="rect">
             <a:avLst/>
@@ -3848,7 +3848,7 @@
               </a:spcAft>
             </a:pPr>
             <a:r>
-              <a:rPr sz="1550" b="1">
+              <a:rPr sz="1400" b="1">
                 <a:solidFill>
                   <a:srgbClr val="0F172A"/>
                 </a:solidFill>
@@ -3857,7 +3857,7 @@
               <a:t>Amex’s 2026 direction is agentic commerce — agents that decide and act</a:t>
             </a:r>
             <a:r>
-              <a:rPr sz="1550" b="0">
+              <a:rPr sz="1400" b="0">
                 <a:solidFill>
                   <a:srgbClr val="5B6673"/>
                 </a:solidFill>
@@ -3876,7 +3876,7 @@
         </p:nvSpPr>
         <p:spPr>
           <a:xfrm>
-            <a:off x="822960" y="2916936"/>
+            <a:off x="822960" y="2734056"/>
             <a:ext cx="109728" cy="109728"/>
           </a:xfrm>
           <a:prstGeom prst="roundRect">
@@ -3920,8 +3920,8 @@
         </p:nvSpPr>
         <p:spPr>
           <a:xfrm>
-            <a:off x="1115568" y="2834640"/>
-            <a:ext cx="10424160" cy="822960"/>
+            <a:off x="1115568" y="2651760"/>
+            <a:ext cx="10424160" cy="731520"/>
           </a:xfrm>
           <a:prstGeom prst="rect">
             <a:avLst/>
@@ -3943,22 +3943,22 @@
               </a:spcAft>
             </a:pPr>
             <a:r>
-              <a:rPr sz="1550" b="1">
+              <a:rPr sz="1400" b="1">
                 <a:solidFill>
                   <a:srgbClr val="0F172A"/>
                 </a:solidFill>
                 <a:latin typeface="Calibri"/>
               </a:rPr>
-              <a:t>Only 21% of enterprises have mature agentic-AI governance, yet 74% expect to use AI agents by 2027</a:t>
-            </a:r>
-            <a:r>
-              <a:rPr sz="1550" b="0">
+              <a:t>No deployed bank assistant performs autonomous write-actions on accounts today</a:t>
+            </a:r>
+            <a:r>
+              <a:rPr sz="1400" b="0">
                 <a:solidFill>
                   <a:srgbClr val="5B6673"/>
                 </a:solidFill>
                 <a:latin typeface="Calibri"/>
               </a:rPr>
-              <a:t>  (Deloitte) — most are scaling agents without the guardrails.</a:t>
+              <a:t>  — Erica uses curated responses; Wells Fargo’s LLM only parses intent; Capital One kept its agent off bank accounts. We show how to do it safely.</a:t>
             </a:r>
           </a:p>
         </p:txBody>
@@ -3971,7 +3971,7 @@
         </p:nvSpPr>
         <p:spPr>
           <a:xfrm>
-            <a:off x="822960" y="3739896"/>
+            <a:off x="822960" y="3465576"/>
             <a:ext cx="109728" cy="109728"/>
           </a:xfrm>
           <a:prstGeom prst="roundRect">
@@ -4015,8 +4015,8 @@
         </p:nvSpPr>
         <p:spPr>
           <a:xfrm>
-            <a:off x="1115568" y="3657600"/>
-            <a:ext cx="10424160" cy="822960"/>
+            <a:off x="1115568" y="3383280"/>
+            <a:ext cx="10424160" cy="731520"/>
           </a:xfrm>
           <a:prstGeom prst="rect">
             <a:avLst/>
@@ -4038,22 +4038,22 @@
               </a:spcAft>
             </a:pPr>
             <a:r>
-              <a:rPr sz="1550" b="1">
+              <a:rPr sz="1400" b="1">
                 <a:solidFill>
                   <a:srgbClr val="0F172A"/>
                 </a:solidFill>
                 <a:latin typeface="Calibri"/>
               </a:rPr>
-              <a:t>Deloitte names the missing controls: audit trails of every agent action + human-approval boundaries</a:t>
-            </a:r>
-            <a:r>
-              <a:rPr sz="1550" b="0">
+              <a:t>Only 21% of enterprises have mature agentic-AI governance, yet 74% expect to use AI agents by 2027</a:t>
+            </a:r>
+            <a:r>
+              <a:rPr sz="1400" b="0">
                 <a:solidFill>
                   <a:srgbClr val="5B6673"/>
                 </a:solidFill>
                 <a:latin typeface="Calibri"/>
               </a:rPr>
-              <a:t>  — the exact two things we built.</a:t>
+              <a:t>  (Deloitte) — most are scaling agents without the guardrails.</a:t>
             </a:r>
           </a:p>
         </p:txBody>
@@ -4066,8 +4066,103 @@
         </p:nvSpPr>
         <p:spPr>
           <a:xfrm>
-            <a:off x="822960" y="4617720"/>
-            <a:ext cx="10515600" cy="914400"/>
+            <a:off x="822960" y="4197096"/>
+            <a:ext cx="109728" cy="109728"/>
+          </a:xfrm>
+          <a:prstGeom prst="roundRect">
+            <a:avLst/>
+          </a:prstGeom>
+          <a:solidFill>
+            <a:srgbClr val="016FD0"/>
+          </a:solidFill>
+          <a:ln>
+            <a:noFill/>
+          </a:ln>
+          <a:effectLst/>
+        </p:spPr>
+        <p:style>
+          <a:lnRef idx="1">
+            <a:schemeClr val="accent1"/>
+          </a:lnRef>
+          <a:fillRef idx="3">
+            <a:schemeClr val="accent1"/>
+          </a:fillRef>
+          <a:effectRef idx="2">
+            <a:schemeClr val="accent1"/>
+          </a:effectRef>
+          <a:fontRef idx="minor">
+            <a:schemeClr val="lt1"/>
+          </a:fontRef>
+        </p:style>
+        <p:txBody>
+          <a:bodyPr rtlCol="0" anchor="ctr"/>
+          <a:lstStyle/>
+          <a:p>
+            <a:pPr algn="ctr"/>
+          </a:p>
+        </p:txBody>
+      </p:sp>
+      <p:sp>
+        <p:nvSpPr>
+          <p:cNvPr id="13" name="TextBox 12"/>
+          <p:cNvSpPr txBox="1"/>
+          <p:nvPr/>
+        </p:nvSpPr>
+        <p:spPr>
+          <a:xfrm>
+            <a:off x="1115568" y="4114800"/>
+            <a:ext cx="10424160" cy="731520"/>
+          </a:xfrm>
+          <a:prstGeom prst="rect">
+            <a:avLst/>
+          </a:prstGeom>
+          <a:noFill/>
+        </p:spPr>
+        <p:txBody>
+          <a:bodyPr wrap="square" anchor="t" lIns="0" rIns="0" tIns="0" bIns="0">
+            <a:spAutoFit/>
+          </a:bodyPr>
+          <a:lstStyle/>
+          <a:p>
+            <a:pPr algn="l">
+              <a:spcBef>
+                <a:spcPts val="0"/>
+              </a:spcBef>
+              <a:spcAft>
+                <a:spcPts val="400"/>
+              </a:spcAft>
+            </a:pPr>
+            <a:r>
+              <a:rPr sz="1400" b="1">
+                <a:solidFill>
+                  <a:srgbClr val="0F172A"/>
+                </a:solidFill>
+                <a:latin typeface="Calibri"/>
+              </a:rPr>
+              <a:t>Deloitte names the missing controls: audit trails of every agent action + human-approval boundaries</a:t>
+            </a:r>
+            <a:r>
+              <a:rPr sz="1400" b="0">
+                <a:solidFill>
+                  <a:srgbClr val="5B6673"/>
+                </a:solidFill>
+                <a:latin typeface="Calibri"/>
+              </a:rPr>
+              <a:t>  — the exact two things we built.</a:t>
+            </a:r>
+          </a:p>
+        </p:txBody>
+      </p:sp>
+      <p:sp>
+        <p:nvSpPr>
+          <p:cNvPr id="14" name="Rounded Rectangle 13"/>
+          <p:cNvSpPr/>
+          <p:nvPr/>
+        </p:nvSpPr>
+        <p:spPr>
+          <a:xfrm>
+            <a:off x="822960" y="4892040"/>
+            <a:ext cx="10515600" cy="841248"/>
           </a:xfrm>
           <a:prstGeom prst="roundRect">
             <a:avLst/>
@@ -4106,14 +4201,14 @@
       </p:sp>
       <p:sp>
         <p:nvSpPr>
-          <p:cNvPr id="13" name="TextBox 12"/>
+          <p:cNvPr id="15" name="TextBox 14"/>
           <p:cNvSpPr txBox="1"/>
           <p:nvPr/>
         </p:nvSpPr>
         <p:spPr>
           <a:xfrm>
-            <a:off x="1097280" y="4754880"/>
-            <a:ext cx="10058400" cy="731520"/>
+            <a:off x="1097280" y="5029200"/>
+            <a:ext cx="10058400" cy="640080"/>
           </a:xfrm>
           <a:prstGeom prst="rect">
             <a:avLst/>
@@ -4135,7 +4230,7 @@
               </a:spcAft>
             </a:pPr>
             <a:r>
-              <a:rPr sz="1500" b="1">
+              <a:rPr sz="1450" b="1">
                 <a:solidFill>
                   <a:srgbClr val="0F172A"/>
                 </a:solidFill>
@@ -4144,7 +4239,7 @@
               <a:t>“With every use case, we’ve ensured there is human oversight.”</a:t>
             </a:r>
             <a:r>
-              <a:rPr sz="1250" b="0">
+              <a:rPr sz="1200" b="0">
                 <a:solidFill>
                   <a:srgbClr val="5B6673"/>
                 </a:solidFill>
@@ -4157,13 +4252,13 @@
       </p:sp>
       <p:sp>
         <p:nvSpPr>
-          <p:cNvPr id="14" name="TextBox 13"/>
+          <p:cNvPr id="16" name="TextBox 15"/>
           <p:cNvSpPr txBox="1"/>
           <p:nvPr/>
         </p:nvSpPr>
         <p:spPr>
           <a:xfrm>
-            <a:off x="822960" y="5760720"/>
+            <a:off x="822960" y="5897880"/>
             <a:ext cx="10515600" cy="457200"/>
           </a:xfrm>
           <a:prstGeom prst="rect">
@@ -4201,14 +4296,14 @@
                 </a:solidFill>
                 <a:latin typeface="Calibri"/>
               </a:rPr>
-              <a:t>Deloitte, “Agentic AI is scaling faster than guardrails” (2025)   ·   Forbes / Peter High, “Ravi Radhakrishnan on Driving AI Innovation at American Express” (May 2025)</a:t>
-            </a:r>
-          </a:p>
-        </p:txBody>
-      </p:sp>
-      <p:sp>
-        <p:nvSpPr>
-          <p:cNvPr id="15" name="TextBox 14"/>
+              <a:t>Deloitte, “Agentic AI is scaling faster than guardrails” (2025) · Forbes/Peter High (May 2025) · American Banker (Erica) · VentureBeat (Fargo) · The Financial Brand (Capital One)</a:t>
+            </a:r>
+          </a:p>
+        </p:txBody>
+      </p:sp>
+      <p:sp>
+        <p:nvSpPr>
+          <p:cNvPr id="17" name="TextBox 16"/>
           <p:cNvSpPr txBox="1"/>
           <p:nvPr/>
         </p:nvSpPr>
@@ -4250,7 +4345,7 @@
       </p:sp>
       <p:sp>
         <p:nvSpPr>
-          <p:cNvPr id="16" name="TextBox 15"/>
+          <p:cNvPr id="18" name="TextBox 17"/>
           <p:cNvSpPr txBox="1"/>
           <p:nvPr/>
         </p:nvSpPr>
@@ -13430,8 +13525,8 @@
         </p:nvSpPr>
         <p:spPr>
           <a:xfrm>
-            <a:off x="777240" y="6419088"/>
-            <a:ext cx="7315200" cy="274320"/>
+            <a:off x="822960" y="6035040"/>
+            <a:ext cx="10515600" cy="320040"/>
           </a:xfrm>
           <a:prstGeom prst="rect">
             <a:avLst/>
@@ -13444,6 +13539,48 @@
           </a:bodyPr>
           <a:lstStyle/>
           <a:p>
+            <a:pPr algn="ctr">
+              <a:spcBef>
+                <a:spcPts val="0"/>
+              </a:spcBef>
+              <a:spcAft>
+                <a:spcPts val="400"/>
+              </a:spcAft>
+            </a:pPr>
+            <a:r>
+              <a:rPr sz="1100" b="1">
+                <a:solidFill>
+                  <a:srgbClr val="002663"/>
+                </a:solidFill>
+                <a:latin typeface="Calibri"/>
+              </a:rPr>
+              <a:t>In our research we found no prior example — hackathon or production — of rule citations in customer replies, or counterfactual offers in a servicing conversation.</a:t>
+            </a:r>
+          </a:p>
+        </p:txBody>
+      </p:sp>
+      <p:sp>
+        <p:nvSpPr>
+          <p:cNvPr id="23" name="TextBox 22"/>
+          <p:cNvSpPr txBox="1"/>
+          <p:nvPr/>
+        </p:nvSpPr>
+        <p:spPr>
+          <a:xfrm>
+            <a:off x="777240" y="6419088"/>
+            <a:ext cx="7315200" cy="274320"/>
+          </a:xfrm>
+          <a:prstGeom prst="rect">
+            <a:avLst/>
+          </a:prstGeom>
+          <a:noFill/>
+        </p:spPr>
+        <p:txBody>
+          <a:bodyPr wrap="square" anchor="t" lIns="0" rIns="0" tIns="0" bIns="0">
+            <a:spAutoFit/>
+          </a:bodyPr>
+          <a:lstStyle/>
+          <a:p>
             <a:pPr algn="l">
               <a:spcBef>
                 <a:spcPts val="0"/>
@@ -13466,7 +13603,7 @@
       </p:sp>
       <p:sp>
         <p:nvSpPr>
-          <p:cNvPr id="23" name="TextBox 22"/>
+          <p:cNvPr id="24" name="TextBox 23"/>
           <p:cNvSpPr txBox="1"/>
           <p:nvPr/>
         </p:nvSpPr>

</xml_diff>

<commit_message>
Slide 6: tighter graph crop so the timeline fills the panel
</commit_message>
<xml_diff>
--- a/deck/CodeStreet2026_Servicing_Agent.pptx
+++ b/deck/CodeStreet2026_Servicing_Agent.pptx
@@ -11503,8 +11503,8 @@
         </p:blipFill>
         <p:spPr>
           <a:xfrm>
-            <a:off x="8138160" y="2240280"/>
-            <a:ext cx="2597307" cy="3611880"/>
+            <a:off x="7754112" y="2231136"/>
+            <a:ext cx="3520440" cy="3385038"/>
           </a:xfrm>
           <a:prstGeom prst="rect">
             <a:avLst/>
@@ -11548,7 +11548,7 @@
                 </a:solidFill>
                 <a:latin typeface="Calibri"/>
               </a:rPr>
-              <a:t>Live Neo4j graph — policy rules are nodes (APPLIED_RULE)</a:t>
+              <a:t>Live Neo4j graph — the sequence spine, rules linked APPLIED_RULE</a:t>
             </a:r>
           </a:p>
         </p:txBody>

</xml_diff>

<commit_message>
Visible decision pipeline in the UI + deck/README updates
- /chat returns the turn's audit entries as a trace; PipelineStrip renders
  them under every reply: classified -> verified -> policy rule -> executed
- Slide 4: fresh capture showing the pipeline; annotations lead with it
- Slide 8: name the bounded propose->verify->revise agentic loop explicitly
- README: demo step mentions the pipeline strip
</commit_message>
<xml_diff>
--- a/deck/CodeStreet2026_Servicing_Agent.pptx
+++ b/deck/CodeStreet2026_Servicing_Agent.pptx
@@ -9107,7 +9107,112 @@
         </p:nvSpPr>
         <p:spPr>
           <a:xfrm>
-            <a:off x="8001000" y="2551176"/>
+            <a:off x="8001000" y="2432304"/>
+            <a:ext cx="109728" cy="109728"/>
+          </a:xfrm>
+          <a:prstGeom prst="roundRect">
+            <a:avLst/>
+          </a:prstGeom>
+          <a:solidFill>
+            <a:srgbClr val="002663"/>
+          </a:solidFill>
+          <a:ln>
+            <a:noFill/>
+          </a:ln>
+          <a:effectLst/>
+        </p:spPr>
+        <p:style>
+          <a:lnRef idx="1">
+            <a:schemeClr val="accent1"/>
+          </a:lnRef>
+          <a:fillRef idx="3">
+            <a:schemeClr val="accent1"/>
+          </a:fillRef>
+          <a:effectRef idx="2">
+            <a:schemeClr val="accent1"/>
+          </a:effectRef>
+          <a:fontRef idx="minor">
+            <a:schemeClr val="lt1"/>
+          </a:fontRef>
+        </p:style>
+        <p:txBody>
+          <a:bodyPr rtlCol="0" anchor="ctr"/>
+          <a:lstStyle/>
+          <a:p>
+            <a:pPr algn="ctr"/>
+          </a:p>
+        </p:txBody>
+      </p:sp>
+      <p:sp>
+        <p:nvSpPr>
+          <p:cNvPr id="9" name="TextBox 8"/>
+          <p:cNvSpPr txBox="1"/>
+          <p:nvPr/>
+        </p:nvSpPr>
+        <p:spPr>
+          <a:xfrm>
+            <a:off x="8275320" y="2395728"/>
+            <a:ext cx="3063240" cy="640080"/>
+          </a:xfrm>
+          <a:prstGeom prst="rect">
+            <a:avLst/>
+          </a:prstGeom>
+          <a:noFill/>
+        </p:spPr>
+        <p:txBody>
+          <a:bodyPr wrap="square" anchor="t" lIns="0" rIns="0" tIns="0" bIns="0">
+            <a:spAutoFit/>
+          </a:bodyPr>
+          <a:lstStyle/>
+          <a:p>
+            <a:pPr algn="l">
+              <a:spcBef>
+                <a:spcPts val="0"/>
+              </a:spcBef>
+              <a:spcAft>
+                <a:spcPts val="400"/>
+              </a:spcAft>
+            </a:pPr>
+            <a:r>
+              <a:rPr sz="1150" b="1">
+                <a:solidFill>
+                  <a:srgbClr val="0F172A"/>
+                </a:solidFill>
+                <a:latin typeface="Calibri"/>
+              </a:rPr>
+              <a:t>Visible decision pipeline per reply</a:t>
+            </a:r>
+          </a:p>
+          <a:p>
+            <a:pPr algn="l">
+              <a:spcBef>
+                <a:spcPts val="0"/>
+              </a:spcBef>
+              <a:spcAft>
+                <a:spcPts val="400"/>
+              </a:spcAft>
+            </a:pPr>
+            <a:r>
+              <a:rPr sz="1000" b="0">
+                <a:solidFill>
+                  <a:srgbClr val="5B6673"/>
+                </a:solidFill>
+                <a:latin typeface="Calibri"/>
+              </a:rPr>
+              <a:t>classified → verified → rule → executed</a:t>
+            </a:r>
+          </a:p>
+        </p:txBody>
+      </p:sp>
+      <p:sp>
+        <p:nvSpPr>
+          <p:cNvPr id="10" name="Rounded Rectangle 9"/>
+          <p:cNvSpPr/>
+          <p:nvPr/>
+        </p:nvSpPr>
+        <p:spPr>
+          <a:xfrm>
+            <a:off x="8001000" y="3145536"/>
             <a:ext cx="109728" cy="109728"/>
           </a:xfrm>
           <a:prstGeom prst="roundRect">
@@ -9145,13 +9250,13 @@
       </p:sp>
       <p:sp>
         <p:nvSpPr>
-          <p:cNvPr id="9" name="TextBox 8"/>
+          <p:cNvPr id="11" name="TextBox 10"/>
           <p:cNvSpPr txBox="1"/>
           <p:nvPr/>
         </p:nvSpPr>
         <p:spPr>
           <a:xfrm>
-            <a:off x="8275320" y="2514600"/>
+            <a:off x="8275320" y="3108960"/>
             <a:ext cx="3063240" cy="640080"/>
           </a:xfrm>
           <a:prstGeom prst="rect">
@@ -9174,7 +9279,7 @@
               </a:spcAft>
             </a:pPr>
             <a:r>
-              <a:rPr sz="1200" b="1">
+              <a:rPr sz="1150" b="1">
                 <a:solidFill>
                   <a:srgbClr val="0F172A"/>
                 </a:solidFill>
@@ -9193,7 +9298,7 @@
               </a:spcAft>
             </a:pPr>
             <a:r>
-              <a:rPr sz="1050" b="0">
+              <a:rPr sz="1000" b="0">
                 <a:solidFill>
                   <a:srgbClr val="5B6673"/>
                 </a:solidFill>
@@ -9206,13 +9311,13 @@
       </p:sp>
       <p:sp>
         <p:nvSpPr>
-          <p:cNvPr id="10" name="Rounded Rectangle 9"/>
+          <p:cNvPr id="12" name="Rounded Rectangle 11"/>
           <p:cNvSpPr/>
           <p:nvPr/>
         </p:nvSpPr>
         <p:spPr>
           <a:xfrm>
-            <a:off x="8001000" y="3392424"/>
+            <a:off x="8001000" y="3858768"/>
             <a:ext cx="109728" cy="109728"/>
           </a:xfrm>
           <a:prstGeom prst="roundRect">
@@ -9250,13 +9355,13 @@
       </p:sp>
       <p:sp>
         <p:nvSpPr>
-          <p:cNvPr id="11" name="TextBox 10"/>
+          <p:cNvPr id="13" name="TextBox 12"/>
           <p:cNvSpPr txBox="1"/>
           <p:nvPr/>
         </p:nvSpPr>
         <p:spPr>
           <a:xfrm>
-            <a:off x="8275320" y="3355848"/>
+            <a:off x="8275320" y="3822192"/>
             <a:ext cx="3063240" cy="640080"/>
           </a:xfrm>
           <a:prstGeom prst="rect">
@@ -9279,7 +9384,7 @@
               </a:spcAft>
             </a:pPr>
             <a:r>
-              <a:rPr sz="1200" b="1">
+              <a:rPr sz="1150" b="1">
                 <a:solidFill>
                   <a:srgbClr val="0F172A"/>
                 </a:solidFill>
@@ -9298,7 +9403,7 @@
               </a:spcAft>
             </a:pPr>
             <a:r>
-              <a:rPr sz="1050" b="0">
+              <a:rPr sz="1000" b="0">
                 <a:solidFill>
                   <a:srgbClr val="5B6673"/>
                 </a:solidFill>
@@ -9311,13 +9416,13 @@
       </p:sp>
       <p:sp>
         <p:nvSpPr>
-          <p:cNvPr id="12" name="Rounded Rectangle 11"/>
+          <p:cNvPr id="14" name="Rounded Rectangle 13"/>
           <p:cNvSpPr/>
           <p:nvPr/>
         </p:nvSpPr>
         <p:spPr>
           <a:xfrm>
-            <a:off x="8001000" y="4233672"/>
+            <a:off x="8001000" y="4572000"/>
             <a:ext cx="109728" cy="109728"/>
           </a:xfrm>
           <a:prstGeom prst="roundRect">
@@ -9355,13 +9460,13 @@
       </p:sp>
       <p:sp>
         <p:nvSpPr>
-          <p:cNvPr id="13" name="TextBox 12"/>
+          <p:cNvPr id="15" name="TextBox 14"/>
           <p:cNvSpPr txBox="1"/>
           <p:nvPr/>
         </p:nvSpPr>
         <p:spPr>
           <a:xfrm>
-            <a:off x="8275320" y="4197096"/>
+            <a:off x="8275320" y="4535424"/>
             <a:ext cx="3063240" cy="640080"/>
           </a:xfrm>
           <a:prstGeom prst="rect">
@@ -9384,7 +9489,7 @@
               </a:spcAft>
             </a:pPr>
             <a:r>
-              <a:rPr sz="1200" b="1">
+              <a:rPr sz="1150" b="1">
                 <a:solidFill>
                   <a:srgbClr val="0F172A"/>
                 </a:solidFill>
@@ -9403,7 +9508,7 @@
               </a:spcAft>
             </a:pPr>
             <a:r>
-              <a:rPr sz="1050" b="0">
+              <a:rPr sz="1000" b="0">
                 <a:solidFill>
                   <a:srgbClr val="5B6673"/>
                 </a:solidFill>
@@ -9416,13 +9521,13 @@
       </p:sp>
       <p:sp>
         <p:nvSpPr>
-          <p:cNvPr id="14" name="Rounded Rectangle 13"/>
+          <p:cNvPr id="16" name="Rounded Rectangle 15"/>
           <p:cNvSpPr/>
           <p:nvPr/>
         </p:nvSpPr>
         <p:spPr>
           <a:xfrm>
-            <a:off x="8001000" y="5074920"/>
+            <a:off x="8001000" y="5285232"/>
             <a:ext cx="109728" cy="109728"/>
           </a:xfrm>
           <a:prstGeom prst="roundRect">
@@ -9460,13 +9565,13 @@
       </p:sp>
       <p:sp>
         <p:nvSpPr>
-          <p:cNvPr id="15" name="TextBox 14"/>
+          <p:cNvPr id="17" name="TextBox 16"/>
           <p:cNvSpPr txBox="1"/>
           <p:nvPr/>
         </p:nvSpPr>
         <p:spPr>
           <a:xfrm>
-            <a:off x="8275320" y="5038344"/>
+            <a:off x="8275320" y="5248656"/>
             <a:ext cx="3063240" cy="640080"/>
           </a:xfrm>
           <a:prstGeom prst="rect">
@@ -9489,7 +9594,7 @@
               </a:spcAft>
             </a:pPr>
             <a:r>
-              <a:rPr sz="1200" b="1">
+              <a:rPr sz="1150" b="1">
                 <a:solidFill>
                   <a:srgbClr val="0F172A"/>
                 </a:solidFill>
@@ -9508,7 +9613,7 @@
               </a:spcAft>
             </a:pPr>
             <a:r>
-              <a:rPr sz="1050" b="0">
+              <a:rPr sz="1000" b="0">
                 <a:solidFill>
                   <a:srgbClr val="5B6673"/>
                 </a:solidFill>
@@ -9521,13 +9626,13 @@
       </p:sp>
       <p:sp>
         <p:nvSpPr>
-          <p:cNvPr id="16" name="TextBox 15"/>
+          <p:cNvPr id="18" name="TextBox 17"/>
           <p:cNvSpPr txBox="1"/>
           <p:nvPr/>
         </p:nvSpPr>
         <p:spPr>
           <a:xfrm>
-            <a:off x="8275320" y="5943600"/>
+            <a:off x="8275320" y="6035040"/>
             <a:ext cx="3108960" cy="274320"/>
           </a:xfrm>
           <a:prstGeom prst="rect">
@@ -9563,7 +9668,7 @@
       </p:sp>
       <p:sp>
         <p:nvSpPr>
-          <p:cNvPr id="17" name="TextBox 16"/>
+          <p:cNvPr id="19" name="TextBox 18"/>
           <p:cNvSpPr txBox="1"/>
           <p:nvPr/>
         </p:nvSpPr>
@@ -9605,7 +9710,7 @@
       </p:sp>
       <p:sp>
         <p:nvSpPr>
-          <p:cNvPr id="18" name="TextBox 17"/>
+          <p:cNvPr id="20" name="TextBox 19"/>
           <p:cNvSpPr txBox="1"/>
           <p:nvPr/>
         </p:nvSpPr>
@@ -13122,7 +13227,7 @@
                 </a:solidFill>
                 <a:latin typeface="Calibri"/>
               </a:rPr>
-              <a:t>Self-verifying agent</a:t>
+              <a:t>Self-verifying agentic loop</a:t>
             </a:r>
           </a:p>
         </p:txBody>
@@ -13164,7 +13269,7 @@
                 </a:solidFill>
                 <a:latin typeface="Calibri"/>
               </a:rPr>
-              <a:t>A second reviewer LLM must agree the interpretation matches the request before acting — a bounded propose → verify → revise loop; escalates if the two agents can't agree. Risk-based, so it's spent where it matters.</a:t>
+              <a:t>A second reviewer LLM must agree the interpretation matches the request before acting — a bounded propose → verify → revise loop that escalates if the agents can't agree. Risk-based, so it's spent where it matters.</a:t>
             </a:r>
           </a:p>
         </p:txBody>

</xml_diff>